<commit_message>
Atualiza apresentacao do Projeto 2 (ultima versao)
Co-Authored-By: Claude Opus 5.5 <noreply@anthropic.com>
</commit_message>
<xml_diff>
--- a/Apresentacao_Projeto2_Grupo10.pptx
+++ b/Apresentacao_Projeto2_Grupo10.pptx
@@ -10,8 +10,8 @@
   <p:sldIdLst>
     <p:sldId id="256" r:id="rId2"/>
     <p:sldId id="257" r:id="rId3"/>
-    <p:sldId id="258" r:id="rId4"/>
-    <p:sldId id="259" r:id="rId5"/>
+    <p:sldId id="259" r:id="rId4"/>
+    <p:sldId id="258" r:id="rId5"/>
     <p:sldId id="260" r:id="rId6"/>
     <p:sldId id="261" r:id="rId7"/>
     <p:sldId id="262" r:id="rId8"/>
@@ -1000,7 +1000,7 @@
               <a:lstStyle/>
               <a:p>
                 <a:r>
-                  <a:rPr sz="1300" b="0">
+                  <a:rPr lang="pt-BR" sz="1300" b="0">
                     <a:solidFill>
                       <a:srgbClr val="5B6170"/>
                     </a:solidFill>
@@ -1068,7 +1068,7 @@
               <a:lstStyle/>
               <a:p>
                 <a:r>
-                  <a:rPr sz="1300" b="0">
+                  <a:rPr lang="pt-BR" sz="1300" b="0">
                     <a:solidFill>
                       <a:srgbClr val="5B6170"/>
                     </a:solidFill>
@@ -1633,7 +1633,7 @@
               <a:lstStyle/>
               <a:p>
                 <a:r>
-                  <a:rPr sz="1300" b="0">
+                  <a:rPr lang="pt-BR" sz="1300" b="0">
                     <a:solidFill>
                       <a:srgbClr val="5B6170"/>
                     </a:solidFill>
@@ -1701,7 +1701,7 @@
               <a:lstStyle/>
               <a:p>
                 <a:r>
-                  <a:rPr sz="1300" b="0">
+                  <a:rPr lang="pt-BR" sz="1300" b="0">
                     <a:solidFill>
                       <a:srgbClr val="5B6170"/>
                     </a:solidFill>
@@ -2080,7 +2080,7 @@
           <a:lstStyle/>
           <a:p>
             <a:r>
-              <a:t>Dois estoques: a energia interna da panela e a da água. Q1 é o calor da indução, Q2 vai da panela para a água, Q3 e Q4 são as perdas para o ar pelas paredes e pelo topo.</a:t>
+              <a:t>Pela 1ª Lei, a variação de temperatura de cada estoque é o calor que entra menos o que sai, dividido pela capacidade térmica. Os fluxos são escritos com resistências térmicas, como na latinha da Aula 15.</a:t>
             </a:r>
           </a:p>
         </p:txBody>
@@ -2150,7 +2150,7 @@
           <a:lstStyle/>
           <a:p>
             <a:r>
-              <a:t>Pela 1ª Lei, a variação de temperatura de cada estoque é o calor que entra menos o que sai, dividido pela capacidade térmica. Os fluxos são escritos com resistências térmicas, como na latinha da Aula 15.</a:t>
+              <a:t>Dois estoques: a energia interna da panela e a da água. Q1 é o calor da indução, Q2 vai da panela para a água, Q3 e Q4 são as perdas para o ar pelas paredes e pelo topo.</a:t>
             </a:r>
           </a:p>
         </p:txBody>
@@ -2430,7 +2430,204 @@
           <a:lstStyle/>
           <a:p>
             <a:r>
-              <a:t>Conclusões: com a panela sem tampa, existe uma potência mínima para ferver; acima de uns 2000 W, aumentar a potência quase não ajuda. O modelo reproduz o experimento com 2,8 % de erro médio. Limitação: evaporação e radiação estão embutidas no h do ar.</a:t>
+              <a:rPr dirty="0" err="1"/>
+              <a:t>Conclusões</a:t>
+            </a:r>
+            <a:r>
+              <a:rPr dirty="0"/>
+              <a:t>: com a panela </a:t>
+            </a:r>
+            <a:r>
+              <a:rPr dirty="0" err="1"/>
+              <a:t>sem</a:t>
+            </a:r>
+            <a:r>
+              <a:rPr dirty="0"/>
+              <a:t> </a:t>
+            </a:r>
+            <a:r>
+              <a:rPr dirty="0" err="1"/>
+              <a:t>tampa</a:t>
+            </a:r>
+            <a:r>
+              <a:rPr dirty="0"/>
+              <a:t>, </a:t>
+            </a:r>
+            <a:r>
+              <a:rPr dirty="0" err="1"/>
+              <a:t>existe</a:t>
+            </a:r>
+            <a:r>
+              <a:rPr dirty="0"/>
+              <a:t> </a:t>
+            </a:r>
+            <a:r>
+              <a:rPr dirty="0" err="1"/>
+              <a:t>uma</a:t>
+            </a:r>
+            <a:r>
+              <a:rPr dirty="0"/>
+              <a:t> </a:t>
+            </a:r>
+            <a:r>
+              <a:rPr dirty="0" err="1"/>
+              <a:t>potência</a:t>
+            </a:r>
+            <a:r>
+              <a:rPr dirty="0"/>
+              <a:t> </a:t>
+            </a:r>
+            <a:r>
+              <a:rPr dirty="0" err="1"/>
+              <a:t>mínima</a:t>
+            </a:r>
+            <a:r>
+              <a:rPr dirty="0"/>
+              <a:t> para </a:t>
+            </a:r>
+            <a:r>
+              <a:rPr dirty="0" err="1"/>
+              <a:t>ferver</a:t>
+            </a:r>
+            <a:r>
+              <a:rPr dirty="0"/>
+              <a:t>; </a:t>
+            </a:r>
+            <a:r>
+              <a:rPr dirty="0" err="1"/>
+              <a:t>acima</a:t>
+            </a:r>
+            <a:r>
+              <a:rPr dirty="0"/>
+              <a:t> de </a:t>
+            </a:r>
+            <a:r>
+              <a:rPr dirty="0" err="1"/>
+              <a:t>uns</a:t>
+            </a:r>
+            <a:r>
+              <a:rPr dirty="0"/>
+              <a:t> 2000 W, </a:t>
+            </a:r>
+            <a:r>
+              <a:rPr dirty="0" err="1"/>
+              <a:t>aumentar</a:t>
+            </a:r>
+            <a:r>
+              <a:rPr dirty="0"/>
+              <a:t> a </a:t>
+            </a:r>
+            <a:r>
+              <a:rPr dirty="0" err="1"/>
+              <a:t>potência</a:t>
+            </a:r>
+            <a:r>
+              <a:rPr dirty="0"/>
+              <a:t> </a:t>
+            </a:r>
+            <a:r>
+              <a:rPr dirty="0" err="1"/>
+              <a:t>quase</a:t>
+            </a:r>
+            <a:r>
+              <a:rPr dirty="0"/>
+              <a:t> </a:t>
+            </a:r>
+            <a:r>
+              <a:rPr dirty="0" err="1"/>
+              <a:t>não</a:t>
+            </a:r>
+            <a:r>
+              <a:rPr dirty="0"/>
+              <a:t> </a:t>
+            </a:r>
+            <a:r>
+              <a:rPr dirty="0" err="1"/>
+              <a:t>ajuda</a:t>
+            </a:r>
+            <a:r>
+              <a:rPr dirty="0"/>
+              <a:t>. O </a:t>
+            </a:r>
+            <a:r>
+              <a:rPr dirty="0" err="1"/>
+              <a:t>modelo</a:t>
+            </a:r>
+            <a:r>
+              <a:rPr dirty="0"/>
+              <a:t> </a:t>
+            </a:r>
+            <a:r>
+              <a:rPr dirty="0" err="1"/>
+              <a:t>reproduz</a:t>
+            </a:r>
+            <a:r>
+              <a:rPr dirty="0"/>
+              <a:t> o </a:t>
+            </a:r>
+            <a:r>
+              <a:rPr dirty="0" err="1"/>
+              <a:t>experimento</a:t>
+            </a:r>
+            <a:r>
+              <a:rPr dirty="0"/>
+              <a:t> com 2,8 % de </a:t>
+            </a:r>
+            <a:r>
+              <a:rPr dirty="0" err="1"/>
+              <a:t>erro</a:t>
+            </a:r>
+            <a:r>
+              <a:rPr dirty="0"/>
+              <a:t> </a:t>
+            </a:r>
+            <a:r>
+              <a:rPr dirty="0" err="1"/>
+              <a:t>médio</a:t>
+            </a:r>
+            <a:r>
+              <a:rPr dirty="0"/>
+              <a:t>. </a:t>
+            </a:r>
+            <a:r>
+              <a:rPr dirty="0" err="1"/>
+              <a:t>Limitação</a:t>
+            </a:r>
+            <a:r>
+              <a:rPr dirty="0"/>
+              <a:t>: </a:t>
+            </a:r>
+            <a:r>
+              <a:rPr dirty="0" err="1"/>
+              <a:t>evaporação</a:t>
+            </a:r>
+            <a:r>
+              <a:rPr dirty="0"/>
+              <a:t> e </a:t>
+            </a:r>
+            <a:r>
+              <a:rPr dirty="0" err="1"/>
+              <a:t>radiação</a:t>
+            </a:r>
+            <a:r>
+              <a:rPr dirty="0"/>
+              <a:t> </a:t>
+            </a:r>
+            <a:r>
+              <a:rPr dirty="0" err="1"/>
+              <a:t>estão</a:t>
+            </a:r>
+            <a:r>
+              <a:rPr dirty="0"/>
+              <a:t> </a:t>
+            </a:r>
+            <a:r>
+              <a:rPr dirty="0" err="1"/>
+              <a:t>embutidas</a:t>
+            </a:r>
+            <a:r>
+              <a:rPr dirty="0"/>
+              <a:t> no h do ar.</a:t>
             </a:r>
           </a:p>
         </p:txBody>
@@ -2634,7 +2831,7 @@
           <a:p>
             <a:fld id="{5BCAD085-E8A6-8845-BD4E-CB4CCA059FC4}" type="datetimeFigureOut">
               <a:rPr lang="en-US" smtClean="0"/>
-              <a:t>10/20/2026</a:t>
+              <a:t>10/26/2026</a:t>
             </a:fld>
             <a:endParaRPr lang="en-US"/>
           </a:p>
@@ -2802,7 +2999,7 @@
           <a:p>
             <a:fld id="{5BCAD085-E8A6-8845-BD4E-CB4CCA059FC4}" type="datetimeFigureOut">
               <a:rPr lang="en-US" smtClean="0"/>
-              <a:t>10/20/2026</a:t>
+              <a:t>10/26/2026</a:t>
             </a:fld>
             <a:endParaRPr lang="en-US"/>
           </a:p>
@@ -2980,7 +3177,7 @@
           <a:p>
             <a:fld id="{5BCAD085-E8A6-8845-BD4E-CB4CCA059FC4}" type="datetimeFigureOut">
               <a:rPr lang="en-US" smtClean="0"/>
-              <a:t>10/20/2026</a:t>
+              <a:t>10/26/2026</a:t>
             </a:fld>
             <a:endParaRPr lang="en-US"/>
           </a:p>
@@ -3148,7 +3345,7 @@
           <a:p>
             <a:fld id="{5BCAD085-E8A6-8845-BD4E-CB4CCA059FC4}" type="datetimeFigureOut">
               <a:rPr lang="en-US" smtClean="0"/>
-              <a:t>10/20/2026</a:t>
+              <a:t>10/26/2026</a:t>
             </a:fld>
             <a:endParaRPr lang="en-US"/>
           </a:p>
@@ -3393,7 +3590,7 @@
           <a:p>
             <a:fld id="{5BCAD085-E8A6-8845-BD4E-CB4CCA059FC4}" type="datetimeFigureOut">
               <a:rPr lang="en-US" smtClean="0"/>
-              <a:t>10/20/2026</a:t>
+              <a:t>10/26/2026</a:t>
             </a:fld>
             <a:endParaRPr lang="en-US"/>
           </a:p>
@@ -3678,7 +3875,7 @@
           <a:p>
             <a:fld id="{5BCAD085-E8A6-8845-BD4E-CB4CCA059FC4}" type="datetimeFigureOut">
               <a:rPr lang="en-US" smtClean="0"/>
-              <a:t>10/20/2026</a:t>
+              <a:t>10/26/2026</a:t>
             </a:fld>
             <a:endParaRPr lang="en-US"/>
           </a:p>
@@ -4097,7 +4294,7 @@
           <a:p>
             <a:fld id="{5BCAD085-E8A6-8845-BD4E-CB4CCA059FC4}" type="datetimeFigureOut">
               <a:rPr lang="en-US" smtClean="0"/>
-              <a:t>10/20/2026</a:t>
+              <a:t>10/26/2026</a:t>
             </a:fld>
             <a:endParaRPr lang="en-US"/>
           </a:p>
@@ -4214,7 +4411,7 @@
           <a:p>
             <a:fld id="{5BCAD085-E8A6-8845-BD4E-CB4CCA059FC4}" type="datetimeFigureOut">
               <a:rPr lang="en-US" smtClean="0"/>
-              <a:t>10/20/2026</a:t>
+              <a:t>10/26/2026</a:t>
             </a:fld>
             <a:endParaRPr lang="en-US"/>
           </a:p>
@@ -4309,7 +4506,7 @@
           <a:p>
             <a:fld id="{5BCAD085-E8A6-8845-BD4E-CB4CCA059FC4}" type="datetimeFigureOut">
               <a:rPr lang="en-US" smtClean="0"/>
-              <a:t>10/20/2026</a:t>
+              <a:t>10/26/2026</a:t>
             </a:fld>
             <a:endParaRPr lang="en-US"/>
           </a:p>
@@ -4584,7 +4781,7 @@
           <a:p>
             <a:fld id="{5BCAD085-E8A6-8845-BD4E-CB4CCA059FC4}" type="datetimeFigureOut">
               <a:rPr lang="en-US" smtClean="0"/>
-              <a:t>10/20/2026</a:t>
+              <a:t>10/26/2026</a:t>
             </a:fld>
             <a:endParaRPr lang="en-US"/>
           </a:p>
@@ -4836,7 +5033,7 @@
           <a:p>
             <a:fld id="{5BCAD085-E8A6-8845-BD4E-CB4CCA059FC4}" type="datetimeFigureOut">
               <a:rPr lang="en-US" smtClean="0"/>
-              <a:t>10/20/2026</a:t>
+              <a:t>10/26/2026</a:t>
             </a:fld>
             <a:endParaRPr lang="en-US"/>
           </a:p>
@@ -5047,7 +5244,7 @@
           <a:p>
             <a:fld id="{5BCAD085-E8A6-8845-BD4E-CB4CCA059FC4}" type="datetimeFigureOut">
               <a:rPr lang="en-US" smtClean="0"/>
-              <a:t>10/20/2026</a:t>
+              <a:t>10/26/2026</a:t>
             </a:fld>
             <a:endParaRPr lang="en-US"/>
           </a:p>
@@ -5845,8 +6042,8 @@
         </p:nvSpPr>
         <p:spPr>
           <a:xfrm>
-            <a:off x="685800" y="2148840"/>
-            <a:ext cx="5577840" cy="1737360"/>
+            <a:off x="685800" y="2194560"/>
+            <a:ext cx="5486400" cy="2651760"/>
           </a:xfrm>
           <a:prstGeom prst="rect">
             <a:avLst/>
@@ -5859,62 +6056,28 @@
           </a:bodyPr>
           <a:lstStyle/>
           <a:p>
-            <a:pPr algn="l"/>
-            <a:r>
-              <a:rPr sz="4400" b="1" i="0">
+            <a:r>
+              <a:rPr lang="pt-BR" sz="2200" b="1" dirty="0">
+                <a:solidFill>
+                  <a:srgbClr val="F2711C"/>
+                </a:solidFill>
+              </a:rPr>
+              <a:t>Pergunta</a:t>
+            </a:r>
+          </a:p>
+          <a:p>
+            <a:pPr>
+              <a:spcBef>
+                <a:spcPts val="600"/>
+              </a:spcBef>
+            </a:pPr>
+            <a:r>
+              <a:rPr lang="pt-BR" sz="3200" b="1" dirty="0">
                 <a:solidFill>
                   <a:srgbClr val="14171F"/>
                 </a:solidFill>
-                <a:latin typeface="Calibri"/>
               </a:rPr>
-              <a:t>Panela no fogão</a:t>
-            </a:r>
-          </a:p>
-          <a:p>
-            <a:pPr algn="l"/>
-            <a:r>
-              <a:rPr sz="4400" b="1" i="0">
-                <a:solidFill>
-                  <a:srgbClr val="F2711C"/>
-                </a:solidFill>
-                <a:latin typeface="Calibri"/>
-              </a:rPr>
-              <a:t>de indução</a:t>
-            </a:r>
-          </a:p>
-        </p:txBody>
-      </p:sp>
-      <p:sp>
-        <p:nvSpPr>
-          <p:cNvPr id="12" name="Subtítulo"/>
-          <p:cNvSpPr txBox="1"/>
-          <p:nvPr/>
-        </p:nvSpPr>
-        <p:spPr>
-          <a:xfrm>
-            <a:off x="685800" y="3840480"/>
-            <a:ext cx="5486400" cy="731520"/>
-          </a:xfrm>
-          <a:prstGeom prst="rect">
-            <a:avLst/>
-          </a:prstGeom>
-          <a:noFill/>
-        </p:spPr>
-        <p:txBody>
-          <a:bodyPr wrap="square" lIns="0" tIns="0" rIns="0" bIns="0" anchor="t">
-            <a:spAutoFit/>
-          </a:bodyPr>
-          <a:lstStyle/>
-          <a:p>
-            <a:pPr algn="l"/>
-            <a:r>
-              <a:rPr sz="2000" b="0" i="0">
-                <a:solidFill>
-                  <a:srgbClr val="5B6170"/>
-                </a:solidFill>
-                <a:latin typeface="Calibri"/>
-              </a:rPr>
-              <a:t>Quanto tempo a água leva para ferver?</a:t>
+              <a:t>Quanto tempo 1,1 kg de água leva para ferver em função da potência do fogão?</a:t>
             </a:r>
           </a:p>
         </p:txBody>
@@ -6014,51 +6177,6 @@
       </p:grpSpPr>
       <p:sp>
         <p:nvSpPr>
-          <p:cNvPr id="2" name="Painel escuro"/>
-          <p:cNvSpPr/>
-          <p:nvPr/>
-        </p:nvSpPr>
-        <p:spPr>
-          <a:xfrm>
-            <a:off x="5257800" y="0"/>
-            <a:ext cx="6933895" cy="6858000"/>
-          </a:xfrm>
-          <a:prstGeom prst="rect">
-            <a:avLst/>
-          </a:prstGeom>
-          <a:solidFill>
-            <a:srgbClr val="14171F"/>
-          </a:solidFill>
-          <a:ln>
-            <a:noFill/>
-          </a:ln>
-          <a:effectLst/>
-        </p:spPr>
-        <p:style>
-          <a:lnRef idx="1">
-            <a:schemeClr val="accent1"/>
-          </a:lnRef>
-          <a:fillRef idx="3">
-            <a:schemeClr val="accent1"/>
-          </a:fillRef>
-          <a:effectRef idx="2">
-            <a:schemeClr val="accent1"/>
-          </a:effectRef>
-          <a:fontRef idx="minor">
-            <a:schemeClr val="lt1"/>
-          </a:fontRef>
-        </p:style>
-        <p:txBody>
-          <a:bodyPr rtlCol="0" anchor="ctr"/>
-          <a:lstStyle/>
-          <a:p>
-            <a:pPr algn="ctr"/>
-            <a:endParaRPr/>
-          </a:p>
-        </p:txBody>
-      </p:sp>
-      <p:sp>
-        <p:nvSpPr>
           <p:cNvPr id="3" name="Rótulo"/>
           <p:cNvSpPr txBox="1"/>
           <p:nvPr/>
@@ -6094,49 +6212,14 @@
       </p:sp>
       <p:sp>
         <p:nvSpPr>
-          <p:cNvPr id="4" name="Título"/>
-          <p:cNvSpPr txBox="1"/>
+          <p:cNvPr id="14" name="Moldura do esquema"/>
+          <p:cNvSpPr/>
           <p:nvPr/>
         </p:nvSpPr>
         <p:spPr>
           <a:xfrm>
-            <a:off x="548640" y="566928"/>
-            <a:ext cx="11064240" cy="731520"/>
-          </a:xfrm>
-          <a:prstGeom prst="rect">
-            <a:avLst/>
-          </a:prstGeom>
-          <a:noFill/>
-        </p:spPr>
-        <p:txBody>
-          <a:bodyPr wrap="square" lIns="0" tIns="0" rIns="0" bIns="0" anchor="t">
-            <a:spAutoFit/>
-          </a:bodyPr>
-          <a:lstStyle/>
-          <a:p>
-            <a:pPr algn="l"/>
-            <a:r>
-              <a:rPr sz="3600" b="1" i="0">
-                <a:solidFill>
-                  <a:srgbClr val="14171F"/>
-                </a:solidFill>
-                <a:latin typeface="Calibri"/>
-              </a:rPr>
-              <a:t>O sistema e a pergunta</a:t>
-            </a:r>
-          </a:p>
-        </p:txBody>
-      </p:sp>
-      <p:sp>
-        <p:nvSpPr>
-          <p:cNvPr id="5" name="Cartão da pergunta"/>
-          <p:cNvSpPr/>
-          <p:nvPr/>
-        </p:nvSpPr>
-        <p:spPr>
-          <a:xfrm>
-            <a:off x="548640" y="1463040"/>
-            <a:ext cx="4389120" cy="1463040"/>
+            <a:off x="548640" y="1417320"/>
+            <a:ext cx="7269480" cy="5029200"/>
           </a:xfrm>
           <a:prstGeom prst="roundRect">
             <a:avLst>
@@ -6180,414 +6263,40 @@
           </a:p>
         </p:txBody>
       </p:sp>
-      <p:sp>
-        <p:nvSpPr>
-          <p:cNvPr id="6" name="TextBox 5"/>
-          <p:cNvSpPr txBox="1"/>
+      <p:pic>
+        <p:nvPicPr>
+          <p:cNvPr id="15" name="Esquema físico" descr="esquema_fisico.png"/>
+          <p:cNvPicPr>
+            <a:picLocks noChangeAspect="1"/>
+          </p:cNvPicPr>
           <p:nvPr/>
-        </p:nvSpPr>
+        </p:nvPicPr>
+        <p:blipFill>
+          <a:blip r:embed="rId3"/>
+          <a:stretch>
+            <a:fillRect/>
+          </a:stretch>
+        </p:blipFill>
         <p:spPr>
           <a:xfrm>
-            <a:off x="822960" y="1627632"/>
-            <a:ext cx="3931920" cy="1325880"/>
+            <a:off x="804672" y="1554480"/>
+            <a:ext cx="6766560" cy="4736592"/>
           </a:xfrm>
           <a:prstGeom prst="rect">
             <a:avLst/>
           </a:prstGeom>
-          <a:noFill/>
         </p:spPr>
-        <p:txBody>
-          <a:bodyPr wrap="square" lIns="0" tIns="0" rIns="0" bIns="0" anchor="t">
-            <a:spAutoFit/>
-          </a:bodyPr>
-          <a:lstStyle/>
-          <a:p>
-            <a:pPr algn="l"/>
-            <a:r>
-              <a:rPr sz="1300" b="1" i="0">
-                <a:solidFill>
-                  <a:srgbClr val="F2711C"/>
-                </a:solidFill>
-                <a:latin typeface="Calibri"/>
-              </a:rPr>
-              <a:t>Pergunta</a:t>
-            </a:r>
-          </a:p>
-          <a:p>
-            <a:pPr algn="l">
-              <a:spcBef>
-                <a:spcPts val="200"/>
-              </a:spcBef>
-            </a:pPr>
-            <a:r>
-              <a:rPr sz="1900" b="1" i="0">
-                <a:solidFill>
-                  <a:srgbClr val="14171F"/>
-                </a:solidFill>
-                <a:latin typeface="Calibri"/>
-              </a:rPr>
-              <a:t>Quanto tempo 1,1 kg de água leva para ferver em função da potência do fogão?</a:t>
-            </a:r>
-          </a:p>
-        </p:txBody>
-      </p:sp>
-      <p:sp>
-        <p:nvSpPr>
-          <p:cNvPr id="7" name="Número 01"/>
+      </p:pic>
+      <p:sp>
+        <p:nvSpPr>
+          <p:cNvPr id="19" name="Cartão do rendimento"/>
           <p:cNvSpPr/>
           <p:nvPr/>
         </p:nvSpPr>
         <p:spPr>
           <a:xfrm>
-            <a:off x="548640" y="3383280"/>
-            <a:ext cx="502920" cy="502920"/>
-          </a:xfrm>
-          <a:prstGeom prst="ellipse">
-            <a:avLst/>
-          </a:prstGeom>
-          <a:solidFill>
-            <a:srgbClr val="F2711C"/>
-          </a:solidFill>
-          <a:ln>
-            <a:noFill/>
-          </a:ln>
-          <a:effectLst/>
-        </p:spPr>
-        <p:style>
-          <a:lnRef idx="1">
-            <a:schemeClr val="accent1"/>
-          </a:lnRef>
-          <a:fillRef idx="3">
-            <a:schemeClr val="accent1"/>
-          </a:fillRef>
-          <a:effectRef idx="2">
-            <a:schemeClr val="accent1"/>
-          </a:effectRef>
-          <a:fontRef idx="minor">
-            <a:schemeClr val="lt1"/>
-          </a:fontRef>
-        </p:style>
-        <p:txBody>
-          <a:bodyPr lIns="0" tIns="0" rIns="0" bIns="0" rtlCol="0" anchor="ctr"/>
-          <a:lstStyle/>
-          <a:p>
-            <a:pPr algn="ctr"/>
-            <a:r>
-              <a:rPr sz="1500" b="1">
-                <a:solidFill>
-                  <a:srgbClr val="FFFFFF"/>
-                </a:solidFill>
-                <a:latin typeface="Calibri"/>
-              </a:rPr>
-              <a:t>01</a:t>
-            </a:r>
-          </a:p>
-        </p:txBody>
-      </p:sp>
-      <p:sp>
-        <p:nvSpPr>
-          <p:cNvPr id="8" name="TextBox 7"/>
-          <p:cNvSpPr txBox="1"/>
-          <p:nvPr/>
-        </p:nvSpPr>
-        <p:spPr>
-          <a:xfrm>
-            <a:off x="1280160" y="3346704"/>
-            <a:ext cx="3657600" cy="960120"/>
-          </a:xfrm>
-          <a:prstGeom prst="rect">
-            <a:avLst/>
-          </a:prstGeom>
-          <a:noFill/>
-        </p:spPr>
-        <p:txBody>
-          <a:bodyPr wrap="square" lIns="0" tIns="0" rIns="0" bIns="0" anchor="t">
-            <a:spAutoFit/>
-          </a:bodyPr>
-          <a:lstStyle/>
-          <a:p>
-            <a:pPr algn="l"/>
-            <a:r>
-              <a:rPr sz="1800" b="1" i="0">
-                <a:solidFill>
-                  <a:srgbClr val="14171F"/>
-                </a:solidFill>
-                <a:latin typeface="Calibri"/>
-              </a:rPr>
-              <a:t>Indução</a:t>
-            </a:r>
-          </a:p>
-          <a:p>
-            <a:pPr algn="l">
-              <a:spcBef>
-                <a:spcPts val="200"/>
-              </a:spcBef>
-            </a:pPr>
-            <a:r>
-              <a:rPr sz="1400" b="0" i="0">
-                <a:solidFill>
-                  <a:srgbClr val="5B6170"/>
-                </a:solidFill>
-                <a:latin typeface="Calibri"/>
-              </a:rPr>
-              <a:t>O campo magnético da bobina esquenta direto o aço da panela.</a:t>
-            </a:r>
-          </a:p>
-        </p:txBody>
-      </p:sp>
-      <p:sp>
-        <p:nvSpPr>
-          <p:cNvPr id="9" name="Número 02"/>
-          <p:cNvSpPr/>
-          <p:nvPr/>
-        </p:nvSpPr>
-        <p:spPr>
-          <a:xfrm>
-            <a:off x="548640" y="4434840"/>
-            <a:ext cx="502920" cy="502920"/>
-          </a:xfrm>
-          <a:prstGeom prst="ellipse">
-            <a:avLst/>
-          </a:prstGeom>
-          <a:solidFill>
-            <a:srgbClr val="F2711C"/>
-          </a:solidFill>
-          <a:ln>
-            <a:noFill/>
-          </a:ln>
-          <a:effectLst/>
-        </p:spPr>
-        <p:style>
-          <a:lnRef idx="1">
-            <a:schemeClr val="accent1"/>
-          </a:lnRef>
-          <a:fillRef idx="3">
-            <a:schemeClr val="accent1"/>
-          </a:fillRef>
-          <a:effectRef idx="2">
-            <a:schemeClr val="accent1"/>
-          </a:effectRef>
-          <a:fontRef idx="minor">
-            <a:schemeClr val="lt1"/>
-          </a:fontRef>
-        </p:style>
-        <p:txBody>
-          <a:bodyPr lIns="0" tIns="0" rIns="0" bIns="0" rtlCol="0" anchor="ctr"/>
-          <a:lstStyle/>
-          <a:p>
-            <a:pPr algn="ctr"/>
-            <a:r>
-              <a:rPr sz="1500" b="1">
-                <a:solidFill>
-                  <a:srgbClr val="FFFFFF"/>
-                </a:solidFill>
-                <a:latin typeface="Calibri"/>
-              </a:rPr>
-              <a:t>02</a:t>
-            </a:r>
-          </a:p>
-        </p:txBody>
-      </p:sp>
-      <p:sp>
-        <p:nvSpPr>
-          <p:cNvPr id="10" name="TextBox 9"/>
-          <p:cNvSpPr txBox="1"/>
-          <p:nvPr/>
-        </p:nvSpPr>
-        <p:spPr>
-          <a:xfrm>
-            <a:off x="1280160" y="4398264"/>
-            <a:ext cx="3657600" cy="960120"/>
-          </a:xfrm>
-          <a:prstGeom prst="rect">
-            <a:avLst/>
-          </a:prstGeom>
-          <a:noFill/>
-        </p:spPr>
-        <p:txBody>
-          <a:bodyPr wrap="square" lIns="0" tIns="0" rIns="0" bIns="0" anchor="t">
-            <a:spAutoFit/>
-          </a:bodyPr>
-          <a:lstStyle/>
-          <a:p>
-            <a:pPr algn="l"/>
-            <a:r>
-              <a:rPr sz="1800" b="1" i="0">
-                <a:solidFill>
-                  <a:srgbClr val="14171F"/>
-                </a:solidFill>
-                <a:latin typeface="Calibri"/>
-              </a:rPr>
-              <a:t>Panela sem tampa</a:t>
-            </a:r>
-          </a:p>
-          <a:p>
-            <a:pPr algn="l">
-              <a:spcBef>
-                <a:spcPts val="200"/>
-              </a:spcBef>
-            </a:pPr>
-            <a:r>
-              <a:rPr sz="1400" b="0" i="0">
-                <a:solidFill>
-                  <a:srgbClr val="5B6170"/>
-                </a:solidFill>
-                <a:latin typeface="Calibri"/>
-              </a:rPr>
-              <a:t>Perde calor para o ar pelas paredes e pela superfície da água.</a:t>
-            </a:r>
-          </a:p>
-        </p:txBody>
-      </p:sp>
-      <p:sp>
-        <p:nvSpPr>
-          <p:cNvPr id="11" name="Número 03"/>
-          <p:cNvSpPr/>
-          <p:nvPr/>
-        </p:nvSpPr>
-        <p:spPr>
-          <a:xfrm>
-            <a:off x="548640" y="5486400"/>
-            <a:ext cx="502920" cy="502920"/>
-          </a:xfrm>
-          <a:prstGeom prst="ellipse">
-            <a:avLst/>
-          </a:prstGeom>
-          <a:solidFill>
-            <a:srgbClr val="F2711C"/>
-          </a:solidFill>
-          <a:ln>
-            <a:noFill/>
-          </a:ln>
-          <a:effectLst/>
-        </p:spPr>
-        <p:style>
-          <a:lnRef idx="1">
-            <a:schemeClr val="accent1"/>
-          </a:lnRef>
-          <a:fillRef idx="3">
-            <a:schemeClr val="accent1"/>
-          </a:fillRef>
-          <a:effectRef idx="2">
-            <a:schemeClr val="accent1"/>
-          </a:effectRef>
-          <a:fontRef idx="minor">
-            <a:schemeClr val="lt1"/>
-          </a:fontRef>
-        </p:style>
-        <p:txBody>
-          <a:bodyPr lIns="0" tIns="0" rIns="0" bIns="0" rtlCol="0" anchor="ctr"/>
-          <a:lstStyle/>
-          <a:p>
-            <a:pPr algn="ctr"/>
-            <a:r>
-              <a:rPr sz="1500" b="1">
-                <a:solidFill>
-                  <a:srgbClr val="FFFFFF"/>
-                </a:solidFill>
-                <a:latin typeface="Calibri"/>
-              </a:rPr>
-              <a:t>03</a:t>
-            </a:r>
-          </a:p>
-        </p:txBody>
-      </p:sp>
-      <p:sp>
-        <p:nvSpPr>
-          <p:cNvPr id="12" name="TextBox 11"/>
-          <p:cNvSpPr txBox="1"/>
-          <p:nvPr/>
-        </p:nvSpPr>
-        <p:spPr>
-          <a:xfrm>
-            <a:off x="1280160" y="5449824"/>
-            <a:ext cx="3657600" cy="960120"/>
-          </a:xfrm>
-          <a:prstGeom prst="rect">
-            <a:avLst/>
-          </a:prstGeom>
-          <a:noFill/>
-        </p:spPr>
-        <p:txBody>
-          <a:bodyPr wrap="square" lIns="0" tIns="0" rIns="0" bIns="0" anchor="t">
-            <a:spAutoFit/>
-          </a:bodyPr>
-          <a:lstStyle/>
-          <a:p>
-            <a:pPr algn="l"/>
-            <a:r>
-              <a:rPr sz="1800" b="1" i="0">
-                <a:solidFill>
-                  <a:srgbClr val="14171F"/>
-                </a:solidFill>
-                <a:latin typeface="Calibri"/>
-              </a:rPr>
-              <a:t>Fogão liga e desliga</a:t>
-            </a:r>
-          </a:p>
-          <a:p>
-            <a:pPr algn="l">
-              <a:spcBef>
-                <a:spcPts val="200"/>
-              </a:spcBef>
-            </a:pPr>
-            <a:r>
-              <a:rPr sz="1400" b="0" i="0">
-                <a:solidFill>
-                  <a:srgbClr val="5B6170"/>
-                </a:solidFill>
-                <a:latin typeface="Calibri"/>
-              </a:rPr>
-              <a:t>No modo 150 °C, a potência que chega à panela é uma média.</a:t>
-            </a:r>
-          </a:p>
-        </p:txBody>
-      </p:sp>
-      <p:sp>
-        <p:nvSpPr>
-          <p:cNvPr id="13" name="TextBox 12"/>
-          <p:cNvSpPr txBox="1"/>
-          <p:nvPr/>
-        </p:nvSpPr>
-        <p:spPr>
-          <a:xfrm>
-            <a:off x="5623560" y="457200"/>
-            <a:ext cx="6217920" cy="320040"/>
-          </a:xfrm>
-          <a:prstGeom prst="rect">
-            <a:avLst/>
-          </a:prstGeom>
-          <a:noFill/>
-        </p:spPr>
-        <p:txBody>
-          <a:bodyPr wrap="square" lIns="0" tIns="0" rIns="0" bIns="0" anchor="t">
-            <a:spAutoFit/>
-          </a:bodyPr>
-          <a:lstStyle/>
-          <a:p>
-            <a:pPr algn="l"/>
-            <a:r>
-              <a:rPr sz="1200" b="1" i="0">
-                <a:solidFill>
-                  <a:srgbClr val="FFFFFF"/>
-                </a:solidFill>
-                <a:latin typeface="Calibri"/>
-              </a:rPr>
-              <a:t>ESQUEMA FÍSICO</a:t>
-            </a:r>
-          </a:p>
-        </p:txBody>
-      </p:sp>
-      <p:sp>
-        <p:nvSpPr>
-          <p:cNvPr id="14" name="Moldura do esquema"/>
-          <p:cNvSpPr/>
-          <p:nvPr/>
-        </p:nvSpPr>
-        <p:spPr>
-          <a:xfrm>
-            <a:off x="5623560" y="868680"/>
-            <a:ext cx="6217920" cy="4526280"/>
+            <a:off x="8183879" y="2788920"/>
+            <a:ext cx="3474720" cy="2103120"/>
           </a:xfrm>
           <a:prstGeom prst="roundRect">
             <a:avLst>
@@ -6631,30 +6340,6 @@
           </a:p>
         </p:txBody>
       </p:sp>
-      <p:pic>
-        <p:nvPicPr>
-          <p:cNvPr id="15" name="Esquema físico" descr="esquema_fisico.png"/>
-          <p:cNvPicPr>
-            <a:picLocks noChangeAspect="1"/>
-          </p:cNvPicPr>
-          <p:nvPr/>
-        </p:nvPicPr>
-        <p:blipFill>
-          <a:blip r:embed="rId3"/>
-          <a:stretch>
-            <a:fillRect/>
-          </a:stretch>
-        </p:blipFill>
-        <p:spPr>
-          <a:xfrm>
-            <a:off x="5852160" y="1097280"/>
-            <a:ext cx="5760720" cy="4032504"/>
-          </a:xfrm>
-          <a:prstGeom prst="rect">
-            <a:avLst/>
-          </a:prstGeom>
-        </p:spPr>
-      </p:pic>
       <p:sp>
         <p:nvSpPr>
           <p:cNvPr id="16" name="TextBox 15"/>
@@ -6663,8 +6348,8 @@
         </p:nvSpPr>
         <p:spPr>
           <a:xfrm>
-            <a:off x="5623560" y="5669280"/>
-            <a:ext cx="1600200" cy="731520"/>
+            <a:off x="8458200" y="2926080"/>
+            <a:ext cx="3017520" cy="914400"/>
           </a:xfrm>
           <a:prstGeom prst="rect">
             <a:avLst/>
@@ -6679,7 +6364,7 @@
           <a:p>
             <a:pPr algn="l"/>
             <a:r>
-              <a:rPr sz="4000" b="1" i="0">
+              <a:rPr sz="5400" b="1" i="0">
                 <a:solidFill>
                   <a:srgbClr val="F2711C"/>
                 </a:solidFill>
@@ -6698,8 +6383,8 @@
         </p:nvSpPr>
         <p:spPr>
           <a:xfrm>
-            <a:off x="7086600" y="5669280"/>
-            <a:ext cx="4754880" cy="731520"/>
+            <a:off x="8458200" y="3886200"/>
+            <a:ext cx="3017520" cy="1005840"/>
           </a:xfrm>
           <a:prstGeom prst="rect">
             <a:avLst/>
@@ -6707,7 +6392,7 @@
           <a:noFill/>
         </p:spPr>
         <p:txBody>
-          <a:bodyPr wrap="square" lIns="0" tIns="0" rIns="0" bIns="0" anchor="ctr">
+          <a:bodyPr wrap="square" lIns="0" tIns="0" rIns="0" bIns="0" anchor="t">
             <a:spAutoFit/>
           </a:bodyPr>
           <a:lstStyle/>
@@ -6716,7 +6401,7 @@
             <a:r>
               <a:rPr sz="1500" b="0" i="0">
                 <a:solidFill>
-                  <a:srgbClr val="FFFFFF"/>
+                  <a:srgbClr val="5B6170"/>
                 </a:solidFill>
                 <a:latin typeface="Calibri"/>
               </a:rPr>
@@ -6725,77 +6410,9 @@
           </a:p>
         </p:txBody>
       </p:sp>
-    </p:spTree>
-  </p:cSld>
-  <p:clrMapOvr>
-    <a:masterClrMapping/>
-  </p:clrMapOvr>
-</p:sld>
-</file>
-
-<file path=ppt/slides/slide3.xml><?xml version="1.0" encoding="utf-8"?>
-<p:sld xmlns:a="http://schemas.openxmlformats.org/drawingml/2006/main" xmlns:r="http://schemas.openxmlformats.org/officeDocument/2006/relationships" xmlns:p="http://schemas.openxmlformats.org/presentationml/2006/main">
-  <p:cSld>
-    <p:bg>
-      <p:bgPr>
-        <a:solidFill>
-          <a:srgbClr val="FFFFFF"/>
-        </a:solidFill>
-        <a:effectLst/>
-      </p:bgPr>
-    </p:bg>
-    <p:spTree>
-      <p:nvGrpSpPr>
-        <p:cNvPr id="1" name=""/>
-        <p:cNvGrpSpPr/>
-        <p:nvPr/>
-      </p:nvGrpSpPr>
-      <p:grpSpPr>
-        <a:xfrm>
-          <a:off x="0" y="0"/>
-          <a:ext cx="0" cy="0"/>
-          <a:chOff x="0" y="0"/>
-          <a:chExt cx="0" cy="0"/>
-        </a:xfrm>
-      </p:grpSpPr>
-      <p:sp>
-        <p:nvSpPr>
-          <p:cNvPr id="2" name="Rótulo"/>
-          <p:cNvSpPr txBox="1"/>
-          <p:nvPr/>
-        </p:nvSpPr>
-        <p:spPr>
-          <a:xfrm>
-            <a:off x="548640" y="347472"/>
-            <a:ext cx="7315200" cy="274320"/>
-          </a:xfrm>
-          <a:prstGeom prst="rect">
-            <a:avLst/>
-          </a:prstGeom>
-          <a:noFill/>
-        </p:spPr>
-        <p:txBody>
-          <a:bodyPr wrap="square" lIns="0" tIns="0" rIns="0" bIns="0" anchor="t">
-            <a:spAutoFit/>
-          </a:bodyPr>
-          <a:lstStyle/>
-          <a:p>
-            <a:pPr algn="l"/>
-            <a:r>
-              <a:rPr sz="1200" b="1" i="0">
-                <a:solidFill>
-                  <a:srgbClr val="F2711C"/>
-                </a:solidFill>
-                <a:latin typeface="Calibri"/>
-              </a:rPr>
-              <a:t>MODELO E EQUAÇÕES</a:t>
-            </a:r>
-          </a:p>
-        </p:txBody>
-      </p:sp>
-      <p:sp>
-        <p:nvSpPr>
-          <p:cNvPr id="3" name="Título"/>
+      <p:sp>
+        <p:nvSpPr>
+          <p:cNvPr id="18" name="TextBox 17"/>
           <p:cNvSpPr txBox="1"/>
           <p:nvPr/>
         </p:nvSpPr>
@@ -6815,511 +6432,14 @@
           </a:bodyPr>
           <a:lstStyle/>
           <a:p>
-            <a:pPr algn="l"/>
-            <a:r>
-              <a:rPr sz="3600" b="1" i="0">
+            <a:r>
+              <a:rPr sz="3600" b="1">
                 <a:solidFill>
                   <a:srgbClr val="14171F"/>
                 </a:solidFill>
                 <a:latin typeface="Calibri"/>
               </a:rPr>
-              <a:t>O modelo: dois estoques de energia</a:t>
-            </a:r>
-          </a:p>
-        </p:txBody>
-      </p:sp>
-      <p:pic>
-        <p:nvPicPr>
-          <p:cNvPr id="4" name="Diagrama de estoques e fluxos" descr="diagrama_estoques_fluxos.png"/>
-          <p:cNvPicPr>
-            <a:picLocks noChangeAspect="1"/>
-          </p:cNvPicPr>
-          <p:nvPr/>
-        </p:nvPicPr>
-        <p:blipFill>
-          <a:blip r:embed="rId3"/>
-          <a:stretch>
-            <a:fillRect/>
-          </a:stretch>
-        </p:blipFill>
-        <p:spPr>
-          <a:xfrm>
-            <a:off x="411480" y="1417320"/>
-            <a:ext cx="7223760" cy="4714454"/>
-          </a:xfrm>
-          <a:prstGeom prst="rect">
-            <a:avLst/>
-          </a:prstGeom>
-        </p:spPr>
-      </p:pic>
-      <p:sp>
-        <p:nvSpPr>
-          <p:cNvPr id="5" name="Cartão das hipóteses"/>
-          <p:cNvSpPr/>
-          <p:nvPr/>
-        </p:nvSpPr>
-        <p:spPr>
-          <a:xfrm>
-            <a:off x="8001000" y="1508760"/>
-            <a:ext cx="3611880" cy="4754880"/>
-          </a:xfrm>
-          <a:prstGeom prst="roundRect">
-            <a:avLst>
-              <a:gd name="adj" fmla="val 8000"/>
-            </a:avLst>
-          </a:prstGeom>
-          <a:solidFill>
-            <a:srgbClr val="F6F7F9"/>
-          </a:solidFill>
-          <a:ln>
-            <a:noFill/>
-          </a:ln>
-          <a:effectLst>
-            <a:outerShdw blurRad="190500" dist="38100" dir="5400000" algn="t" rotWithShape="0">
-              <a:srgbClr val="000000">
-                <a:alpha val="14000"/>
-              </a:srgbClr>
-            </a:outerShdw>
-          </a:effectLst>
-        </p:spPr>
-        <p:style>
-          <a:lnRef idx="1">
-            <a:schemeClr val="accent1"/>
-          </a:lnRef>
-          <a:fillRef idx="3">
-            <a:schemeClr val="accent1"/>
-          </a:fillRef>
-          <a:effectRef idx="2">
-            <a:schemeClr val="accent1"/>
-          </a:effectRef>
-          <a:fontRef idx="minor">
-            <a:schemeClr val="lt1"/>
-          </a:fontRef>
-        </p:style>
-        <p:txBody>
-          <a:bodyPr rtlCol="0" anchor="ctr"/>
-          <a:lstStyle/>
-          <a:p>
-            <a:pPr algn="ctr"/>
-            <a:endParaRPr/>
-          </a:p>
-        </p:txBody>
-      </p:sp>
-      <p:sp>
-        <p:nvSpPr>
-          <p:cNvPr id="6" name="TextBox 5"/>
-          <p:cNvSpPr txBox="1"/>
-          <p:nvPr/>
-        </p:nvSpPr>
-        <p:spPr>
-          <a:xfrm>
-            <a:off x="8321040" y="1783080"/>
-            <a:ext cx="3108960" cy="365760"/>
-          </a:xfrm>
-          <a:prstGeom prst="rect">
-            <a:avLst/>
-          </a:prstGeom>
-          <a:noFill/>
-        </p:spPr>
-        <p:txBody>
-          <a:bodyPr wrap="square" lIns="0" tIns="0" rIns="0" bIns="0" anchor="t">
-            <a:spAutoFit/>
-          </a:bodyPr>
-          <a:lstStyle/>
-          <a:p>
-            <a:pPr algn="l"/>
-            <a:r>
-              <a:rPr sz="2000" b="1" i="0">
-                <a:solidFill>
-                  <a:srgbClr val="14171F"/>
-                </a:solidFill>
-                <a:latin typeface="Calibri"/>
-              </a:rPr>
-              <a:t>Hipóteses</a:t>
-            </a:r>
-          </a:p>
-        </p:txBody>
-      </p:sp>
-      <p:sp>
-        <p:nvSpPr>
-          <p:cNvPr id="7" name="Marcador 1"/>
-          <p:cNvSpPr/>
-          <p:nvPr/>
-        </p:nvSpPr>
-        <p:spPr>
-          <a:xfrm>
-            <a:off x="8321040" y="2450592"/>
-            <a:ext cx="146304" cy="146304"/>
-          </a:xfrm>
-          <a:prstGeom prst="ellipse">
-            <a:avLst/>
-          </a:prstGeom>
-          <a:solidFill>
-            <a:srgbClr val="F2711C"/>
-          </a:solidFill>
-          <a:ln>
-            <a:noFill/>
-          </a:ln>
-          <a:effectLst/>
-        </p:spPr>
-        <p:style>
-          <a:lnRef idx="1">
-            <a:schemeClr val="accent1"/>
-          </a:lnRef>
-          <a:fillRef idx="3">
-            <a:schemeClr val="accent1"/>
-          </a:fillRef>
-          <a:effectRef idx="2">
-            <a:schemeClr val="accent1"/>
-          </a:effectRef>
-          <a:fontRef idx="minor">
-            <a:schemeClr val="lt1"/>
-          </a:fontRef>
-        </p:style>
-        <p:txBody>
-          <a:bodyPr rtlCol="0" anchor="ctr"/>
-          <a:lstStyle/>
-          <a:p>
-            <a:pPr algn="ctr"/>
-            <a:endParaRPr/>
-          </a:p>
-        </p:txBody>
-      </p:sp>
-      <p:sp>
-        <p:nvSpPr>
-          <p:cNvPr id="8" name="TextBox 7"/>
-          <p:cNvSpPr txBox="1"/>
-          <p:nvPr/>
-        </p:nvSpPr>
-        <p:spPr>
-          <a:xfrm>
-            <a:off x="8613648" y="2377440"/>
-            <a:ext cx="2880360" cy="868680"/>
-          </a:xfrm>
-          <a:prstGeom prst="rect">
-            <a:avLst/>
-          </a:prstGeom>
-          <a:noFill/>
-        </p:spPr>
-        <p:txBody>
-          <a:bodyPr wrap="square" lIns="0" tIns="0" rIns="0" bIns="0" anchor="t">
-            <a:spAutoFit/>
-          </a:bodyPr>
-          <a:lstStyle/>
-          <a:p>
-            <a:pPr algn="l"/>
-            <a:r>
-              <a:rPr sz="1600" b="1" i="0">
-                <a:solidFill>
-                  <a:srgbClr val="14171F"/>
-                </a:solidFill>
-                <a:latin typeface="Calibri"/>
-              </a:rPr>
-              <a:t>Temperatura uniforme</a:t>
-            </a:r>
-          </a:p>
-          <a:p>
-            <a:pPr algn="l">
-              <a:spcBef>
-                <a:spcPts val="100"/>
-              </a:spcBef>
-            </a:pPr>
-            <a:r>
-              <a:rPr sz="1400" b="0" i="0">
-                <a:solidFill>
-                  <a:srgbClr val="5B6170"/>
-                </a:solidFill>
-                <a:latin typeface="Calibri"/>
-              </a:rPr>
-              <a:t>na panela (Tp) e na água (Ta)</a:t>
-            </a:r>
-          </a:p>
-        </p:txBody>
-      </p:sp>
-      <p:sp>
-        <p:nvSpPr>
-          <p:cNvPr id="9" name="Marcador 2"/>
-          <p:cNvSpPr/>
-          <p:nvPr/>
-        </p:nvSpPr>
-        <p:spPr>
-          <a:xfrm>
-            <a:off x="8321040" y="3383280"/>
-            <a:ext cx="146304" cy="146304"/>
-          </a:xfrm>
-          <a:prstGeom prst="ellipse">
-            <a:avLst/>
-          </a:prstGeom>
-          <a:solidFill>
-            <a:srgbClr val="F2711C"/>
-          </a:solidFill>
-          <a:ln>
-            <a:noFill/>
-          </a:ln>
-          <a:effectLst/>
-        </p:spPr>
-        <p:style>
-          <a:lnRef idx="1">
-            <a:schemeClr val="accent1"/>
-          </a:lnRef>
-          <a:fillRef idx="3">
-            <a:schemeClr val="accent1"/>
-          </a:fillRef>
-          <a:effectRef idx="2">
-            <a:schemeClr val="accent1"/>
-          </a:effectRef>
-          <a:fontRef idx="minor">
-            <a:schemeClr val="lt1"/>
-          </a:fontRef>
-        </p:style>
-        <p:txBody>
-          <a:bodyPr rtlCol="0" anchor="ctr"/>
-          <a:lstStyle/>
-          <a:p>
-            <a:pPr algn="ctr"/>
-            <a:endParaRPr/>
-          </a:p>
-        </p:txBody>
-      </p:sp>
-      <p:sp>
-        <p:nvSpPr>
-          <p:cNvPr id="10" name="TextBox 9"/>
-          <p:cNvSpPr txBox="1"/>
-          <p:nvPr/>
-        </p:nvSpPr>
-        <p:spPr>
-          <a:xfrm>
-            <a:off x="8613648" y="3310128"/>
-            <a:ext cx="2880360" cy="868680"/>
-          </a:xfrm>
-          <a:prstGeom prst="rect">
-            <a:avLst/>
-          </a:prstGeom>
-          <a:noFill/>
-        </p:spPr>
-        <p:txBody>
-          <a:bodyPr wrap="square" lIns="0" tIns="0" rIns="0" bIns="0" anchor="t">
-            <a:spAutoFit/>
-          </a:bodyPr>
-          <a:lstStyle/>
-          <a:p>
-            <a:pPr algn="l"/>
-            <a:r>
-              <a:rPr sz="1600" b="1" i="0">
-                <a:solidFill>
-                  <a:srgbClr val="14171F"/>
-                </a:solidFill>
-                <a:latin typeface="Calibri"/>
-              </a:rPr>
-              <a:t>Sem convecção na água</a:t>
-            </a:r>
-          </a:p>
-          <a:p>
-            <a:pPr algn="l">
-              <a:spcBef>
-                <a:spcPts val="100"/>
-              </a:spcBef>
-            </a:pPr>
-            <a:r>
-              <a:rPr sz="1400" b="0" i="0">
-                <a:solidFill>
-                  <a:srgbClr val="5B6170"/>
-                </a:solidFill>
-                <a:latin typeface="Calibri"/>
-              </a:rPr>
-              <a:t>calor passa por condução na parede</a:t>
-            </a:r>
-          </a:p>
-        </p:txBody>
-      </p:sp>
-      <p:sp>
-        <p:nvSpPr>
-          <p:cNvPr id="11" name="Marcador 3"/>
-          <p:cNvSpPr/>
-          <p:nvPr/>
-        </p:nvSpPr>
-        <p:spPr>
-          <a:xfrm>
-            <a:off x="8321040" y="4315968"/>
-            <a:ext cx="146304" cy="146304"/>
-          </a:xfrm>
-          <a:prstGeom prst="ellipse">
-            <a:avLst/>
-          </a:prstGeom>
-          <a:solidFill>
-            <a:srgbClr val="F2711C"/>
-          </a:solidFill>
-          <a:ln>
-            <a:noFill/>
-          </a:ln>
-          <a:effectLst/>
-        </p:spPr>
-        <p:style>
-          <a:lnRef idx="1">
-            <a:schemeClr val="accent1"/>
-          </a:lnRef>
-          <a:fillRef idx="3">
-            <a:schemeClr val="accent1"/>
-          </a:fillRef>
-          <a:effectRef idx="2">
-            <a:schemeClr val="accent1"/>
-          </a:effectRef>
-          <a:fontRef idx="minor">
-            <a:schemeClr val="lt1"/>
-          </a:fontRef>
-        </p:style>
-        <p:txBody>
-          <a:bodyPr rtlCol="0" anchor="ctr"/>
-          <a:lstStyle/>
-          <a:p>
-            <a:pPr algn="ctr"/>
-            <a:endParaRPr/>
-          </a:p>
-        </p:txBody>
-      </p:sp>
-      <p:sp>
-        <p:nvSpPr>
-          <p:cNvPr id="12" name="TextBox 11"/>
-          <p:cNvSpPr txBox="1"/>
-          <p:nvPr/>
-        </p:nvSpPr>
-        <p:spPr>
-          <a:xfrm>
-            <a:off x="8613648" y="4242816"/>
-            <a:ext cx="2880360" cy="868680"/>
-          </a:xfrm>
-          <a:prstGeom prst="rect">
-            <a:avLst/>
-          </a:prstGeom>
-          <a:noFill/>
-        </p:spPr>
-        <p:txBody>
-          <a:bodyPr wrap="square" lIns="0" tIns="0" rIns="0" bIns="0" anchor="t">
-            <a:spAutoFit/>
-          </a:bodyPr>
-          <a:lstStyle/>
-          <a:p>
-            <a:pPr algn="l"/>
-            <a:r>
-              <a:rPr sz="1600" b="1" i="0">
-                <a:solidFill>
-                  <a:srgbClr val="14171F"/>
-                </a:solidFill>
-                <a:latin typeface="Calibri"/>
-              </a:rPr>
-              <a:t>Fundo não perde calor</a:t>
-            </a:r>
-          </a:p>
-          <a:p>
-            <a:pPr algn="l">
-              <a:spcBef>
-                <a:spcPts val="100"/>
-              </a:spcBef>
-            </a:pPr>
-            <a:r>
-              <a:rPr sz="1400" b="0" i="0">
-                <a:solidFill>
-                  <a:srgbClr val="5B6170"/>
-                </a:solidFill>
-                <a:latin typeface="Calibri"/>
-              </a:rPr>
-              <a:t>apoiado no fogão</a:t>
-            </a:r>
-          </a:p>
-        </p:txBody>
-      </p:sp>
-      <p:sp>
-        <p:nvSpPr>
-          <p:cNvPr id="13" name="Marcador 4"/>
-          <p:cNvSpPr/>
-          <p:nvPr/>
-        </p:nvSpPr>
-        <p:spPr>
-          <a:xfrm>
-            <a:off x="8321040" y="5248656"/>
-            <a:ext cx="146304" cy="146304"/>
-          </a:xfrm>
-          <a:prstGeom prst="ellipse">
-            <a:avLst/>
-          </a:prstGeom>
-          <a:solidFill>
-            <a:srgbClr val="F2711C"/>
-          </a:solidFill>
-          <a:ln>
-            <a:noFill/>
-          </a:ln>
-          <a:effectLst/>
-        </p:spPr>
-        <p:style>
-          <a:lnRef idx="1">
-            <a:schemeClr val="accent1"/>
-          </a:lnRef>
-          <a:fillRef idx="3">
-            <a:schemeClr val="accent1"/>
-          </a:fillRef>
-          <a:effectRef idx="2">
-            <a:schemeClr val="accent1"/>
-          </a:effectRef>
-          <a:fontRef idx="minor">
-            <a:schemeClr val="lt1"/>
-          </a:fontRef>
-        </p:style>
-        <p:txBody>
-          <a:bodyPr rtlCol="0" anchor="ctr"/>
-          <a:lstStyle/>
-          <a:p>
-            <a:pPr algn="ctr"/>
-            <a:endParaRPr/>
-          </a:p>
-        </p:txBody>
-      </p:sp>
-      <p:sp>
-        <p:nvSpPr>
-          <p:cNvPr id="14" name="TextBox 13"/>
-          <p:cNvSpPr txBox="1"/>
-          <p:nvPr/>
-        </p:nvSpPr>
-        <p:spPr>
-          <a:xfrm>
-            <a:off x="8613648" y="5175504"/>
-            <a:ext cx="2880360" cy="868680"/>
-          </a:xfrm>
-          <a:prstGeom prst="rect">
-            <a:avLst/>
-          </a:prstGeom>
-          <a:noFill/>
-        </p:spPr>
-        <p:txBody>
-          <a:bodyPr wrap="square" lIns="0" tIns="0" rIns="0" bIns="0" anchor="t">
-            <a:spAutoFit/>
-          </a:bodyPr>
-          <a:lstStyle/>
-          <a:p>
-            <a:pPr algn="l"/>
-            <a:r>
-              <a:rPr sz="1600" b="1" i="0">
-                <a:solidFill>
-                  <a:srgbClr val="14171F"/>
-                </a:solidFill>
-                <a:latin typeface="Calibri"/>
-              </a:rPr>
-              <a:t>Sem radiação e evaporação</a:t>
-            </a:r>
-          </a:p>
-          <a:p>
-            <a:pPr algn="l">
-              <a:spcBef>
-                <a:spcPts val="100"/>
-              </a:spcBef>
-            </a:pPr>
-            <a:r>
-              <a:rPr sz="1400" b="0" i="0">
-                <a:solidFill>
-                  <a:srgbClr val="5B6170"/>
-                </a:solidFill>
-                <a:latin typeface="Calibri"/>
-              </a:rPr>
-              <a:t>como termos separados</a:t>
+              <a:t>Esquema físico</a:t>
             </a:r>
           </a:p>
         </p:txBody>
@@ -7332,7 +6452,7 @@
 </p:sld>
 </file>
 
-<file path=ppt/slides/slide4.xml><?xml version="1.0" encoding="utf-8"?>
+<file path=ppt/slides/slide3.xml><?xml version="1.0" encoding="utf-8"?>
 <p:sld xmlns:a="http://schemas.openxmlformats.org/drawingml/2006/main" xmlns:r="http://schemas.openxmlformats.org/officeDocument/2006/relationships" xmlns:p="http://schemas.openxmlformats.org/presentationml/2006/main">
   <p:cSld>
     <p:bg>
@@ -8993,6 +8113,605 @@
 </p:sld>
 </file>
 
+<file path=ppt/slides/slide4.xml><?xml version="1.0" encoding="utf-8"?>
+<p:sld xmlns:a="http://schemas.openxmlformats.org/drawingml/2006/main" xmlns:r="http://schemas.openxmlformats.org/officeDocument/2006/relationships" xmlns:p="http://schemas.openxmlformats.org/presentationml/2006/main">
+  <p:cSld>
+    <p:bg>
+      <p:bgPr>
+        <a:solidFill>
+          <a:srgbClr val="FFFFFF"/>
+        </a:solidFill>
+        <a:effectLst/>
+      </p:bgPr>
+    </p:bg>
+    <p:spTree>
+      <p:nvGrpSpPr>
+        <p:cNvPr id="1" name=""/>
+        <p:cNvGrpSpPr/>
+        <p:nvPr/>
+      </p:nvGrpSpPr>
+      <p:grpSpPr>
+        <a:xfrm>
+          <a:off x="0" y="0"/>
+          <a:ext cx="0" cy="0"/>
+          <a:chOff x="0" y="0"/>
+          <a:chExt cx="0" cy="0"/>
+        </a:xfrm>
+      </p:grpSpPr>
+      <p:sp>
+        <p:nvSpPr>
+          <p:cNvPr id="2" name="Rótulo"/>
+          <p:cNvSpPr txBox="1"/>
+          <p:nvPr/>
+        </p:nvSpPr>
+        <p:spPr>
+          <a:xfrm>
+            <a:off x="548640" y="347472"/>
+            <a:ext cx="7315200" cy="274320"/>
+          </a:xfrm>
+          <a:prstGeom prst="rect">
+            <a:avLst/>
+          </a:prstGeom>
+          <a:noFill/>
+        </p:spPr>
+        <p:txBody>
+          <a:bodyPr wrap="square" lIns="0" tIns="0" rIns="0" bIns="0" anchor="t">
+            <a:spAutoFit/>
+          </a:bodyPr>
+          <a:lstStyle/>
+          <a:p>
+            <a:pPr algn="l"/>
+            <a:r>
+              <a:rPr sz="1200" b="1" i="0">
+                <a:solidFill>
+                  <a:srgbClr val="F2711C"/>
+                </a:solidFill>
+                <a:latin typeface="Calibri"/>
+              </a:rPr>
+              <a:t>MODELO E EQUAÇÕES</a:t>
+            </a:r>
+          </a:p>
+        </p:txBody>
+      </p:sp>
+      <p:sp>
+        <p:nvSpPr>
+          <p:cNvPr id="3" name="Título"/>
+          <p:cNvSpPr txBox="1"/>
+          <p:nvPr/>
+        </p:nvSpPr>
+        <p:spPr>
+          <a:xfrm>
+            <a:off x="548640" y="566928"/>
+            <a:ext cx="11064240" cy="731520"/>
+          </a:xfrm>
+          <a:prstGeom prst="rect">
+            <a:avLst/>
+          </a:prstGeom>
+          <a:noFill/>
+        </p:spPr>
+        <p:txBody>
+          <a:bodyPr wrap="square" lIns="0" tIns="0" rIns="0" bIns="0" anchor="t">
+            <a:spAutoFit/>
+          </a:bodyPr>
+          <a:lstStyle/>
+          <a:p>
+            <a:pPr algn="l"/>
+            <a:r>
+              <a:rPr sz="3600" b="1" i="0">
+                <a:solidFill>
+                  <a:srgbClr val="14171F"/>
+                </a:solidFill>
+                <a:latin typeface="Calibri"/>
+              </a:rPr>
+              <a:t>O modelo: dois estoques de energia</a:t>
+            </a:r>
+          </a:p>
+        </p:txBody>
+      </p:sp>
+      <p:pic>
+        <p:nvPicPr>
+          <p:cNvPr id="4" name="Diagrama de estoques e fluxos" descr="diagrama_estoques_fluxos.png"/>
+          <p:cNvPicPr>
+            <a:picLocks noChangeAspect="1"/>
+          </p:cNvPicPr>
+          <p:nvPr/>
+        </p:nvPicPr>
+        <p:blipFill>
+          <a:blip r:embed="rId3"/>
+          <a:stretch>
+            <a:fillRect/>
+          </a:stretch>
+        </p:blipFill>
+        <p:spPr>
+          <a:xfrm>
+            <a:off x="411480" y="1417320"/>
+            <a:ext cx="7223760" cy="4714454"/>
+          </a:xfrm>
+          <a:prstGeom prst="rect">
+            <a:avLst/>
+          </a:prstGeom>
+        </p:spPr>
+      </p:pic>
+      <p:sp>
+        <p:nvSpPr>
+          <p:cNvPr id="5" name="Cartão das hipóteses"/>
+          <p:cNvSpPr/>
+          <p:nvPr/>
+        </p:nvSpPr>
+        <p:spPr>
+          <a:xfrm>
+            <a:off x="8001000" y="1508760"/>
+            <a:ext cx="3611880" cy="4754880"/>
+          </a:xfrm>
+          <a:prstGeom prst="roundRect">
+            <a:avLst>
+              <a:gd name="adj" fmla="val 8000"/>
+            </a:avLst>
+          </a:prstGeom>
+          <a:solidFill>
+            <a:srgbClr val="F6F7F9"/>
+          </a:solidFill>
+          <a:ln>
+            <a:noFill/>
+          </a:ln>
+          <a:effectLst>
+            <a:outerShdw blurRad="190500" dist="38100" dir="5400000" algn="t" rotWithShape="0">
+              <a:srgbClr val="000000">
+                <a:alpha val="14000"/>
+              </a:srgbClr>
+            </a:outerShdw>
+          </a:effectLst>
+        </p:spPr>
+        <p:style>
+          <a:lnRef idx="1">
+            <a:schemeClr val="accent1"/>
+          </a:lnRef>
+          <a:fillRef idx="3">
+            <a:schemeClr val="accent1"/>
+          </a:fillRef>
+          <a:effectRef idx="2">
+            <a:schemeClr val="accent1"/>
+          </a:effectRef>
+          <a:fontRef idx="minor">
+            <a:schemeClr val="lt1"/>
+          </a:fontRef>
+        </p:style>
+        <p:txBody>
+          <a:bodyPr rtlCol="0" anchor="ctr"/>
+          <a:lstStyle/>
+          <a:p>
+            <a:pPr algn="ctr"/>
+            <a:endParaRPr/>
+          </a:p>
+        </p:txBody>
+      </p:sp>
+      <p:sp>
+        <p:nvSpPr>
+          <p:cNvPr id="6" name="TextBox 5"/>
+          <p:cNvSpPr txBox="1"/>
+          <p:nvPr/>
+        </p:nvSpPr>
+        <p:spPr>
+          <a:xfrm>
+            <a:off x="8321040" y="1783080"/>
+            <a:ext cx="3108960" cy="365760"/>
+          </a:xfrm>
+          <a:prstGeom prst="rect">
+            <a:avLst/>
+          </a:prstGeom>
+          <a:noFill/>
+        </p:spPr>
+        <p:txBody>
+          <a:bodyPr wrap="square" lIns="0" tIns="0" rIns="0" bIns="0" anchor="t">
+            <a:spAutoFit/>
+          </a:bodyPr>
+          <a:lstStyle/>
+          <a:p>
+            <a:pPr algn="l"/>
+            <a:r>
+              <a:rPr sz="2000" b="1" i="0">
+                <a:solidFill>
+                  <a:srgbClr val="14171F"/>
+                </a:solidFill>
+                <a:latin typeface="Calibri"/>
+              </a:rPr>
+              <a:t>Hipóteses</a:t>
+            </a:r>
+          </a:p>
+        </p:txBody>
+      </p:sp>
+      <p:sp>
+        <p:nvSpPr>
+          <p:cNvPr id="7" name="Marcador 1"/>
+          <p:cNvSpPr/>
+          <p:nvPr/>
+        </p:nvSpPr>
+        <p:spPr>
+          <a:xfrm>
+            <a:off x="8321040" y="2450592"/>
+            <a:ext cx="146304" cy="146304"/>
+          </a:xfrm>
+          <a:prstGeom prst="ellipse">
+            <a:avLst/>
+          </a:prstGeom>
+          <a:solidFill>
+            <a:srgbClr val="F2711C"/>
+          </a:solidFill>
+          <a:ln>
+            <a:noFill/>
+          </a:ln>
+          <a:effectLst/>
+        </p:spPr>
+        <p:style>
+          <a:lnRef idx="1">
+            <a:schemeClr val="accent1"/>
+          </a:lnRef>
+          <a:fillRef idx="3">
+            <a:schemeClr val="accent1"/>
+          </a:fillRef>
+          <a:effectRef idx="2">
+            <a:schemeClr val="accent1"/>
+          </a:effectRef>
+          <a:fontRef idx="minor">
+            <a:schemeClr val="lt1"/>
+          </a:fontRef>
+        </p:style>
+        <p:txBody>
+          <a:bodyPr rtlCol="0" anchor="ctr"/>
+          <a:lstStyle/>
+          <a:p>
+            <a:pPr algn="ctr"/>
+            <a:endParaRPr/>
+          </a:p>
+        </p:txBody>
+      </p:sp>
+      <p:sp>
+        <p:nvSpPr>
+          <p:cNvPr id="8" name="TextBox 7"/>
+          <p:cNvSpPr txBox="1"/>
+          <p:nvPr/>
+        </p:nvSpPr>
+        <p:spPr>
+          <a:xfrm>
+            <a:off x="8613648" y="2377440"/>
+            <a:ext cx="2880360" cy="868680"/>
+          </a:xfrm>
+          <a:prstGeom prst="rect">
+            <a:avLst/>
+          </a:prstGeom>
+          <a:noFill/>
+        </p:spPr>
+        <p:txBody>
+          <a:bodyPr wrap="square" lIns="0" tIns="0" rIns="0" bIns="0" anchor="t">
+            <a:spAutoFit/>
+          </a:bodyPr>
+          <a:lstStyle/>
+          <a:p>
+            <a:pPr algn="l"/>
+            <a:r>
+              <a:rPr sz="1600" b="1" i="0">
+                <a:solidFill>
+                  <a:srgbClr val="14171F"/>
+                </a:solidFill>
+                <a:latin typeface="Calibri"/>
+              </a:rPr>
+              <a:t>Temperatura uniforme</a:t>
+            </a:r>
+          </a:p>
+          <a:p>
+            <a:pPr algn="l">
+              <a:spcBef>
+                <a:spcPts val="100"/>
+              </a:spcBef>
+            </a:pPr>
+            <a:r>
+              <a:rPr sz="1400" b="0" i="0">
+                <a:solidFill>
+                  <a:srgbClr val="5B6170"/>
+                </a:solidFill>
+                <a:latin typeface="Calibri"/>
+              </a:rPr>
+              <a:t>na panela (Tp) e na água (Ta)</a:t>
+            </a:r>
+          </a:p>
+        </p:txBody>
+      </p:sp>
+      <p:sp>
+        <p:nvSpPr>
+          <p:cNvPr id="9" name="Marcador 2"/>
+          <p:cNvSpPr/>
+          <p:nvPr/>
+        </p:nvSpPr>
+        <p:spPr>
+          <a:xfrm>
+            <a:off x="8321040" y="3383280"/>
+            <a:ext cx="146304" cy="146304"/>
+          </a:xfrm>
+          <a:prstGeom prst="ellipse">
+            <a:avLst/>
+          </a:prstGeom>
+          <a:solidFill>
+            <a:srgbClr val="F2711C"/>
+          </a:solidFill>
+          <a:ln>
+            <a:noFill/>
+          </a:ln>
+          <a:effectLst/>
+        </p:spPr>
+        <p:style>
+          <a:lnRef idx="1">
+            <a:schemeClr val="accent1"/>
+          </a:lnRef>
+          <a:fillRef idx="3">
+            <a:schemeClr val="accent1"/>
+          </a:fillRef>
+          <a:effectRef idx="2">
+            <a:schemeClr val="accent1"/>
+          </a:effectRef>
+          <a:fontRef idx="minor">
+            <a:schemeClr val="lt1"/>
+          </a:fontRef>
+        </p:style>
+        <p:txBody>
+          <a:bodyPr rtlCol="0" anchor="ctr"/>
+          <a:lstStyle/>
+          <a:p>
+            <a:pPr algn="ctr"/>
+            <a:endParaRPr/>
+          </a:p>
+        </p:txBody>
+      </p:sp>
+      <p:sp>
+        <p:nvSpPr>
+          <p:cNvPr id="10" name="TextBox 9"/>
+          <p:cNvSpPr txBox="1"/>
+          <p:nvPr/>
+        </p:nvSpPr>
+        <p:spPr>
+          <a:xfrm>
+            <a:off x="8613648" y="3310128"/>
+            <a:ext cx="2880360" cy="868680"/>
+          </a:xfrm>
+          <a:prstGeom prst="rect">
+            <a:avLst/>
+          </a:prstGeom>
+          <a:noFill/>
+        </p:spPr>
+        <p:txBody>
+          <a:bodyPr wrap="square" lIns="0" tIns="0" rIns="0" bIns="0" anchor="t">
+            <a:spAutoFit/>
+          </a:bodyPr>
+          <a:lstStyle/>
+          <a:p>
+            <a:pPr algn="l"/>
+            <a:r>
+              <a:rPr sz="1600" b="1" i="0">
+                <a:solidFill>
+                  <a:srgbClr val="14171F"/>
+                </a:solidFill>
+                <a:latin typeface="Calibri"/>
+              </a:rPr>
+              <a:t>Sem convecção na água</a:t>
+            </a:r>
+          </a:p>
+          <a:p>
+            <a:pPr algn="l">
+              <a:spcBef>
+                <a:spcPts val="100"/>
+              </a:spcBef>
+            </a:pPr>
+            <a:r>
+              <a:rPr sz="1400" b="0" i="0">
+                <a:solidFill>
+                  <a:srgbClr val="5B6170"/>
+                </a:solidFill>
+                <a:latin typeface="Calibri"/>
+              </a:rPr>
+              <a:t>calor passa por condução na parede</a:t>
+            </a:r>
+          </a:p>
+        </p:txBody>
+      </p:sp>
+      <p:sp>
+        <p:nvSpPr>
+          <p:cNvPr id="11" name="Marcador 3"/>
+          <p:cNvSpPr/>
+          <p:nvPr/>
+        </p:nvSpPr>
+        <p:spPr>
+          <a:xfrm>
+            <a:off x="8321040" y="4315968"/>
+            <a:ext cx="146304" cy="146304"/>
+          </a:xfrm>
+          <a:prstGeom prst="ellipse">
+            <a:avLst/>
+          </a:prstGeom>
+          <a:solidFill>
+            <a:srgbClr val="F2711C"/>
+          </a:solidFill>
+          <a:ln>
+            <a:noFill/>
+          </a:ln>
+          <a:effectLst/>
+        </p:spPr>
+        <p:style>
+          <a:lnRef idx="1">
+            <a:schemeClr val="accent1"/>
+          </a:lnRef>
+          <a:fillRef idx="3">
+            <a:schemeClr val="accent1"/>
+          </a:fillRef>
+          <a:effectRef idx="2">
+            <a:schemeClr val="accent1"/>
+          </a:effectRef>
+          <a:fontRef idx="minor">
+            <a:schemeClr val="lt1"/>
+          </a:fontRef>
+        </p:style>
+        <p:txBody>
+          <a:bodyPr rtlCol="0" anchor="ctr"/>
+          <a:lstStyle/>
+          <a:p>
+            <a:pPr algn="ctr"/>
+            <a:endParaRPr/>
+          </a:p>
+        </p:txBody>
+      </p:sp>
+      <p:sp>
+        <p:nvSpPr>
+          <p:cNvPr id="12" name="TextBox 11"/>
+          <p:cNvSpPr txBox="1"/>
+          <p:nvPr/>
+        </p:nvSpPr>
+        <p:spPr>
+          <a:xfrm>
+            <a:off x="8613648" y="4242816"/>
+            <a:ext cx="2880360" cy="868680"/>
+          </a:xfrm>
+          <a:prstGeom prst="rect">
+            <a:avLst/>
+          </a:prstGeom>
+          <a:noFill/>
+        </p:spPr>
+        <p:txBody>
+          <a:bodyPr wrap="square" lIns="0" tIns="0" rIns="0" bIns="0" anchor="t">
+            <a:spAutoFit/>
+          </a:bodyPr>
+          <a:lstStyle/>
+          <a:p>
+            <a:pPr algn="l"/>
+            <a:r>
+              <a:rPr sz="1600" b="1" i="0">
+                <a:solidFill>
+                  <a:srgbClr val="14171F"/>
+                </a:solidFill>
+                <a:latin typeface="Calibri"/>
+              </a:rPr>
+              <a:t>Fundo não perde calor</a:t>
+            </a:r>
+          </a:p>
+          <a:p>
+            <a:pPr algn="l">
+              <a:spcBef>
+                <a:spcPts val="100"/>
+              </a:spcBef>
+            </a:pPr>
+            <a:r>
+              <a:rPr sz="1400" b="0" i="0">
+                <a:solidFill>
+                  <a:srgbClr val="5B6170"/>
+                </a:solidFill>
+                <a:latin typeface="Calibri"/>
+              </a:rPr>
+              <a:t>apoiado no fogão</a:t>
+            </a:r>
+          </a:p>
+        </p:txBody>
+      </p:sp>
+      <p:sp>
+        <p:nvSpPr>
+          <p:cNvPr id="13" name="Marcador 4"/>
+          <p:cNvSpPr/>
+          <p:nvPr/>
+        </p:nvSpPr>
+        <p:spPr>
+          <a:xfrm>
+            <a:off x="8321040" y="5248656"/>
+            <a:ext cx="146304" cy="146304"/>
+          </a:xfrm>
+          <a:prstGeom prst="ellipse">
+            <a:avLst/>
+          </a:prstGeom>
+          <a:solidFill>
+            <a:srgbClr val="F2711C"/>
+          </a:solidFill>
+          <a:ln>
+            <a:noFill/>
+          </a:ln>
+          <a:effectLst/>
+        </p:spPr>
+        <p:style>
+          <a:lnRef idx="1">
+            <a:schemeClr val="accent1"/>
+          </a:lnRef>
+          <a:fillRef idx="3">
+            <a:schemeClr val="accent1"/>
+          </a:fillRef>
+          <a:effectRef idx="2">
+            <a:schemeClr val="accent1"/>
+          </a:effectRef>
+          <a:fontRef idx="minor">
+            <a:schemeClr val="lt1"/>
+          </a:fontRef>
+        </p:style>
+        <p:txBody>
+          <a:bodyPr rtlCol="0" anchor="ctr"/>
+          <a:lstStyle/>
+          <a:p>
+            <a:pPr algn="ctr"/>
+            <a:endParaRPr/>
+          </a:p>
+        </p:txBody>
+      </p:sp>
+      <p:sp>
+        <p:nvSpPr>
+          <p:cNvPr id="14" name="TextBox 13"/>
+          <p:cNvSpPr txBox="1"/>
+          <p:nvPr/>
+        </p:nvSpPr>
+        <p:spPr>
+          <a:xfrm>
+            <a:off x="8613648" y="5175504"/>
+            <a:ext cx="2880360" cy="868680"/>
+          </a:xfrm>
+          <a:prstGeom prst="rect">
+            <a:avLst/>
+          </a:prstGeom>
+          <a:noFill/>
+        </p:spPr>
+        <p:txBody>
+          <a:bodyPr wrap="square" lIns="0" tIns="0" rIns="0" bIns="0" anchor="t">
+            <a:spAutoFit/>
+          </a:bodyPr>
+          <a:lstStyle/>
+          <a:p>
+            <a:pPr algn="l"/>
+            <a:r>
+              <a:rPr sz="1600" b="1" i="0">
+                <a:solidFill>
+                  <a:srgbClr val="14171F"/>
+                </a:solidFill>
+                <a:latin typeface="Calibri"/>
+              </a:rPr>
+              <a:t>Sem radiação e evaporação</a:t>
+            </a:r>
+          </a:p>
+          <a:p>
+            <a:pPr algn="l">
+              <a:spcBef>
+                <a:spcPts val="100"/>
+              </a:spcBef>
+            </a:pPr>
+            <a:r>
+              <a:rPr sz="1400" b="0" i="0">
+                <a:solidFill>
+                  <a:srgbClr val="5B6170"/>
+                </a:solidFill>
+                <a:latin typeface="Calibri"/>
+              </a:rPr>
+              <a:t>como termos separados</a:t>
+            </a:r>
+          </a:p>
+        </p:txBody>
+      </p:sp>
+    </p:spTree>
+  </p:cSld>
+  <p:clrMapOvr>
+    <a:masterClrMapping/>
+  </p:clrMapOvr>
+</p:sld>
+</file>
+
 <file path=ppt/slides/slide5.xml><?xml version="1.0" encoding="utf-8"?>
 <p:sld xmlns:a="http://schemas.openxmlformats.org/drawingml/2006/main" xmlns:r="http://schemas.openxmlformats.org/officeDocument/2006/relationships" xmlns:p="http://schemas.openxmlformats.org/presentationml/2006/main">
   <p:cSld>
@@ -9125,7 +8844,7 @@
       </p:sp>
       <p:sp>
         <p:nvSpPr>
-          <p:cNvPr id="5" name="Medido 1"/>
+          <p:cNvPr id="7" name="Medido 2"/>
           <p:cNvSpPr/>
           <p:nvPr/>
         </p:nvSpPr>
@@ -9178,7 +8897,7 @@
       </p:sp>
       <p:sp>
         <p:nvSpPr>
-          <p:cNvPr id="6" name="TextBox 5"/>
+          <p:cNvPr id="8" name="TextBox 7"/>
           <p:cNvSpPr txBox="1"/>
           <p:nvPr/>
         </p:nvSpPr>
@@ -9206,7 +8925,7 @@
                 </a:solidFill>
                 <a:latin typeface="Calibri"/>
               </a:rPr>
-              <a:t>160 mm</a:t>
+              <a:t>81,2 mm</a:t>
             </a:r>
             <a:r>
               <a:rPr sz="1400" b="0" i="0">
@@ -9215,14 +8934,14 @@
                 </a:solidFill>
                 <a:latin typeface="Calibri"/>
               </a:rPr>
-              <a:t>   diâmetro da panela</a:t>
-            </a:r>
-          </a:p>
-        </p:txBody>
-      </p:sp>
-      <p:sp>
-        <p:nvSpPr>
-          <p:cNvPr id="7" name="Medido 2"/>
+              <a:t>   altura</a:t>
+            </a:r>
+          </a:p>
+        </p:txBody>
+      </p:sp>
+      <p:sp>
+        <p:nvSpPr>
+          <p:cNvPr id="13" name="Medido 5"/>
           <p:cNvSpPr/>
           <p:nvPr/>
         </p:nvSpPr>
@@ -9275,7 +8994,7 @@
       </p:sp>
       <p:sp>
         <p:nvSpPr>
-          <p:cNvPr id="8" name="TextBox 7"/>
+          <p:cNvPr id="14" name="TextBox 13"/>
           <p:cNvSpPr txBox="1"/>
           <p:nvPr/>
         </p:nvSpPr>
@@ -9303,7 +9022,7 @@
                 </a:solidFill>
                 <a:latin typeface="Calibri"/>
               </a:rPr>
-              <a:t>81,2 mm</a:t>
+              <a:t>18,9 °C</a:t>
             </a:r>
             <a:r>
               <a:rPr sz="1400" b="0" i="0">
@@ -9312,21 +9031,56 @@
                 </a:solidFill>
                 <a:latin typeface="Calibri"/>
               </a:rPr>
-              <a:t>   altura</a:t>
-            </a:r>
-          </a:p>
-        </p:txBody>
-      </p:sp>
-      <p:sp>
-        <p:nvSpPr>
-          <p:cNvPr id="9" name="Medido 3"/>
+              <a:t>   temperatura ambiente</a:t>
+            </a:r>
+          </a:p>
+        </p:txBody>
+      </p:sp>
+      <p:sp>
+        <p:nvSpPr>
+          <p:cNvPr id="15" name="TextBox 14"/>
+          <p:cNvSpPr txBox="1"/>
+          <p:nvPr/>
+        </p:nvSpPr>
+        <p:spPr>
+          <a:xfrm>
+            <a:off x="4434840" y="1508760"/>
+            <a:ext cx="3383280" cy="320040"/>
+          </a:xfrm>
+          <a:prstGeom prst="rect">
+            <a:avLst/>
+          </a:prstGeom>
+          <a:noFill/>
+        </p:spPr>
+        <p:txBody>
+          <a:bodyPr wrap="square" lIns="0" tIns="0" rIns="0" bIns="0" anchor="t">
+            <a:spAutoFit/>
+          </a:bodyPr>
+          <a:lstStyle/>
+          <a:p>
+            <a:pPr algn="l"/>
+            <a:r>
+              <a:rPr sz="1300" b="1" i="0">
+                <a:solidFill>
+                  <a:srgbClr val="5B6170"/>
+                </a:solidFill>
+                <a:latin typeface="Calibri"/>
+              </a:rPr>
+              <a:t>CALCULADO</a:t>
+            </a:r>
+          </a:p>
+        </p:txBody>
+      </p:sp>
+      <p:sp>
+        <p:nvSpPr>
+          <p:cNvPr id="16" name="Cartão CALCULADO"/>
           <p:cNvSpPr/>
           <p:nvPr/>
         </p:nvSpPr>
         <p:spPr>
           <a:xfrm>
-            <a:off x="548640" y="3694176"/>
-            <a:ext cx="3337560" cy="749808"/>
+            <a:off x="4434840" y="1920240"/>
+            <a:ext cx="3337560" cy="1636776"/>
           </a:xfrm>
           <a:prstGeom prst="roundRect">
             <a:avLst>
@@ -9372,339 +9126,13 @@
       </p:sp>
       <p:sp>
         <p:nvSpPr>
-          <p:cNvPr id="10" name="TextBox 9"/>
-          <p:cNvSpPr txBox="1"/>
-          <p:nvPr/>
-        </p:nvSpPr>
-        <p:spPr>
-          <a:xfrm>
-            <a:off x="777240" y="3785615"/>
-            <a:ext cx="3017520" cy="594360"/>
-          </a:xfrm>
-          <a:prstGeom prst="rect">
-            <a:avLst/>
-          </a:prstGeom>
-          <a:noFill/>
-        </p:spPr>
-        <p:txBody>
-          <a:bodyPr wrap="square" lIns="0" tIns="0" rIns="0" bIns="0" anchor="ctr">
-            <a:spAutoFit/>
-          </a:bodyPr>
-          <a:lstStyle/>
-          <a:p>
-            <a:pPr algn="l"/>
-            <a:r>
-              <a:rPr sz="2000" b="1" i="0">
-                <a:solidFill>
-                  <a:srgbClr val="1C7ED6"/>
-                </a:solidFill>
-                <a:latin typeface="Calibri"/>
-              </a:rPr>
-              <a:t>0,54 mm</a:t>
-            </a:r>
-            <a:r>
-              <a:rPr sz="1400" b="0" i="0">
-                <a:solidFill>
-                  <a:srgbClr val="5B6170"/>
-                </a:solidFill>
-                <a:latin typeface="Calibri"/>
-              </a:rPr>
-              <a:t>   espessura da parede</a:t>
-            </a:r>
-          </a:p>
-        </p:txBody>
-      </p:sp>
-      <p:sp>
-        <p:nvSpPr>
-          <p:cNvPr id="11" name="Medido 4"/>
-          <p:cNvSpPr/>
-          <p:nvPr/>
-        </p:nvSpPr>
-        <p:spPr>
-          <a:xfrm>
-            <a:off x="548640" y="4581144"/>
-            <a:ext cx="3337560" cy="749808"/>
-          </a:xfrm>
-          <a:prstGeom prst="roundRect">
-            <a:avLst>
-              <a:gd name="adj" fmla="val 8000"/>
-            </a:avLst>
-          </a:prstGeom>
-          <a:solidFill>
-            <a:srgbClr val="FFFFFF"/>
-          </a:solidFill>
-          <a:ln>
-            <a:noFill/>
-          </a:ln>
-          <a:effectLst>
-            <a:outerShdw blurRad="190500" dist="38100" dir="5400000" algn="t" rotWithShape="0">
-              <a:srgbClr val="000000">
-                <a:alpha val="14000"/>
-              </a:srgbClr>
-            </a:outerShdw>
-          </a:effectLst>
-        </p:spPr>
-        <p:style>
-          <a:lnRef idx="1">
-            <a:schemeClr val="accent1"/>
-          </a:lnRef>
-          <a:fillRef idx="3">
-            <a:schemeClr val="accent1"/>
-          </a:fillRef>
-          <a:effectRef idx="2">
-            <a:schemeClr val="accent1"/>
-          </a:effectRef>
-          <a:fontRef idx="minor">
-            <a:schemeClr val="lt1"/>
-          </a:fontRef>
-        </p:style>
-        <p:txBody>
-          <a:bodyPr rtlCol="0" anchor="ctr"/>
-          <a:lstStyle/>
-          <a:p>
-            <a:pPr algn="ctr"/>
-            <a:endParaRPr/>
-          </a:p>
-        </p:txBody>
-      </p:sp>
-      <p:sp>
-        <p:nvSpPr>
-          <p:cNvPr id="12" name="TextBox 11"/>
-          <p:cNvSpPr txBox="1"/>
-          <p:nvPr/>
-        </p:nvSpPr>
-        <p:spPr>
-          <a:xfrm>
-            <a:off x="777240" y="4672583"/>
-            <a:ext cx="3017520" cy="594360"/>
-          </a:xfrm>
-          <a:prstGeom prst="rect">
-            <a:avLst/>
-          </a:prstGeom>
-          <a:noFill/>
-        </p:spPr>
-        <p:txBody>
-          <a:bodyPr wrap="square" lIns="0" tIns="0" rIns="0" bIns="0" anchor="ctr">
-            <a:spAutoFit/>
-          </a:bodyPr>
-          <a:lstStyle/>
-          <a:p>
-            <a:pPr algn="l"/>
-            <a:r>
-              <a:rPr sz="2000" b="1" i="0">
-                <a:solidFill>
-                  <a:srgbClr val="1C7ED6"/>
-                </a:solidFill>
-                <a:latin typeface="Calibri"/>
-              </a:rPr>
-              <a:t>1,123 kg</a:t>
-            </a:r>
-            <a:r>
-              <a:rPr sz="1400" b="0" i="0">
-                <a:solidFill>
-                  <a:srgbClr val="5B6170"/>
-                </a:solidFill>
-                <a:latin typeface="Calibri"/>
-              </a:rPr>
-              <a:t>   massa de água</a:t>
-            </a:r>
-          </a:p>
-        </p:txBody>
-      </p:sp>
-      <p:sp>
-        <p:nvSpPr>
-          <p:cNvPr id="13" name="Medido 5"/>
-          <p:cNvSpPr/>
-          <p:nvPr/>
-        </p:nvSpPr>
-        <p:spPr>
-          <a:xfrm>
-            <a:off x="548640" y="5468112"/>
-            <a:ext cx="3337560" cy="749808"/>
-          </a:xfrm>
-          <a:prstGeom prst="roundRect">
-            <a:avLst>
-              <a:gd name="adj" fmla="val 8000"/>
-            </a:avLst>
-          </a:prstGeom>
-          <a:solidFill>
-            <a:srgbClr val="FFFFFF"/>
-          </a:solidFill>
-          <a:ln>
-            <a:noFill/>
-          </a:ln>
-          <a:effectLst>
-            <a:outerShdw blurRad="190500" dist="38100" dir="5400000" algn="t" rotWithShape="0">
-              <a:srgbClr val="000000">
-                <a:alpha val="14000"/>
-              </a:srgbClr>
-            </a:outerShdw>
-          </a:effectLst>
-        </p:spPr>
-        <p:style>
-          <a:lnRef idx="1">
-            <a:schemeClr val="accent1"/>
-          </a:lnRef>
-          <a:fillRef idx="3">
-            <a:schemeClr val="accent1"/>
-          </a:fillRef>
-          <a:effectRef idx="2">
-            <a:schemeClr val="accent1"/>
-          </a:effectRef>
-          <a:fontRef idx="minor">
-            <a:schemeClr val="lt1"/>
-          </a:fontRef>
-        </p:style>
-        <p:txBody>
-          <a:bodyPr rtlCol="0" anchor="ctr"/>
-          <a:lstStyle/>
-          <a:p>
-            <a:pPr algn="ctr"/>
-            <a:endParaRPr/>
-          </a:p>
-        </p:txBody>
-      </p:sp>
-      <p:sp>
-        <p:nvSpPr>
-          <p:cNvPr id="14" name="TextBox 13"/>
-          <p:cNvSpPr txBox="1"/>
-          <p:nvPr/>
-        </p:nvSpPr>
-        <p:spPr>
-          <a:xfrm>
-            <a:off x="777240" y="5559552"/>
-            <a:ext cx="3017520" cy="594360"/>
-          </a:xfrm>
-          <a:prstGeom prst="rect">
-            <a:avLst/>
-          </a:prstGeom>
-          <a:noFill/>
-        </p:spPr>
-        <p:txBody>
-          <a:bodyPr wrap="square" lIns="0" tIns="0" rIns="0" bIns="0" anchor="ctr">
-            <a:spAutoFit/>
-          </a:bodyPr>
-          <a:lstStyle/>
-          <a:p>
-            <a:pPr algn="l"/>
-            <a:r>
-              <a:rPr sz="2000" b="1" i="0">
-                <a:solidFill>
-                  <a:srgbClr val="1C7ED6"/>
-                </a:solidFill>
-                <a:latin typeface="Calibri"/>
-              </a:rPr>
-              <a:t>18,9 °C</a:t>
-            </a:r>
-            <a:r>
-              <a:rPr sz="1400" b="0" i="0">
-                <a:solidFill>
-                  <a:srgbClr val="5B6170"/>
-                </a:solidFill>
-                <a:latin typeface="Calibri"/>
-              </a:rPr>
-              <a:t>   temperatura ambiente</a:t>
-            </a:r>
-          </a:p>
-        </p:txBody>
-      </p:sp>
-      <p:sp>
-        <p:nvSpPr>
-          <p:cNvPr id="15" name="TextBox 14"/>
-          <p:cNvSpPr txBox="1"/>
-          <p:nvPr/>
-        </p:nvSpPr>
-        <p:spPr>
-          <a:xfrm>
-            <a:off x="4434840" y="1508760"/>
-            <a:ext cx="3383280" cy="320040"/>
-          </a:xfrm>
-          <a:prstGeom prst="rect">
-            <a:avLst/>
-          </a:prstGeom>
-          <a:noFill/>
-        </p:spPr>
-        <p:txBody>
-          <a:bodyPr wrap="square" lIns="0" tIns="0" rIns="0" bIns="0" anchor="t">
-            <a:spAutoFit/>
-          </a:bodyPr>
-          <a:lstStyle/>
-          <a:p>
-            <a:pPr algn="l"/>
-            <a:r>
-              <a:rPr sz="1300" b="1" i="0">
-                <a:solidFill>
-                  <a:srgbClr val="5B6170"/>
-                </a:solidFill>
-                <a:latin typeface="Calibri"/>
-              </a:rPr>
-              <a:t>CALCULADO</a:t>
-            </a:r>
-          </a:p>
-        </p:txBody>
-      </p:sp>
-      <p:sp>
-        <p:nvSpPr>
-          <p:cNvPr id="16" name="Cartão CALCULADO"/>
-          <p:cNvSpPr/>
-          <p:nvPr/>
-        </p:nvSpPr>
-        <p:spPr>
-          <a:xfrm>
-            <a:off x="4434840" y="1920240"/>
-            <a:ext cx="3337560" cy="4297680"/>
-          </a:xfrm>
-          <a:prstGeom prst="roundRect">
-            <a:avLst>
-              <a:gd name="adj" fmla="val 8000"/>
-            </a:avLst>
-          </a:prstGeom>
-          <a:solidFill>
-            <a:srgbClr val="FFFFFF"/>
-          </a:solidFill>
-          <a:ln>
-            <a:noFill/>
-          </a:ln>
-          <a:effectLst>
-            <a:outerShdw blurRad="190500" dist="38100" dir="5400000" algn="t" rotWithShape="0">
-              <a:srgbClr val="000000">
-                <a:alpha val="14000"/>
-              </a:srgbClr>
-            </a:outerShdw>
-          </a:effectLst>
-        </p:spPr>
-        <p:style>
-          <a:lnRef idx="1">
-            <a:schemeClr val="accent1"/>
-          </a:lnRef>
-          <a:fillRef idx="3">
-            <a:schemeClr val="accent1"/>
-          </a:fillRef>
-          <a:effectRef idx="2">
-            <a:schemeClr val="accent1"/>
-          </a:effectRef>
-          <a:fontRef idx="minor">
-            <a:schemeClr val="lt1"/>
-          </a:fontRef>
-        </p:style>
-        <p:txBody>
-          <a:bodyPr rtlCol="0" anchor="ctr"/>
-          <a:lstStyle/>
-          <a:p>
-            <a:pPr algn="ctr"/>
-            <a:endParaRPr/>
-          </a:p>
-        </p:txBody>
-      </p:sp>
-      <p:sp>
-        <p:nvSpPr>
           <p:cNvPr id="17" name="TextBox 16"/>
           <p:cNvSpPr txBox="1"/>
           <p:nvPr/>
         </p:nvSpPr>
         <p:spPr>
           <a:xfrm>
-            <a:off x="4709159" y="2194560"/>
+            <a:off x="4709159" y="2057400"/>
             <a:ext cx="2834640" cy="731520"/>
           </a:xfrm>
           <a:prstGeom prst="rect">
@@ -9739,7 +9167,7 @@
         </p:nvSpPr>
         <p:spPr>
           <a:xfrm>
-            <a:off x="4709159" y="2880360"/>
+            <a:off x="4709159" y="2788920"/>
             <a:ext cx="2834640" cy="365760"/>
           </a:xfrm>
           <a:prstGeom prst="rect">
@@ -9762,123 +9190,6 @@
                 <a:latin typeface="Calibri"/>
               </a:rPr>
               <a:t>massa da panela</a:t>
-            </a:r>
-          </a:p>
-        </p:txBody>
-      </p:sp>
-      <p:sp>
-        <p:nvSpPr>
-          <p:cNvPr id="19" name="TextBox 18"/>
-          <p:cNvSpPr txBox="1"/>
-          <p:nvPr/>
-        </p:nvSpPr>
-        <p:spPr>
-          <a:xfrm>
-            <a:off x="4709159" y="3474720"/>
-            <a:ext cx="2834640" cy="2560320"/>
-          </a:xfrm>
-          <a:prstGeom prst="rect">
-            <a:avLst/>
-          </a:prstGeom>
-          <a:noFill/>
-        </p:spPr>
-        <p:txBody>
-          <a:bodyPr wrap="square" lIns="0" tIns="0" rIns="0" bIns="0" anchor="t">
-            <a:spAutoFit/>
-          </a:bodyPr>
-          <a:lstStyle/>
-          <a:p>
-            <a:pPr algn="l"/>
-            <a:r>
-              <a:rPr sz="1400" b="1" i="0">
-                <a:solidFill>
-                  <a:srgbClr val="14171F"/>
-                </a:solidFill>
-                <a:latin typeface="Calibri"/>
-              </a:rPr>
-              <a:t>Volume de aço</a:t>
-            </a:r>
-          </a:p>
-          <a:p>
-            <a:pPr algn="l">
-              <a:spcBef>
-                <a:spcPts val="600"/>
-              </a:spcBef>
-            </a:pPr>
-            <a:r>
-              <a:rPr sz="1400" b="0" i="0">
-                <a:solidFill>
-                  <a:srgbClr val="5B6170"/>
-                </a:solidFill>
-                <a:latin typeface="Calibri"/>
-              </a:rPr>
-              <a:t>parede lateral + fundo</a:t>
-            </a:r>
-          </a:p>
-          <a:p>
-            <a:pPr algn="l">
-              <a:spcBef>
-                <a:spcPts val="600"/>
-              </a:spcBef>
-            </a:pPr>
-            <a:r>
-              <a:rPr sz="1400" b="1" i="0">
-                <a:solidFill>
-                  <a:srgbClr val="14171F"/>
-                </a:solidFill>
-                <a:latin typeface="Calibri"/>
-              </a:rPr>
-              <a:t>Fundo: </a:t>
-            </a:r>
-            <a:r>
-              <a:rPr sz="1400" b="0" i="0">
-                <a:solidFill>
-                  <a:srgbClr val="5B6170"/>
-                </a:solidFill>
-                <a:latin typeface="Calibri"/>
-              </a:rPr>
-              <a:t>≈ 3,7 mm</a:t>
-            </a:r>
-          </a:p>
-          <a:p>
-            <a:pPr algn="l">
-              <a:spcBef>
-                <a:spcPts val="600"/>
-              </a:spcBef>
-            </a:pPr>
-            <a:r>
-              <a:rPr sz="1400" b="0" i="0">
-                <a:solidFill>
-                  <a:srgbClr val="5B6170"/>
-                </a:solidFill>
-                <a:latin typeface="Calibri"/>
-              </a:rPr>
-              <a:t>(altura externa − profundidade)</a:t>
-            </a:r>
-          </a:p>
-          <a:p>
-            <a:pPr algn="l">
-              <a:spcBef>
-                <a:spcPts val="600"/>
-              </a:spcBef>
-            </a:pPr>
-            <a:r>
-              <a:rPr sz="1400" b="1" i="0">
-                <a:solidFill>
-                  <a:srgbClr val="14171F"/>
-                </a:solidFill>
-                <a:latin typeface="Calibri"/>
-              </a:rPr>
-              <a:t>Densidade do inox: </a:t>
-            </a:r>
-            <a:r>
-              <a:rPr sz="1400" b="0" i="0">
-                <a:solidFill>
-                  <a:srgbClr val="5B6170"/>
-                </a:solidFill>
-                <a:latin typeface="Calibri"/>
-              </a:rPr>
-              <a:t>7900 kg/m³</a:t>
             </a:r>
           </a:p>
         </p:txBody>
@@ -10065,16 +9376,25 @@
           <a:p>
             <a:pPr algn="l"/>
             <a:r>
-              <a:rPr sz="1400" b="1" i="0">
+              <a:rPr sz="1400" b="1" i="0" dirty="0" err="1">
                 <a:solidFill>
                   <a:srgbClr val="14171F"/>
                 </a:solidFill>
                 <a:latin typeface="Calibri"/>
               </a:rPr>
-              <a:t>Ligado: </a:t>
-            </a:r>
-            <a:r>
-              <a:rPr sz="1400" b="0" i="0">
+              <a:t>Ligado</a:t>
+            </a:r>
+            <a:r>
+              <a:rPr sz="1400" b="1" i="0" dirty="0">
+                <a:solidFill>
+                  <a:srgbClr val="14171F"/>
+                </a:solidFill>
+                <a:latin typeface="Calibri"/>
+              </a:rPr>
+              <a:t>: </a:t>
+            </a:r>
+            <a:r>
+              <a:rPr sz="1400" b="0" i="0" dirty="0">
                 <a:solidFill>
                   <a:srgbClr val="5B6170"/>
                 </a:solidFill>
@@ -10090,13 +9410,58 @@
               </a:spcBef>
             </a:pPr>
             <a:r>
-              <a:rPr sz="1400" b="0" i="0">
+              <a:rPr sz="1400" b="0" i="0" dirty="0" err="1">
                 <a:solidFill>
                   <a:srgbClr val="5B6170"/>
                 </a:solidFill>
                 <a:latin typeface="Calibri"/>
               </a:rPr>
-              <a:t>liga e desliga: ligado ≈ 40 % do tempo</a:t>
+              <a:t>liga</a:t>
+            </a:r>
+            <a:r>
+              <a:rPr sz="1400" b="0" i="0" dirty="0">
+                <a:solidFill>
+                  <a:srgbClr val="5B6170"/>
+                </a:solidFill>
+                <a:latin typeface="Calibri"/>
+              </a:rPr>
+              <a:t> e </a:t>
+            </a:r>
+            <a:r>
+              <a:rPr sz="1400" b="0" i="0" dirty="0" err="1">
+                <a:solidFill>
+                  <a:srgbClr val="5B6170"/>
+                </a:solidFill>
+                <a:latin typeface="Calibri"/>
+              </a:rPr>
+              <a:t>desliga</a:t>
+            </a:r>
+            <a:r>
+              <a:rPr sz="1400" b="0" i="0" dirty="0">
+                <a:solidFill>
+                  <a:srgbClr val="5B6170"/>
+                </a:solidFill>
+                <a:latin typeface="Calibri"/>
+              </a:rPr>
+              <a:t>: </a:t>
+            </a:r>
+            <a:r>
+              <a:rPr sz="1400" b="0" i="0" dirty="0" err="1">
+                <a:solidFill>
+                  <a:srgbClr val="5B6170"/>
+                </a:solidFill>
+                <a:latin typeface="Calibri"/>
+              </a:rPr>
+              <a:t>ligado</a:t>
+            </a:r>
+            <a:r>
+              <a:rPr sz="1400" b="0" i="0" dirty="0">
+                <a:solidFill>
+                  <a:srgbClr val="5B6170"/>
+                </a:solidFill>
+                <a:latin typeface="Calibri"/>
+              </a:rPr>
+              <a:t> ≈ 40 % do tempo</a:t>
             </a:r>
           </a:p>
         </p:txBody>
@@ -10183,6 +9548,474 @@
                 <a:latin typeface="Calibri"/>
               </a:rPr>
               <a:t>acima da convecção natural: inclui evaporação e radiação</a:t>
+            </a:r>
+          </a:p>
+        </p:txBody>
+      </p:sp>
+      <p:sp>
+        <p:nvSpPr>
+          <p:cNvPr id="27" name="Item 01"/>
+          <p:cNvSpPr/>
+          <p:nvPr/>
+        </p:nvSpPr>
+        <p:spPr>
+          <a:xfrm>
+            <a:off x="548640" y="3931920"/>
+            <a:ext cx="2286000" cy="2286000"/>
+          </a:xfrm>
+          <a:prstGeom prst="roundRect">
+            <a:avLst>
+              <a:gd name="adj" fmla="val 8000"/>
+            </a:avLst>
+          </a:prstGeom>
+          <a:solidFill>
+            <a:srgbClr val="FFFFFF"/>
+          </a:solidFill>
+          <a:ln>
+            <a:noFill/>
+          </a:ln>
+          <a:effectLst>
+            <a:outerShdw blurRad="190500" dist="38100" dir="5400000" algn="t" rotWithShape="0">
+              <a:srgbClr val="000000">
+                <a:alpha val="14000"/>
+              </a:srgbClr>
+            </a:outerShdw>
+          </a:effectLst>
+        </p:spPr>
+        <p:style>
+          <a:lnRef idx="1">
+            <a:schemeClr val="accent1"/>
+          </a:lnRef>
+          <a:fillRef idx="3">
+            <a:schemeClr val="accent1"/>
+          </a:fillRef>
+          <a:effectRef idx="2">
+            <a:schemeClr val="accent1"/>
+          </a:effectRef>
+          <a:fontRef idx="minor">
+            <a:schemeClr val="lt1"/>
+          </a:fontRef>
+        </p:style>
+        <p:txBody>
+          <a:bodyPr rtlCol="0" anchor="ctr"/>
+          <a:lstStyle/>
+          <a:p>
+            <a:pPr algn="ctr"/>
+            <a:endParaRPr/>
+          </a:p>
+        </p:txBody>
+      </p:sp>
+      <p:sp>
+        <p:nvSpPr>
+          <p:cNvPr id="28" name="Número 01"/>
+          <p:cNvSpPr/>
+          <p:nvPr/>
+        </p:nvSpPr>
+        <p:spPr>
+          <a:xfrm>
+            <a:off x="777240" y="4133087"/>
+            <a:ext cx="457200" cy="457200"/>
+          </a:xfrm>
+          <a:prstGeom prst="ellipse">
+            <a:avLst/>
+          </a:prstGeom>
+          <a:solidFill>
+            <a:srgbClr val="F2711C"/>
+          </a:solidFill>
+          <a:ln>
+            <a:noFill/>
+          </a:ln>
+          <a:effectLst/>
+        </p:spPr>
+        <p:style>
+          <a:lnRef idx="1">
+            <a:schemeClr val="accent1"/>
+          </a:lnRef>
+          <a:fillRef idx="3">
+            <a:schemeClr val="accent1"/>
+          </a:fillRef>
+          <a:effectRef idx="2">
+            <a:schemeClr val="accent1"/>
+          </a:effectRef>
+          <a:fontRef idx="minor">
+            <a:schemeClr val="lt1"/>
+          </a:fontRef>
+        </p:style>
+        <p:txBody>
+          <a:bodyPr lIns="0" tIns="0" rIns="0" bIns="0" rtlCol="0" anchor="ctr"/>
+          <a:lstStyle/>
+          <a:p>
+            <a:pPr algn="ctr"/>
+            <a:r>
+              <a:rPr sz="1400" b="1">
+                <a:solidFill>
+                  <a:srgbClr val="FFFFFF"/>
+                </a:solidFill>
+                <a:latin typeface="Calibri"/>
+              </a:rPr>
+              <a:t>01</a:t>
+            </a:r>
+          </a:p>
+        </p:txBody>
+      </p:sp>
+      <p:sp>
+        <p:nvSpPr>
+          <p:cNvPr id="29" name="TextBox 28"/>
+          <p:cNvSpPr txBox="1"/>
+          <p:nvPr/>
+        </p:nvSpPr>
+        <p:spPr>
+          <a:xfrm>
+            <a:off x="777240" y="4727448"/>
+            <a:ext cx="1874519" cy="1417320"/>
+          </a:xfrm>
+          <a:prstGeom prst="rect">
+            <a:avLst/>
+          </a:prstGeom>
+          <a:noFill/>
+        </p:spPr>
+        <p:txBody>
+          <a:bodyPr wrap="square" lIns="0" tIns="0" rIns="0" bIns="0" anchor="t">
+            <a:spAutoFit/>
+          </a:bodyPr>
+          <a:lstStyle/>
+          <a:p>
+            <a:r>
+              <a:rPr sz="1600" b="1">
+                <a:solidFill>
+                  <a:srgbClr val="14171F"/>
+                </a:solidFill>
+                <a:latin typeface="Calibri"/>
+              </a:rPr>
+              <a:t>Indução</a:t>
+            </a:r>
+          </a:p>
+          <a:p>
+            <a:pPr>
+              <a:spcBef>
+                <a:spcPts val="300"/>
+              </a:spcBef>
+            </a:pPr>
+            <a:r>
+              <a:rPr sz="1300" b="0">
+                <a:solidFill>
+                  <a:srgbClr val="5B6170"/>
+                </a:solidFill>
+                <a:latin typeface="Calibri"/>
+              </a:rPr>
+              <a:t>O campo magnético da bobina esquenta direto o aço da panela.</a:t>
+            </a:r>
+          </a:p>
+        </p:txBody>
+      </p:sp>
+      <p:sp>
+        <p:nvSpPr>
+          <p:cNvPr id="30" name="Item 02"/>
+          <p:cNvSpPr/>
+          <p:nvPr/>
+        </p:nvSpPr>
+        <p:spPr>
+          <a:xfrm>
+            <a:off x="2999232" y="3931920"/>
+            <a:ext cx="2286000" cy="2286000"/>
+          </a:xfrm>
+          <a:prstGeom prst="roundRect">
+            <a:avLst>
+              <a:gd name="adj" fmla="val 8000"/>
+            </a:avLst>
+          </a:prstGeom>
+          <a:solidFill>
+            <a:srgbClr val="FFFFFF"/>
+          </a:solidFill>
+          <a:ln>
+            <a:noFill/>
+          </a:ln>
+          <a:effectLst>
+            <a:outerShdw blurRad="190500" dist="38100" dir="5400000" algn="t" rotWithShape="0">
+              <a:srgbClr val="000000">
+                <a:alpha val="14000"/>
+              </a:srgbClr>
+            </a:outerShdw>
+          </a:effectLst>
+        </p:spPr>
+        <p:style>
+          <a:lnRef idx="1">
+            <a:schemeClr val="accent1"/>
+          </a:lnRef>
+          <a:fillRef idx="3">
+            <a:schemeClr val="accent1"/>
+          </a:fillRef>
+          <a:effectRef idx="2">
+            <a:schemeClr val="accent1"/>
+          </a:effectRef>
+          <a:fontRef idx="minor">
+            <a:schemeClr val="lt1"/>
+          </a:fontRef>
+        </p:style>
+        <p:txBody>
+          <a:bodyPr rtlCol="0" anchor="ctr"/>
+          <a:lstStyle/>
+          <a:p>
+            <a:pPr algn="ctr"/>
+            <a:endParaRPr/>
+          </a:p>
+        </p:txBody>
+      </p:sp>
+      <p:sp>
+        <p:nvSpPr>
+          <p:cNvPr id="31" name="Número 02"/>
+          <p:cNvSpPr/>
+          <p:nvPr/>
+        </p:nvSpPr>
+        <p:spPr>
+          <a:xfrm>
+            <a:off x="3227832" y="4133087"/>
+            <a:ext cx="457200" cy="457200"/>
+          </a:xfrm>
+          <a:prstGeom prst="ellipse">
+            <a:avLst/>
+          </a:prstGeom>
+          <a:solidFill>
+            <a:srgbClr val="F2711C"/>
+          </a:solidFill>
+          <a:ln>
+            <a:noFill/>
+          </a:ln>
+          <a:effectLst/>
+        </p:spPr>
+        <p:style>
+          <a:lnRef idx="1">
+            <a:schemeClr val="accent1"/>
+          </a:lnRef>
+          <a:fillRef idx="3">
+            <a:schemeClr val="accent1"/>
+          </a:fillRef>
+          <a:effectRef idx="2">
+            <a:schemeClr val="accent1"/>
+          </a:effectRef>
+          <a:fontRef idx="minor">
+            <a:schemeClr val="lt1"/>
+          </a:fontRef>
+        </p:style>
+        <p:txBody>
+          <a:bodyPr lIns="0" tIns="0" rIns="0" bIns="0" rtlCol="0" anchor="ctr"/>
+          <a:lstStyle/>
+          <a:p>
+            <a:pPr algn="ctr"/>
+            <a:r>
+              <a:rPr sz="1400" b="1">
+                <a:solidFill>
+                  <a:srgbClr val="FFFFFF"/>
+                </a:solidFill>
+                <a:latin typeface="Calibri"/>
+              </a:rPr>
+              <a:t>02</a:t>
+            </a:r>
+          </a:p>
+        </p:txBody>
+      </p:sp>
+      <p:sp>
+        <p:nvSpPr>
+          <p:cNvPr id="32" name="TextBox 31"/>
+          <p:cNvSpPr txBox="1"/>
+          <p:nvPr/>
+        </p:nvSpPr>
+        <p:spPr>
+          <a:xfrm>
+            <a:off x="3227832" y="4727448"/>
+            <a:ext cx="1874519" cy="1417320"/>
+          </a:xfrm>
+          <a:prstGeom prst="rect">
+            <a:avLst/>
+          </a:prstGeom>
+          <a:noFill/>
+        </p:spPr>
+        <p:txBody>
+          <a:bodyPr wrap="square" lIns="0" tIns="0" rIns="0" bIns="0" anchor="t">
+            <a:spAutoFit/>
+          </a:bodyPr>
+          <a:lstStyle/>
+          <a:p>
+            <a:r>
+              <a:rPr sz="1600" b="1">
+                <a:solidFill>
+                  <a:srgbClr val="14171F"/>
+                </a:solidFill>
+                <a:latin typeface="Calibri"/>
+              </a:rPr>
+              <a:t>Panela sem tampa</a:t>
+            </a:r>
+          </a:p>
+          <a:p>
+            <a:pPr>
+              <a:spcBef>
+                <a:spcPts val="300"/>
+              </a:spcBef>
+            </a:pPr>
+            <a:r>
+              <a:rPr sz="1300" b="0">
+                <a:solidFill>
+                  <a:srgbClr val="5B6170"/>
+                </a:solidFill>
+                <a:latin typeface="Calibri"/>
+              </a:rPr>
+              <a:t>Perde calor para o ar pelas paredes e pela superfície da água.</a:t>
+            </a:r>
+          </a:p>
+        </p:txBody>
+      </p:sp>
+      <p:sp>
+        <p:nvSpPr>
+          <p:cNvPr id="33" name="Item 03"/>
+          <p:cNvSpPr/>
+          <p:nvPr/>
+        </p:nvSpPr>
+        <p:spPr>
+          <a:xfrm>
+            <a:off x="5449824" y="3931920"/>
+            <a:ext cx="2286000" cy="2286000"/>
+          </a:xfrm>
+          <a:prstGeom prst="roundRect">
+            <a:avLst>
+              <a:gd name="adj" fmla="val 8000"/>
+            </a:avLst>
+          </a:prstGeom>
+          <a:solidFill>
+            <a:srgbClr val="FFFFFF"/>
+          </a:solidFill>
+          <a:ln>
+            <a:noFill/>
+          </a:ln>
+          <a:effectLst>
+            <a:outerShdw blurRad="190500" dist="38100" dir="5400000" algn="t" rotWithShape="0">
+              <a:srgbClr val="000000">
+                <a:alpha val="14000"/>
+              </a:srgbClr>
+            </a:outerShdw>
+          </a:effectLst>
+        </p:spPr>
+        <p:style>
+          <a:lnRef idx="1">
+            <a:schemeClr val="accent1"/>
+          </a:lnRef>
+          <a:fillRef idx="3">
+            <a:schemeClr val="accent1"/>
+          </a:fillRef>
+          <a:effectRef idx="2">
+            <a:schemeClr val="accent1"/>
+          </a:effectRef>
+          <a:fontRef idx="minor">
+            <a:schemeClr val="lt1"/>
+          </a:fontRef>
+        </p:style>
+        <p:txBody>
+          <a:bodyPr rtlCol="0" anchor="ctr"/>
+          <a:lstStyle/>
+          <a:p>
+            <a:pPr algn="ctr"/>
+            <a:endParaRPr/>
+          </a:p>
+        </p:txBody>
+      </p:sp>
+      <p:sp>
+        <p:nvSpPr>
+          <p:cNvPr id="34" name="Número 03"/>
+          <p:cNvSpPr/>
+          <p:nvPr/>
+        </p:nvSpPr>
+        <p:spPr>
+          <a:xfrm>
+            <a:off x="5678424" y="4133087"/>
+            <a:ext cx="457200" cy="457200"/>
+          </a:xfrm>
+          <a:prstGeom prst="ellipse">
+            <a:avLst/>
+          </a:prstGeom>
+          <a:solidFill>
+            <a:srgbClr val="F2711C"/>
+          </a:solidFill>
+          <a:ln>
+            <a:noFill/>
+          </a:ln>
+          <a:effectLst/>
+        </p:spPr>
+        <p:style>
+          <a:lnRef idx="1">
+            <a:schemeClr val="accent1"/>
+          </a:lnRef>
+          <a:fillRef idx="3">
+            <a:schemeClr val="accent1"/>
+          </a:fillRef>
+          <a:effectRef idx="2">
+            <a:schemeClr val="accent1"/>
+          </a:effectRef>
+          <a:fontRef idx="minor">
+            <a:schemeClr val="lt1"/>
+          </a:fontRef>
+        </p:style>
+        <p:txBody>
+          <a:bodyPr lIns="0" tIns="0" rIns="0" bIns="0" rtlCol="0" anchor="ctr"/>
+          <a:lstStyle/>
+          <a:p>
+            <a:pPr algn="ctr"/>
+            <a:r>
+              <a:rPr sz="1400" b="1">
+                <a:solidFill>
+                  <a:srgbClr val="FFFFFF"/>
+                </a:solidFill>
+                <a:latin typeface="Calibri"/>
+              </a:rPr>
+              <a:t>03</a:t>
+            </a:r>
+          </a:p>
+        </p:txBody>
+      </p:sp>
+      <p:sp>
+        <p:nvSpPr>
+          <p:cNvPr id="35" name="TextBox 34"/>
+          <p:cNvSpPr txBox="1"/>
+          <p:nvPr/>
+        </p:nvSpPr>
+        <p:spPr>
+          <a:xfrm>
+            <a:off x="5678424" y="4727448"/>
+            <a:ext cx="1874519" cy="1417320"/>
+          </a:xfrm>
+          <a:prstGeom prst="rect">
+            <a:avLst/>
+          </a:prstGeom>
+          <a:noFill/>
+        </p:spPr>
+        <p:txBody>
+          <a:bodyPr wrap="square" lIns="0" tIns="0" rIns="0" bIns="0" anchor="t">
+            <a:spAutoFit/>
+          </a:bodyPr>
+          <a:lstStyle/>
+          <a:p>
+            <a:r>
+              <a:rPr sz="1600" b="1">
+                <a:solidFill>
+                  <a:srgbClr val="14171F"/>
+                </a:solidFill>
+                <a:latin typeface="Calibri"/>
+              </a:rPr>
+              <a:t>Fogão liga e desliga</a:t>
+            </a:r>
+          </a:p>
+          <a:p>
+            <a:pPr>
+              <a:spcBef>
+                <a:spcPts val="300"/>
+              </a:spcBef>
+            </a:pPr>
+            <a:r>
+              <a:rPr sz="1300" b="0">
+                <a:solidFill>
+                  <a:srgbClr val="5B6170"/>
+                </a:solidFill>
+                <a:latin typeface="Calibri"/>
+              </a:rPr>
+              <a:t>No modo 150 °C, a potência que chega à panela é uma média.</a:t>
             </a:r>
           </a:p>
         </p:txBody>
@@ -10316,8 +10149,8 @@
         </p:nvSpPr>
         <p:spPr>
           <a:xfrm>
-            <a:off x="8183879" y="1508760"/>
-            <a:ext cx="3474720" cy="1874519"/>
+            <a:off x="8183879" y="2743200"/>
+            <a:ext cx="3474720" cy="2194560"/>
           </a:xfrm>
           <a:prstGeom prst="roundRect">
             <a:avLst>
@@ -10369,7 +10202,7 @@
         </p:nvSpPr>
         <p:spPr>
           <a:xfrm>
-            <a:off x="8458200" y="1645920"/>
+            <a:off x="8458200" y="2926080"/>
             <a:ext cx="3017520" cy="914400"/>
           </a:xfrm>
           <a:prstGeom prst="rect">
@@ -10385,7 +10218,7 @@
           <a:p>
             <a:pPr algn="l"/>
             <a:r>
-              <a:rPr sz="5400" b="1" i="0">
+              <a:rPr sz="5400" b="1" i="0" dirty="0">
                 <a:solidFill>
                   <a:srgbClr val="F2711C"/>
                 </a:solidFill>
@@ -10404,8 +10237,8 @@
         </p:nvSpPr>
         <p:spPr>
           <a:xfrm>
-            <a:off x="8458200" y="2651760"/>
-            <a:ext cx="3017520" cy="640080"/>
+            <a:off x="8458200" y="3950208"/>
+            <a:ext cx="3017520" cy="215444"/>
           </a:xfrm>
           <a:prstGeom prst="rect">
             <a:avLst/>
@@ -10420,132 +10253,38 @@
           <a:p>
             <a:pPr algn="l"/>
             <a:r>
-              <a:rPr sz="1400" b="1" i="0">
+              <a:rPr sz="1400" b="1" i="0" dirty="0" err="1">
                 <a:solidFill>
                   <a:srgbClr val="14171F"/>
                 </a:solidFill>
                 <a:latin typeface="Calibri"/>
               </a:rPr>
-              <a:t>erro percentual médio</a:t>
-            </a:r>
-          </a:p>
-          <a:p>
-            <a:pPr algn="l">
-              <a:spcBef>
-                <a:spcPts val="100"/>
-              </a:spcBef>
-            </a:pPr>
-            <a:r>
-              <a:rPr sz="1400" b="0" i="0">
-                <a:solidFill>
-                  <a:srgbClr val="5B6170"/>
+              <a:t>erro</a:t>
+            </a:r>
+            <a:r>
+              <a:rPr sz="1400" b="1" i="0" dirty="0">
+                <a:solidFill>
+                  <a:srgbClr val="14171F"/>
                 </a:solidFill>
                 <a:latin typeface="Calibri"/>
               </a:rPr>
-              <a:t>máximo: 6,8 % (aos 11 min)</a:t>
-            </a:r>
-          </a:p>
-        </p:txBody>
-      </p:sp>
-      <p:sp>
-        <p:nvSpPr>
-          <p:cNvPr id="8" name="TextBox 7"/>
-          <p:cNvSpPr txBox="1"/>
-          <p:nvPr/>
-        </p:nvSpPr>
-        <p:spPr>
-          <a:xfrm>
-            <a:off x="8183879" y="3749039"/>
-            <a:ext cx="3474720" cy="1188720"/>
-          </a:xfrm>
-          <a:prstGeom prst="rect">
-            <a:avLst/>
-          </a:prstGeom>
-          <a:noFill/>
-        </p:spPr>
-        <p:txBody>
-          <a:bodyPr wrap="square" lIns="0" tIns="0" rIns="0" bIns="0" anchor="t">
-            <a:spAutoFit/>
-          </a:bodyPr>
-          <a:lstStyle/>
-          <a:p>
-            <a:pPr algn="l"/>
-            <a:r>
-              <a:rPr sz="1400" b="1" i="0">
+              <a:t> percentual </a:t>
+            </a:r>
+            <a:r>
+              <a:rPr sz="1400" b="1" i="0" dirty="0" err="1">
                 <a:solidFill>
                   <a:srgbClr val="14171F"/>
                 </a:solidFill>
                 <a:latin typeface="Calibri"/>
               </a:rPr>
-              <a:t>Equilíbrio térmico</a:t>
-            </a:r>
-          </a:p>
-          <a:p>
-            <a:pPr algn="l">
-              <a:spcBef>
-                <a:spcPts val="300"/>
-              </a:spcBef>
-            </a:pPr>
-            <a:r>
-              <a:rPr sz="1400" b="0" i="0">
-                <a:solidFill>
-                  <a:srgbClr val="5B6170"/>
-                </a:solidFill>
-                <a:latin typeface="Calibri"/>
-              </a:rPr>
-              <a:t>a água para de esquentar perto de 65 °C (aos 89 min: 64,5 °C no modelo × 65,9 °C medido)</a:t>
-            </a:r>
-          </a:p>
-        </p:txBody>
-      </p:sp>
-      <p:sp>
-        <p:nvSpPr>
-          <p:cNvPr id="9" name="TextBox 8"/>
-          <p:cNvSpPr txBox="1"/>
-          <p:nvPr/>
-        </p:nvSpPr>
-        <p:spPr>
-          <a:xfrm>
-            <a:off x="8183879" y="4800600"/>
-            <a:ext cx="3474720" cy="1097280"/>
-          </a:xfrm>
-          <a:prstGeom prst="rect">
-            <a:avLst/>
-          </a:prstGeom>
-          <a:noFill/>
-        </p:spPr>
-        <p:txBody>
-          <a:bodyPr wrap="square" lIns="0" tIns="0" rIns="0" bIns="0" anchor="t">
-            <a:spAutoFit/>
-          </a:bodyPr>
-          <a:lstStyle/>
-          <a:p>
-            <a:pPr algn="l"/>
-            <a:r>
-              <a:rPr sz="1400" b="1" i="0">
-                <a:solidFill>
-                  <a:srgbClr val="14171F"/>
-                </a:solidFill>
-                <a:latin typeface="Calibri"/>
-              </a:rPr>
-              <a:t>Tempo corrigido</a:t>
-            </a:r>
-          </a:p>
-          <a:p>
-            <a:pPr algn="l">
-              <a:spcBef>
-                <a:spcPts val="300"/>
-              </a:spcBef>
-            </a:pPr>
-            <a:r>
-              <a:rPr sz="1400" b="0" i="0">
-                <a:solidFill>
-                  <a:srgbClr val="5B6170"/>
-                </a:solidFill>
-                <a:latin typeface="Calibri"/>
-              </a:rPr>
-              <a:t>o cronômetro começou 7 min antes do aquecimento</a:t>
-            </a:r>
+              <a:t>médio</a:t>
+            </a:r>
+            <a:endParaRPr sz="1400" b="1" i="0" dirty="0">
+              <a:solidFill>
+                <a:srgbClr val="14171F"/>
+              </a:solidFill>
+              <a:latin typeface="Calibri"/>
+            </a:endParaRPr>
           </a:p>
         </p:txBody>
       </p:sp>
@@ -10863,7 +10602,7 @@
         </p:nvSpPr>
         <p:spPr>
           <a:xfrm>
-            <a:off x="8183879" y="1554480"/>
+            <a:off x="8183879" y="2240280"/>
             <a:ext cx="3474720" cy="365760"/>
           </a:xfrm>
           <a:prstGeom prst="rect">
@@ -10898,7 +10637,7 @@
         </p:nvSpPr>
         <p:spPr>
           <a:xfrm>
-            <a:off x="8183879" y="2103120"/>
+            <a:off x="8183879" y="2788920"/>
             <a:ext cx="3474720" cy="804672"/>
           </a:xfrm>
           <a:prstGeom prst="roundRect">
@@ -10951,7 +10690,7 @@
         </p:nvSpPr>
         <p:spPr>
           <a:xfrm>
-            <a:off x="8412480" y="2212848"/>
+            <a:off x="8412480" y="2898648"/>
             <a:ext cx="3108960" cy="640080"/>
           </a:xfrm>
           <a:prstGeom prst="rect">
@@ -10998,7 +10737,7 @@
         </p:nvSpPr>
         <p:spPr>
           <a:xfrm>
-            <a:off x="8183879" y="3063239"/>
+            <a:off x="8183879" y="3749039"/>
             <a:ext cx="3474720" cy="804672"/>
           </a:xfrm>
           <a:prstGeom prst="roundRect">
@@ -11051,7 +10790,7 @@
         </p:nvSpPr>
         <p:spPr>
           <a:xfrm>
-            <a:off x="8412480" y="3172968"/>
+            <a:off x="8412480" y="3858768"/>
             <a:ext cx="3108960" cy="640080"/>
           </a:xfrm>
           <a:prstGeom prst="rect">
@@ -11098,7 +10837,7 @@
         </p:nvSpPr>
         <p:spPr>
           <a:xfrm>
-            <a:off x="8183879" y="4023360"/>
+            <a:off x="8183879" y="4709160"/>
             <a:ext cx="3474720" cy="804672"/>
           </a:xfrm>
           <a:prstGeom prst="roundRect">
@@ -11151,7 +10890,7 @@
         </p:nvSpPr>
         <p:spPr>
           <a:xfrm>
-            <a:off x="8412480" y="4133088"/>
+            <a:off x="8412480" y="4818888"/>
             <a:ext cx="3108960" cy="640080"/>
           </a:xfrm>
           <a:prstGeom prst="rect">
@@ -11186,50 +10925,6 @@
                 <a:latin typeface="Calibri"/>
               </a:rPr>
               <a:t>4,4 min</a:t>
-            </a:r>
-          </a:p>
-        </p:txBody>
-      </p:sp>
-      <p:sp>
-        <p:nvSpPr>
-          <p:cNvPr id="14" name="TextBox 13"/>
-          <p:cNvSpPr txBox="1"/>
-          <p:nvPr/>
-        </p:nvSpPr>
-        <p:spPr>
-          <a:xfrm>
-            <a:off x="8183879" y="5074920"/>
-            <a:ext cx="3474720" cy="1280160"/>
-          </a:xfrm>
-          <a:prstGeom prst="rect">
-            <a:avLst/>
-          </a:prstGeom>
-          <a:noFill/>
-        </p:spPr>
-        <p:txBody>
-          <a:bodyPr wrap="square" lIns="0" tIns="0" rIns="0" bIns="0" anchor="t">
-            <a:spAutoFit/>
-          </a:bodyPr>
-          <a:lstStyle/>
-          <a:p>
-            <a:pPr algn="l"/>
-            <a:r>
-              <a:rPr sz="1500" b="1" i="0">
-                <a:solidFill>
-                  <a:srgbClr val="14171F"/>
-                </a:solidFill>
-                <a:latin typeface="Calibri"/>
-              </a:rPr>
-              <a:t>Acima de ~2000 W, </a:t>
-            </a:r>
-            <a:r>
-              <a:rPr sz="1500" b="0" i="0">
-                <a:solidFill>
-                  <a:srgbClr val="5B6170"/>
-                </a:solidFill>
-                <a:latin typeface="Calibri"/>
-              </a:rPr>
-              <a:t>dobrar a potência economiza menos de 2 min.</a:t>
             </a:r>
           </a:p>
         </p:txBody>
@@ -11624,7 +11319,7 @@
         </p:nvSpPr>
         <p:spPr>
           <a:xfrm>
-            <a:off x="548640" y="2011680"/>
+            <a:off x="548640" y="2651760"/>
             <a:ext cx="3474720" cy="1005840"/>
           </a:xfrm>
           <a:prstGeom prst="rect">
@@ -11640,7 +11335,7 @@
           <a:p>
             <a:pPr algn="l"/>
             <a:r>
-              <a:rPr sz="5400" b="1" i="0">
+              <a:rPr sz="5400" b="1" i="0" dirty="0">
                 <a:solidFill>
                   <a:srgbClr val="F2711C"/>
                 </a:solidFill>
@@ -11659,7 +11354,7 @@
         </p:nvSpPr>
         <p:spPr>
           <a:xfrm>
-            <a:off x="548640" y="3063240"/>
+            <a:off x="548640" y="3703320"/>
             <a:ext cx="3291840" cy="1097280"/>
           </a:xfrm>
           <a:prstGeom prst="rect">
@@ -11675,13 +11370,130 @@
           <a:p>
             <a:pPr algn="l"/>
             <a:r>
-              <a:rPr sz="1700" b="0" i="0">
+              <a:rPr sz="1700" b="0" i="0" dirty="0" err="1">
                 <a:solidFill>
                   <a:srgbClr val="FFFFFF"/>
                 </a:solidFill>
                 <a:latin typeface="Calibri"/>
               </a:rPr>
-              <a:t>potência média mínima para 1,1 kg de água ferver em até 2 h</a:t>
+              <a:t>potência</a:t>
+            </a:r>
+            <a:r>
+              <a:rPr sz="1700" b="0" i="0" dirty="0">
+                <a:solidFill>
+                  <a:srgbClr val="FFFFFF"/>
+                </a:solidFill>
+                <a:latin typeface="Calibri"/>
+              </a:rPr>
+              <a:t> </a:t>
+            </a:r>
+            <a:r>
+              <a:rPr sz="1700" b="0" i="0" dirty="0" err="1">
+                <a:solidFill>
+                  <a:srgbClr val="FFFFFF"/>
+                </a:solidFill>
+                <a:latin typeface="Calibri"/>
+              </a:rPr>
+              <a:t>média</a:t>
+            </a:r>
+            <a:r>
+              <a:rPr sz="1700" b="0" i="0" dirty="0">
+                <a:solidFill>
+                  <a:srgbClr val="FFFFFF"/>
+                </a:solidFill>
+                <a:latin typeface="Calibri"/>
+              </a:rPr>
+              <a:t> </a:t>
+            </a:r>
+            <a:r>
+              <a:rPr sz="1700" b="0" i="0" dirty="0" err="1">
+                <a:solidFill>
+                  <a:srgbClr val="FFFFFF"/>
+                </a:solidFill>
+                <a:latin typeface="Calibri"/>
+              </a:rPr>
+              <a:t>mínima</a:t>
+            </a:r>
+            <a:r>
+              <a:rPr sz="1700" b="0" i="0" dirty="0">
+                <a:solidFill>
+                  <a:srgbClr val="FFFFFF"/>
+                </a:solidFill>
+                <a:latin typeface="Calibri"/>
+              </a:rPr>
+              <a:t> para 1,1 kg de </a:t>
+            </a:r>
+            <a:r>
+              <a:rPr sz="1700" b="0" i="0" dirty="0" err="1">
+                <a:solidFill>
+                  <a:srgbClr val="FFFFFF"/>
+                </a:solidFill>
+                <a:latin typeface="Calibri"/>
+              </a:rPr>
+              <a:t>água</a:t>
+            </a:r>
+            <a:r>
+              <a:rPr sz="1700" b="0" i="0" dirty="0">
+                <a:solidFill>
+                  <a:srgbClr val="FFFFFF"/>
+                </a:solidFill>
+                <a:latin typeface="Calibri"/>
+              </a:rPr>
+              <a:t> </a:t>
+            </a:r>
+            <a:r>
+              <a:rPr sz="1700" b="0" i="0" dirty="0" err="1">
+                <a:solidFill>
+                  <a:srgbClr val="FFFFFF"/>
+                </a:solidFill>
+                <a:latin typeface="Calibri"/>
+              </a:rPr>
+              <a:t>ferver</a:t>
+            </a:r>
+            <a:r>
+              <a:rPr sz="1700" b="0" i="0" dirty="0">
+                <a:solidFill>
+                  <a:srgbClr val="FFFFFF"/>
+                </a:solidFill>
+                <a:latin typeface="Calibri"/>
+              </a:rPr>
+              <a:t> </a:t>
+            </a:r>
+            <a:r>
+              <a:rPr sz="1700" b="0" i="0" dirty="0" err="1">
+                <a:solidFill>
+                  <a:srgbClr val="FFFFFF"/>
+                </a:solidFill>
+                <a:latin typeface="Calibri"/>
+              </a:rPr>
+              <a:t>em</a:t>
+            </a:r>
+            <a:r>
+              <a:rPr sz="1700" b="0" i="0" dirty="0">
+                <a:solidFill>
+                  <a:srgbClr val="FFFFFF"/>
+                </a:solidFill>
+                <a:latin typeface="Calibri"/>
+              </a:rPr>
+              <a:t> </a:t>
+            </a:r>
+            <a:r>
+              <a:rPr sz="1700" b="0" i="0" dirty="0" err="1">
+                <a:solidFill>
+                  <a:srgbClr val="FFFFFF"/>
+                </a:solidFill>
+                <a:latin typeface="Calibri"/>
+              </a:rPr>
+              <a:t>até</a:t>
+            </a:r>
+            <a:r>
+              <a:rPr sz="1700" b="0" i="0" dirty="0">
+                <a:solidFill>
+                  <a:srgbClr val="FFFFFF"/>
+                </a:solidFill>
+                <a:latin typeface="Calibri"/>
+              </a:rPr>
+              <a:t> 2 h</a:t>
             </a:r>
           </a:p>
         </p:txBody>
@@ -11694,7 +11506,7 @@
         </p:nvSpPr>
         <p:spPr>
           <a:xfrm>
-            <a:off x="4297679" y="2011680"/>
+            <a:off x="4297679" y="2651760"/>
             <a:ext cx="3474720" cy="1005840"/>
           </a:xfrm>
           <a:prstGeom prst="rect">
@@ -11729,7 +11541,7 @@
         </p:nvSpPr>
         <p:spPr>
           <a:xfrm>
-            <a:off x="4297679" y="3063240"/>
+            <a:off x="4297679" y="3703320"/>
             <a:ext cx="3291840" cy="1097280"/>
           </a:xfrm>
           <a:prstGeom prst="rect">
@@ -11764,7 +11576,7 @@
         </p:nvSpPr>
         <p:spPr>
           <a:xfrm>
-            <a:off x="8046719" y="2011680"/>
+            <a:off x="8046719" y="2651760"/>
             <a:ext cx="3474720" cy="1005840"/>
           </a:xfrm>
           <a:prstGeom prst="rect">
@@ -11799,7 +11611,7 @@
         </p:nvSpPr>
         <p:spPr>
           <a:xfrm>
-            <a:off x="8046719" y="3063240"/>
+            <a:off x="8046719" y="3703320"/>
             <a:ext cx="3291840" cy="1097280"/>
           </a:xfrm>
           <a:prstGeom prst="rect">
@@ -11822,50 +11634,6 @@
                 <a:latin typeface="Calibri"/>
               </a:rPr>
               <a:t>erro médio entre o modelo e o experimento</a:t>
-            </a:r>
-          </a:p>
-        </p:txBody>
-      </p:sp>
-      <p:sp>
-        <p:nvSpPr>
-          <p:cNvPr id="14" name="TextBox 13"/>
-          <p:cNvSpPr txBox="1"/>
-          <p:nvPr/>
-        </p:nvSpPr>
-        <p:spPr>
-          <a:xfrm>
-            <a:off x="548640" y="4846320"/>
-            <a:ext cx="8778240" cy="1097280"/>
-          </a:xfrm>
-          <a:prstGeom prst="rect">
-            <a:avLst/>
-          </a:prstGeom>
-          <a:noFill/>
-        </p:spPr>
-        <p:txBody>
-          <a:bodyPr wrap="square" lIns="0" tIns="0" rIns="0" bIns="0" anchor="t">
-            <a:spAutoFit/>
-          </a:bodyPr>
-          <a:lstStyle/>
-          <a:p>
-            <a:pPr algn="l"/>
-            <a:r>
-              <a:rPr sz="1500" b="1" i="0">
-                <a:solidFill>
-                  <a:srgbClr val="FFFFFF"/>
-                </a:solidFill>
-                <a:latin typeface="Calibri"/>
-              </a:rPr>
-              <a:t>Limitações: </a:t>
-            </a:r>
-            <a:r>
-              <a:rPr sz="1500" b="0" i="0">
-                <a:solidFill>
-                  <a:srgbClr val="B8BECC"/>
-                </a:solidFill>
-                <a:latin typeface="Calibri"/>
-              </a:rPr>
-              <a:t>evaporação e radiação entram só pelo h do ar ajustado; a potência média foi ajustada aos dados.</a:t>
             </a:r>
           </a:p>
         </p:txBody>

</xml_diff>

<commit_message>
Notebook simplificado com esquema e diagrama; erro de validacao 2,78%
- data_projeto2 modsim.ipynb: adiciona esquema fisico e diagrama de estoques e fluxos
- validacao com a correcao de 7 min do cronometro (erro medio 5,91% -> 2,78%)
- figuras com os nomes do notebook novo (Q1..Q4, P*efi)
- apresentacao atualizada com as figuras e os dados do notebook novo

Co-Authored-By: Claude Opus 5.5 <noreply@anthropic.com>
</commit_message>
<xml_diff>
--- a/Apresentacao_Projeto2_Grupo10.pptx
+++ b/Apresentacao_Projeto2_Grupo10.pptx
@@ -177,274 +177,274 @@
                 <c:formatCode>General</c:formatCode>
                 <c:ptCount val="90"/>
                 <c:pt idx="0">
-                  <c:v>0</c:v>
+                  <c:v>0.0</c:v>
                 </c:pt>
                 <c:pt idx="1">
-                  <c:v>1</c:v>
+                  <c:v>1.0</c:v>
                 </c:pt>
                 <c:pt idx="2">
-                  <c:v>2</c:v>
+                  <c:v>2.0</c:v>
                 </c:pt>
                 <c:pt idx="3">
-                  <c:v>3</c:v>
+                  <c:v>3.0</c:v>
                 </c:pt>
                 <c:pt idx="4">
-                  <c:v>4</c:v>
+                  <c:v>4.0</c:v>
                 </c:pt>
                 <c:pt idx="5">
-                  <c:v>5</c:v>
+                  <c:v>5.0</c:v>
                 </c:pt>
                 <c:pt idx="6">
-                  <c:v>6</c:v>
+                  <c:v>6.0</c:v>
                 </c:pt>
                 <c:pt idx="7">
-                  <c:v>7</c:v>
+                  <c:v>7.0</c:v>
                 </c:pt>
                 <c:pt idx="8">
-                  <c:v>8</c:v>
+                  <c:v>8.0</c:v>
                 </c:pt>
                 <c:pt idx="9">
-                  <c:v>9</c:v>
+                  <c:v>9.0</c:v>
                 </c:pt>
                 <c:pt idx="10">
-                  <c:v>10</c:v>
+                  <c:v>10.0</c:v>
                 </c:pt>
                 <c:pt idx="11">
-                  <c:v>11</c:v>
+                  <c:v>11.0</c:v>
                 </c:pt>
                 <c:pt idx="12">
-                  <c:v>12</c:v>
+                  <c:v>12.0</c:v>
                 </c:pt>
                 <c:pt idx="13">
-                  <c:v>13</c:v>
+                  <c:v>13.0</c:v>
                 </c:pt>
                 <c:pt idx="14">
-                  <c:v>14</c:v>
+                  <c:v>14.0</c:v>
                 </c:pt>
                 <c:pt idx="15">
-                  <c:v>15</c:v>
+                  <c:v>15.0</c:v>
                 </c:pt>
                 <c:pt idx="16">
-                  <c:v>16</c:v>
+                  <c:v>16.0</c:v>
                 </c:pt>
                 <c:pt idx="17">
-                  <c:v>17</c:v>
+                  <c:v>17.0</c:v>
                 </c:pt>
                 <c:pt idx="18">
-                  <c:v>18</c:v>
+                  <c:v>18.0</c:v>
                 </c:pt>
                 <c:pt idx="19">
-                  <c:v>19</c:v>
+                  <c:v>19.0</c:v>
                 </c:pt>
                 <c:pt idx="20">
-                  <c:v>20</c:v>
+                  <c:v>20.0</c:v>
                 </c:pt>
                 <c:pt idx="21">
-                  <c:v>21</c:v>
+                  <c:v>21.0</c:v>
                 </c:pt>
                 <c:pt idx="22">
-                  <c:v>22</c:v>
+                  <c:v>22.0</c:v>
                 </c:pt>
                 <c:pt idx="23">
-                  <c:v>23</c:v>
+                  <c:v>23.0</c:v>
                 </c:pt>
                 <c:pt idx="24">
-                  <c:v>24</c:v>
+                  <c:v>24.0</c:v>
                 </c:pt>
                 <c:pt idx="25">
-                  <c:v>25</c:v>
+                  <c:v>25.0</c:v>
                 </c:pt>
                 <c:pt idx="26">
-                  <c:v>26</c:v>
+                  <c:v>26.0</c:v>
                 </c:pt>
                 <c:pt idx="27">
-                  <c:v>27</c:v>
+                  <c:v>27.0</c:v>
                 </c:pt>
                 <c:pt idx="28">
-                  <c:v>28</c:v>
+                  <c:v>28.0</c:v>
                 </c:pt>
                 <c:pt idx="29">
-                  <c:v>29</c:v>
+                  <c:v>29.0</c:v>
                 </c:pt>
                 <c:pt idx="30">
-                  <c:v>30</c:v>
+                  <c:v>30.0</c:v>
                 </c:pt>
                 <c:pt idx="31">
-                  <c:v>31</c:v>
+                  <c:v>31.0</c:v>
                 </c:pt>
                 <c:pt idx="32">
-                  <c:v>32</c:v>
+                  <c:v>32.0</c:v>
                 </c:pt>
                 <c:pt idx="33">
-                  <c:v>33</c:v>
+                  <c:v>33.0</c:v>
                 </c:pt>
                 <c:pt idx="34">
-                  <c:v>34</c:v>
+                  <c:v>34.0</c:v>
                 </c:pt>
                 <c:pt idx="35">
-                  <c:v>35</c:v>
+                  <c:v>35.0</c:v>
                 </c:pt>
                 <c:pt idx="36">
-                  <c:v>36</c:v>
+                  <c:v>36.0</c:v>
                 </c:pt>
                 <c:pt idx="37">
-                  <c:v>37</c:v>
+                  <c:v>37.0</c:v>
                 </c:pt>
                 <c:pt idx="38">
-                  <c:v>38</c:v>
+                  <c:v>38.0</c:v>
                 </c:pt>
                 <c:pt idx="39">
-                  <c:v>39</c:v>
+                  <c:v>39.0</c:v>
                 </c:pt>
                 <c:pt idx="40">
-                  <c:v>40</c:v>
+                  <c:v>40.0</c:v>
                 </c:pt>
                 <c:pt idx="41">
-                  <c:v>41</c:v>
+                  <c:v>41.0</c:v>
                 </c:pt>
                 <c:pt idx="42">
-                  <c:v>42</c:v>
+                  <c:v>42.0</c:v>
                 </c:pt>
                 <c:pt idx="43">
-                  <c:v>43</c:v>
+                  <c:v>43.0</c:v>
                 </c:pt>
                 <c:pt idx="44">
-                  <c:v>44</c:v>
+                  <c:v>44.0</c:v>
                 </c:pt>
                 <c:pt idx="45">
-                  <c:v>45</c:v>
+                  <c:v>45.0</c:v>
                 </c:pt>
                 <c:pt idx="46">
-                  <c:v>46</c:v>
+                  <c:v>46.0</c:v>
                 </c:pt>
                 <c:pt idx="47">
-                  <c:v>47</c:v>
+                  <c:v>47.0</c:v>
                 </c:pt>
                 <c:pt idx="48">
-                  <c:v>48</c:v>
+                  <c:v>48.0</c:v>
                 </c:pt>
                 <c:pt idx="49">
-                  <c:v>49</c:v>
+                  <c:v>49.0</c:v>
                 </c:pt>
                 <c:pt idx="50">
-                  <c:v>50</c:v>
+                  <c:v>50.0</c:v>
                 </c:pt>
                 <c:pt idx="51">
-                  <c:v>51</c:v>
+                  <c:v>51.0</c:v>
                 </c:pt>
                 <c:pt idx="52">
-                  <c:v>52</c:v>
+                  <c:v>52.0</c:v>
                 </c:pt>
                 <c:pt idx="53">
-                  <c:v>53</c:v>
+                  <c:v>53.0</c:v>
                 </c:pt>
                 <c:pt idx="54">
-                  <c:v>54</c:v>
+                  <c:v>54.0</c:v>
                 </c:pt>
                 <c:pt idx="55">
-                  <c:v>55</c:v>
+                  <c:v>55.0</c:v>
                 </c:pt>
                 <c:pt idx="56">
-                  <c:v>56</c:v>
+                  <c:v>56.0</c:v>
                 </c:pt>
                 <c:pt idx="57">
-                  <c:v>57</c:v>
+                  <c:v>57.0</c:v>
                 </c:pt>
                 <c:pt idx="58">
-                  <c:v>58</c:v>
+                  <c:v>58.0</c:v>
                 </c:pt>
                 <c:pt idx="59">
-                  <c:v>59</c:v>
+                  <c:v>59.0</c:v>
                 </c:pt>
                 <c:pt idx="60">
-                  <c:v>60</c:v>
+                  <c:v>60.0</c:v>
                 </c:pt>
                 <c:pt idx="61">
-                  <c:v>61</c:v>
+                  <c:v>61.0</c:v>
                 </c:pt>
                 <c:pt idx="62">
-                  <c:v>62</c:v>
+                  <c:v>62.0</c:v>
                 </c:pt>
                 <c:pt idx="63">
-                  <c:v>63</c:v>
+                  <c:v>63.0</c:v>
                 </c:pt>
                 <c:pt idx="64">
-                  <c:v>64</c:v>
+                  <c:v>64.0</c:v>
                 </c:pt>
                 <c:pt idx="65">
-                  <c:v>65</c:v>
+                  <c:v>65.0</c:v>
                 </c:pt>
                 <c:pt idx="66">
-                  <c:v>66</c:v>
+                  <c:v>66.0</c:v>
                 </c:pt>
                 <c:pt idx="67">
-                  <c:v>67</c:v>
+                  <c:v>67.0</c:v>
                 </c:pt>
                 <c:pt idx="68">
-                  <c:v>68</c:v>
+                  <c:v>68.0</c:v>
                 </c:pt>
                 <c:pt idx="69">
-                  <c:v>69</c:v>
+                  <c:v>69.0</c:v>
                 </c:pt>
                 <c:pt idx="70">
-                  <c:v>70</c:v>
+                  <c:v>70.0</c:v>
                 </c:pt>
                 <c:pt idx="71">
-                  <c:v>71</c:v>
+                  <c:v>71.0</c:v>
                 </c:pt>
                 <c:pt idx="72">
-                  <c:v>72</c:v>
+                  <c:v>72.0</c:v>
                 </c:pt>
                 <c:pt idx="73">
-                  <c:v>73</c:v>
+                  <c:v>73.0</c:v>
                 </c:pt>
                 <c:pt idx="74">
-                  <c:v>74</c:v>
+                  <c:v>74.0</c:v>
                 </c:pt>
                 <c:pt idx="75">
-                  <c:v>75</c:v>
+                  <c:v>75.0</c:v>
                 </c:pt>
                 <c:pt idx="76">
-                  <c:v>76</c:v>
+                  <c:v>76.0</c:v>
                 </c:pt>
                 <c:pt idx="77">
-                  <c:v>77</c:v>
+                  <c:v>77.0</c:v>
                 </c:pt>
                 <c:pt idx="78">
-                  <c:v>78</c:v>
+                  <c:v>78.0</c:v>
                 </c:pt>
                 <c:pt idx="79">
-                  <c:v>79</c:v>
+                  <c:v>79.0</c:v>
                 </c:pt>
                 <c:pt idx="80">
-                  <c:v>80</c:v>
+                  <c:v>80.0</c:v>
                 </c:pt>
                 <c:pt idx="81">
-                  <c:v>81</c:v>
+                  <c:v>81.0</c:v>
                 </c:pt>
                 <c:pt idx="82">
-                  <c:v>82</c:v>
+                  <c:v>82.0</c:v>
                 </c:pt>
                 <c:pt idx="83">
-                  <c:v>83</c:v>
+                  <c:v>83.0</c:v>
                 </c:pt>
                 <c:pt idx="84">
-                  <c:v>84</c:v>
+                  <c:v>84.0</c:v>
                 </c:pt>
                 <c:pt idx="85">
-                  <c:v>85</c:v>
+                  <c:v>85.0</c:v>
                 </c:pt>
                 <c:pt idx="86">
-                  <c:v>86</c:v>
+                  <c:v>86.0</c:v>
                 </c:pt>
                 <c:pt idx="87">
-                  <c:v>87</c:v>
+                  <c:v>87.0</c:v>
                 </c:pt>
                 <c:pt idx="88">
-                  <c:v>88</c:v>
+                  <c:v>88.0</c:v>
                 </c:pt>
                 <c:pt idx="89">
-                  <c:v>89</c:v>
+                  <c:v>89.0</c:v>
                 </c:pt>
               </c:numCache>
             </c:numRef>
@@ -459,271 +459,271 @@
                   <c:v>20.7</c:v>
                 </c:pt>
                 <c:pt idx="1">
-                  <c:v>22.584751919345155</c:v>
+                  <c:v>22.585475812566685</c:v>
                 </c:pt>
                 <c:pt idx="2">
-                  <c:v>24.393735676856611</c:v>
+                  <c:v>24.3951062284553</c:v>
                 </c:pt>
                 <c:pt idx="3">
-                  <c:v>26.126334866561102</c:v>
+                  <c:v>26.128296165496568</c:v>
                 </c:pt>
                 <c:pt idx="4">
-                  <c:v>27.785774755996922</c:v>
+                  <c:v>27.788274459551868</c:v>
                 </c:pt>
                 <c:pt idx="5">
-                  <c:v>29.375144531293653</c:v>
+                  <c:v>29.378133663993992</c:v>
                 </c:pt>
                 <c:pt idx="6">
-                  <c:v>30.897403028883204</c:v>
+                  <c:v>30.90083579467969</c:v>
                 </c:pt>
                 <c:pt idx="7">
-                  <c:v>32.355383726665764</c:v>
+                  <c:v>32.35921732118952</c:v>
                 </c:pt>
                 <c:pt idx="8">
-                  <c:v>33.75180063538162</c:v>
+                  <c:v>33.75599507572611</c:v>
                 </c:pt>
                 <c:pt idx="9">
-                  <c:v>35.089253593904942</c:v>
+                  <c:v>35.093771559876636</c:v>
                 </c:pt>
                 <c:pt idx="10">
-                  <c:v>36.370232560835348</c:v>
+                  <c:v>36.37503924550296</c:v>
                 </c:pt>
                 <c:pt idx="11">
-                  <c:v>37.597122069345438</c:v>
+                  <c:v>37.602185030326076</c:v>
                 </c:pt>
                 <c:pt idx="12">
-                  <c:v>38.772205947702695</c:v>
+                  <c:v>38.77749496696001</c:v>
                 </c:pt>
                 <c:pt idx="13">
-                  <c:v>39.897671555487385</c:v>
+                  <c:v>39.903158508477446</c:v>
                 </c:pt>
                 <c:pt idx="14">
-                  <c:v>40.975614107100334</c:v>
+                  <c:v>40.98127284003897</c:v>
                 </c:pt>
                 <c:pt idx="15">
-                  <c:v>42.008040307058415</c:v>
+                  <c:v>42.01384651240222</c:v>
                 </c:pt>
                 <c:pt idx="16">
-                  <c:v>42.99687210934524</c:v>
+                  <c:v>43.00280324797232</c:v>
                 </c:pt>
                 <c:pt idx="17">
-                  <c:v>43.943950410782037</c:v>
+                  <c:v>43.94998557109154</c:v>
                 </c:pt>
                 <c:pt idx="18">
-                  <c:v>44.851038197919699</c:v>
+                  <c:v>44.857158015056186</c:v>
                 </c:pt>
                 <c:pt idx="19">
-                  <c:v>45.719824030641206</c:v>
+                  <c:v>45.72601058710477</c:v>
                 </c:pt>
                 <c:pt idx="20">
-                  <c:v>46.551925210459629</c:v>
+                  <c:v>46.55816195925272</c:v>
                 </c:pt>
                 <c:pt idx="21">
-                  <c:v>47.348890777178497</c:v>
+                  <c:v>47.35516244244084</c:v>
                 </c:pt>
                 <c:pt idx="22">
-                  <c:v>48.112204333014319</c:v>
+                  <c:v>48.11849683830918</c:v>
                 </c:pt>
                 <c:pt idx="23">
-                  <c:v>48.8432868192182</c:v>
+                  <c:v>48.849587217387345</c:v>
                 </c:pt>
                 <c:pt idx="24">
-                  <c:v>49.543499254617394</c:v>
+                  <c:v>49.54979565884198</c:v>
                 </c:pt>
                 <c:pt idx="25">
-                  <c:v>50.214145110529238</c:v>
+                  <c:v>50.22042661948687</c:v>
                 </c:pt>
                 <c:pt idx="26">
-                  <c:v>50.856472817353698</c:v>
+                  <c:v>50.862729454025434</c:v>
                 </c:pt>
                 <c:pt idx="27">
-                  <c:v>51.471678117926238</c:v>
+                  <c:v>51.47790078714485</c:v>
                 </c:pt>
                 <c:pt idx="28">
-                  <c:v>52.060906262013276</c:v>
+                  <c:v>52.067086674628335</c:v>
                 </c:pt>
                 <c:pt idx="29">
-                  <c:v>52.625254118018916</c:v>
+                  <c:v>52.63138473272376</c:v>
                 </c:pt>
                 <c:pt idx="30">
-                  <c:v>53.16577223818328</c:v>
+                  <c:v>53.17184625473225</c:v>
                 </c:pt>
                 <c:pt idx="31">
-                  <c:v>53.683466920645309</c:v>
+                  <c:v>53.68947817761515</c:v>
                 </c:pt>
                 <c:pt idx="32">
-                  <c:v>54.179301827534111</c:v>
+                  <c:v>54.18524478442063</c:v>
                 </c:pt>
                 <c:pt idx="33">
-                  <c:v>54.654200041226233</c:v>
+                  <c:v>54.66006975599632</c:v>
                 </c:pt>
                 <c:pt idx="34">
-                  <c:v>55.109045624331372</c:v>
+                  <c:v>55.11483767853565</c:v>
                 </c:pt>
                 <c:pt idx="35">
-                  <c:v>55.544685245075399</c:v>
+                  <c:v>55.550395726155415</c:v>
                 </c:pt>
                 <c:pt idx="36">
-                  <c:v>55.961929933041461</c:v>
+                  <c:v>55.967555406357704</c:v>
                 </c:pt>
                 <c:pt idx="37">
-                  <c:v>56.361556401936845</c:v>
+                  <c:v>56.367093856335785</c:v>
                 </c:pt>
                 <c:pt idx="38">
-                  <c:v>56.744308536699172</c:v>
+                  <c:v>56.749755377479175</c:v>
                 </c:pt>
                 <c:pt idx="39">
-                  <c:v>57.110898931388874</c:v>
+                  <c:v>57.11625293573947</c:v>
                 </c:pt>
                 <c:pt idx="40">
-                  <c:v>57.462009979101033</c:v>
+                  <c:v>57.46726926538757</c:v>
                 </c:pt>
                 <c:pt idx="41">
-                  <c:v>57.798295293480912</c:v>
+                  <c:v>57.80345832371933</c:v>
                 </c:pt>
                 <c:pt idx="42">
-                  <c:v>58.120380920498022</c:v>
+                  <c:v>58.12544644261436</c:v>
                 </c:pt>
                 <c:pt idx="43">
-                  <c:v>58.428866372639277</c:v>
+                  <c:v>58.43383340867081</c:v>
                 </c:pt>
                 <c:pt idx="44">
-                  <c:v>58.724325985756018</c:v>
+                  <c:v>58.72919382702546</c:v>
                 </c:pt>
                 <c:pt idx="45">
-                  <c:v>59.007309741766043</c:v>
+                  <c:v>59.01207789474654</c:v>
                 </c:pt>
                 <c:pt idx="46">
-                  <c:v>59.27834445138437</c:v>
+                  <c:v>59.28301266849482</c:v>
                 </c:pt>
                 <c:pt idx="47">
-                  <c:v>59.537934710747706</c:v>
+                  <c:v>59.54250291696215</c:v>
                 </c:pt>
                 <c:pt idx="48">
-                  <c:v>59.786563685146227</c:v>
+                  <c:v>59.79103200794877</c:v>
                 </c:pt>
                 <c:pt idx="49">
-                  <c:v>60.024694314326368</c:v>
+                  <c:v>60.0290630409615</c:v>
                 </c:pt>
                 <c:pt idx="50">
-                  <c:v>60.252769806221579</c:v>
+                  <c:v>60.257039376064355</c:v>
                 </c:pt>
                 <c:pt idx="51">
-                  <c:v>60.471214803658896</c:v>
+                  <c:v>60.475385805297776</c:v>
                 </c:pt>
                 <c:pt idx="52">
-                  <c:v>60.680435909980979</c:v>
+                  <c:v>60.68450904603286</c:v>
                 </c:pt>
                 <c:pt idx="53">
-                  <c:v>60.880822621438185</c:v>
+                  <c:v>60.88479872857243</c:v>
                 </c:pt>
                 <c:pt idx="54">
-                  <c:v>61.072747990981483</c:v>
+                  <c:v>61.07662798778218</c:v>
                 </c:pt>
                 <c:pt idx="55">
-                  <c:v>61.256569243060632</c:v>
+                  <c:v>61.260354168975425</c:v>
                 </c:pt>
                 <c:pt idx="56">
-                  <c:v>61.432628651264352</c:v>
+                  <c:v>61.43631961045256</c:v>
                 </c:pt>
                 <c:pt idx="57">
-                  <c:v>61.601253894258562</c:v>
+                  <c:v>61.60485207053858</c:v>
                 </c:pt>
                 <c:pt idx="58">
-                  <c:v>61.762758920091649</c:v>
+                  <c:v>61.76626557380605</c:v>
                 </c:pt>
                 <c:pt idx="59">
-                  <c:v>61.917444321622916</c:v>
+                  <c:v>61.9208607591028</c:v>
                 </c:pt>
                 <c:pt idx="60">
-                  <c:v>62.065598121097551</c:v>
+                  <c:v>62.068925715223756</c:v>
                 </c:pt>
                 <c:pt idx="61">
-                  <c:v>62.207496055008782</c:v>
+                  <c:v>62.21073620840695</c:v>
                 </c:pt>
                 <c:pt idx="62">
-                  <c:v>62.343402358645463</c:v>
+                  <c:v>62.3465565296657</c:v>
                 </c:pt>
                 <c:pt idx="63">
-                  <c:v>62.473569963813397</c:v>
+                  <c:v>62.476639626314736</c:v>
                 </c:pt>
                 <c:pt idx="64">
-                  <c:v>62.598241261258593</c:v>
+                  <c:v>62.60122793337413</c:v>
                 </c:pt>
                 <c:pt idx="65">
-                  <c:v>62.717648274397909</c:v>
+                  <c:v>62.72055348842948</c:v>
                 </c:pt>
                 <c:pt idx="66">
-                  <c:v>62.832013340844263</c:v>
+                  <c:v>62.8348386599901</c:v>
                 </c:pt>
                 <c:pt idx="67">
-                  <c:v>62.941549301047807</c:v>
+                  <c:v>62.944296270950055</c:v>
                 </c:pt>
                 <c:pt idx="68">
-                  <c:v>63.046460107110718</c:v>
+                  <c:v>63.049130298216426</c:v>
                 </c:pt>
                 <c:pt idx="69">
-                  <c:v>63.146941029245049</c:v>
+                  <c:v>63.14953605084918</c:v>
                 </c:pt>
                 <c:pt idx="70">
-                  <c:v>63.243179153721705</c:v>
+                  <c:v>63.245700662657434</c:v>
                 </c:pt>
                 <c:pt idx="71">
-                  <c:v>63.335353574990975</c:v>
+                  <c:v>63.33780313741093</c:v>
                 </c:pt>
                 <c:pt idx="72">
-                  <c:v>63.42363592340201</c:v>
+                  <c:v>63.426015078502815</c:v>
                 </c:pt>
                 <c:pt idx="73">
-                  <c:v>63.508190548475262</c:v>
+                  <c:v>63.51050092729485</c:v>
                 </c:pt>
                 <c:pt idx="74">
-                  <c:v>63.589174878298543</c:v>
+                  <c:v>63.591418094104995</c:v>
                 </c:pt>
                 <c:pt idx="75">
-                  <c:v>63.66673960692038</c:v>
+                  <c:v>63.66891718445973</c:v>
                 </c:pt>
                 <c:pt idx="76">
-                  <c:v>63.741029150662548</c:v>
+                  <c:v>63.743142527420375</c:v>
                 </c:pt>
                 <c:pt idx="77">
-                  <c:v>63.812181799755017</c:v>
+                  <c:v>63.81423244918464</c:v>
                 </c:pt>
                 <c:pt idx="78">
-                  <c:v>63.880330027996521</c:v>
+                  <c:v>63.88231961492358</c:v>
                 </c:pt>
                 <c:pt idx="79">
-                  <c:v>63.945600698385313</c:v>
+                  <c:v>63.94753086377993</c:v>
                 </c:pt>
                 <c:pt idx="80">
-                  <c:v>64.008115324415968</c:v>
+                  <c:v>64.0099874671585</c:v>
                 </c:pt>
                 <c:pt idx="81">
-                  <c:v>64.067990231070482</c:v>
+                  <c:v>64.06980576941451</c:v>
                 </c:pt>
                 <c:pt idx="82">
-                  <c:v>64.125336898960228</c:v>
+                  <c:v>64.12709728460867</c:v>
                 </c:pt>
                 <c:pt idx="83">
-                  <c:v>64.180262109359774</c:v>
+                  <c:v>64.18196879715407</c:v>
                 </c:pt>
                 <c:pt idx="84">
-                  <c:v>64.232868107695552</c:v>
+                  <c:v>64.2345225360546</c:v>
                 </c:pt>
                 <c:pt idx="85">
-                  <c:v>64.283252799408416</c:v>
+                  <c:v>64.28485635958772</c:v>
                 </c:pt>
                 <c:pt idx="86">
-                  <c:v>64.331509990073869</c:v>
+                  <c:v>64.33306402478648</c:v>
                 </c:pt>
                 <c:pt idx="87">
-                  <c:v>64.377729515509202</c:v>
+                  <c:v>64.37923534648156</c:v>
                 </c:pt>
                 <c:pt idx="88">
-                  <c:v>64.421997415873491</c:v>
+                  <c:v>64.42345652535612</c:v>
                 </c:pt>
                 <c:pt idx="89">
-                  <c:v>64.464396097525409</c:v>
+                  <c:v>64.46580969783868</c:v>
                 </c:pt>
               </c:numCache>
             </c:numRef>
@@ -775,94 +775,94 @@
                 <c:formatCode>General</c:formatCode>
                 <c:ptCount val="30"/>
                 <c:pt idx="0">
-                  <c:v>2</c:v>
+                  <c:v>2.0</c:v>
                 </c:pt>
                 <c:pt idx="1">
-                  <c:v>5</c:v>
+                  <c:v>5.0</c:v>
                 </c:pt>
                 <c:pt idx="2">
-                  <c:v>8</c:v>
+                  <c:v>8.0</c:v>
                 </c:pt>
                 <c:pt idx="3">
-                  <c:v>11</c:v>
+                  <c:v>11.0</c:v>
                 </c:pt>
                 <c:pt idx="4">
-                  <c:v>14</c:v>
+                  <c:v>14.0</c:v>
                 </c:pt>
                 <c:pt idx="5">
-                  <c:v>17</c:v>
+                  <c:v>17.0</c:v>
                 </c:pt>
                 <c:pt idx="6">
-                  <c:v>20</c:v>
+                  <c:v>20.0</c:v>
                 </c:pt>
                 <c:pt idx="7">
-                  <c:v>23</c:v>
+                  <c:v>23.0</c:v>
                 </c:pt>
                 <c:pt idx="8">
-                  <c:v>26</c:v>
+                  <c:v>26.0</c:v>
                 </c:pt>
                 <c:pt idx="9">
-                  <c:v>29</c:v>
+                  <c:v>29.0</c:v>
                 </c:pt>
                 <c:pt idx="10">
-                  <c:v>32</c:v>
+                  <c:v>32.0</c:v>
                 </c:pt>
                 <c:pt idx="11">
-                  <c:v>35</c:v>
+                  <c:v>35.0</c:v>
                 </c:pt>
                 <c:pt idx="12">
-                  <c:v>38</c:v>
+                  <c:v>38.0</c:v>
                 </c:pt>
                 <c:pt idx="13">
-                  <c:v>41</c:v>
+                  <c:v>41.0</c:v>
                 </c:pt>
                 <c:pt idx="14">
-                  <c:v>44</c:v>
+                  <c:v>44.0</c:v>
                 </c:pt>
                 <c:pt idx="15">
-                  <c:v>47</c:v>
+                  <c:v>47.0</c:v>
                 </c:pt>
                 <c:pt idx="16">
-                  <c:v>50</c:v>
+                  <c:v>50.0</c:v>
                 </c:pt>
                 <c:pt idx="17">
-                  <c:v>53</c:v>
+                  <c:v>53.0</c:v>
                 </c:pt>
                 <c:pt idx="18">
-                  <c:v>56</c:v>
+                  <c:v>56.0</c:v>
                 </c:pt>
                 <c:pt idx="19">
-                  <c:v>59</c:v>
+                  <c:v>59.0</c:v>
                 </c:pt>
                 <c:pt idx="20">
-                  <c:v>62</c:v>
+                  <c:v>62.0</c:v>
                 </c:pt>
                 <c:pt idx="21">
-                  <c:v>65</c:v>
+                  <c:v>65.0</c:v>
                 </c:pt>
                 <c:pt idx="22">
-                  <c:v>68</c:v>
+                  <c:v>68.0</c:v>
                 </c:pt>
                 <c:pt idx="23">
-                  <c:v>71</c:v>
+                  <c:v>71.0</c:v>
                 </c:pt>
                 <c:pt idx="24">
-                  <c:v>74</c:v>
+                  <c:v>74.0</c:v>
                 </c:pt>
                 <c:pt idx="25">
-                  <c:v>77</c:v>
+                  <c:v>77.0</c:v>
                 </c:pt>
                 <c:pt idx="26">
-                  <c:v>80</c:v>
+                  <c:v>80.0</c:v>
                 </c:pt>
                 <c:pt idx="27">
-                  <c:v>83</c:v>
+                  <c:v>83.0</c:v>
                 </c:pt>
                 <c:pt idx="28">
-                  <c:v>86</c:v>
+                  <c:v>86.0</c:v>
                 </c:pt>
                 <c:pt idx="29">
-                  <c:v>89</c:v>
+                  <c:v>89.0</c:v>
                 </c:pt>
               </c:numCache>
             </c:numRef>
@@ -883,16 +883,16 @@
                   <c:v>32.1</c:v>
                 </c:pt>
                 <c:pt idx="3">
-                  <c:v>35.200000000000003</c:v>
+                  <c:v>35.2</c:v>
                 </c:pt>
                 <c:pt idx="4">
-                  <c:v>39</c:v>
+                  <c:v>39.0</c:v>
                 </c:pt>
                 <c:pt idx="5">
                   <c:v>41.2</c:v>
                 </c:pt>
                 <c:pt idx="6">
-                  <c:v>44</c:v>
+                  <c:v>44.0</c:v>
                 </c:pt>
                 <c:pt idx="7">
                   <c:v>47.5</c:v>
@@ -919,7 +919,7 @@
                   <c:v>60.2</c:v>
                 </c:pt>
                 <c:pt idx="15">
-                  <c:v>61</c:v>
+                  <c:v>61.0</c:v>
                 </c:pt>
                 <c:pt idx="16">
                   <c:v>61.7</c:v>
@@ -937,19 +937,19 @@
                   <c:v>63.9</c:v>
                 </c:pt>
                 <c:pt idx="21">
-                  <c:v>64.099999999999994</c:v>
+                  <c:v>64.1</c:v>
                 </c:pt>
                 <c:pt idx="22">
-                  <c:v>64.400000000000006</c:v>
+                  <c:v>64.4</c:v>
                 </c:pt>
                 <c:pt idx="23">
-                  <c:v>64.599999999999994</c:v>
+                  <c:v>64.6</c:v>
                 </c:pt>
                 <c:pt idx="24">
-                  <c:v>64.900000000000006</c:v>
+                  <c:v>64.9</c:v>
                 </c:pt>
                 <c:pt idx="25">
-                  <c:v>65</c:v>
+                  <c:v>65.0</c:v>
                 </c:pt>
                 <c:pt idx="26">
                   <c:v>65.2</c:v>
@@ -961,7 +961,7 @@
                   <c:v>65.7</c:v>
                 </c:pt>
                 <c:pt idx="29">
-                  <c:v>65.900000000000006</c:v>
+                  <c:v>65.9</c:v>
                 </c:pt>
               </c:numCache>
             </c:numRef>
@@ -1210,193 +1210,193 @@
                 <c:formatCode>General</c:formatCode>
                 <c:ptCount val="63"/>
                 <c:pt idx="0">
-                  <c:v>400</c:v>
+                  <c:v>400.0</c:v>
                 </c:pt>
                 <c:pt idx="1">
-                  <c:v>450</c:v>
+                  <c:v>450.0</c:v>
                 </c:pt>
                 <c:pt idx="2">
-                  <c:v>500</c:v>
+                  <c:v>500.0</c:v>
                 </c:pt>
                 <c:pt idx="3">
-                  <c:v>550</c:v>
+                  <c:v>550.0</c:v>
                 </c:pt>
                 <c:pt idx="4">
-                  <c:v>600</c:v>
+                  <c:v>600.0</c:v>
                 </c:pt>
                 <c:pt idx="5">
-                  <c:v>650</c:v>
+                  <c:v>650.0</c:v>
                 </c:pt>
                 <c:pt idx="6">
-                  <c:v>700</c:v>
+                  <c:v>700.0</c:v>
                 </c:pt>
                 <c:pt idx="7">
-                  <c:v>750</c:v>
+                  <c:v>750.0</c:v>
                 </c:pt>
                 <c:pt idx="8">
-                  <c:v>800</c:v>
+                  <c:v>800.0</c:v>
                 </c:pt>
                 <c:pt idx="9">
-                  <c:v>850</c:v>
+                  <c:v>850.0</c:v>
                 </c:pt>
                 <c:pt idx="10">
-                  <c:v>900</c:v>
+                  <c:v>900.0</c:v>
                 </c:pt>
                 <c:pt idx="11">
-                  <c:v>950</c:v>
+                  <c:v>950.0</c:v>
                 </c:pt>
                 <c:pt idx="12">
-                  <c:v>1000</c:v>
+                  <c:v>1000.0</c:v>
                 </c:pt>
                 <c:pt idx="13">
-                  <c:v>1050</c:v>
+                  <c:v>1050.0</c:v>
                 </c:pt>
                 <c:pt idx="14">
-                  <c:v>1100</c:v>
+                  <c:v>1100.0</c:v>
                 </c:pt>
                 <c:pt idx="15">
-                  <c:v>1150</c:v>
+                  <c:v>1150.0</c:v>
                 </c:pt>
                 <c:pt idx="16">
-                  <c:v>1200</c:v>
+                  <c:v>1200.0</c:v>
                 </c:pt>
                 <c:pt idx="17">
-                  <c:v>1250</c:v>
+                  <c:v>1250.0</c:v>
                 </c:pt>
                 <c:pt idx="18">
-                  <c:v>1300</c:v>
+                  <c:v>1300.0</c:v>
                 </c:pt>
                 <c:pt idx="19">
-                  <c:v>1350</c:v>
+                  <c:v>1350.0</c:v>
                 </c:pt>
                 <c:pt idx="20">
-                  <c:v>1400</c:v>
+                  <c:v>1400.0</c:v>
                 </c:pt>
                 <c:pt idx="21">
-                  <c:v>1450</c:v>
+                  <c:v>1450.0</c:v>
                 </c:pt>
                 <c:pt idx="22">
-                  <c:v>1500</c:v>
+                  <c:v>1500.0</c:v>
                 </c:pt>
                 <c:pt idx="23">
-                  <c:v>1550</c:v>
+                  <c:v>1550.0</c:v>
                 </c:pt>
                 <c:pt idx="24">
-                  <c:v>1600</c:v>
+                  <c:v>1600.0</c:v>
                 </c:pt>
                 <c:pt idx="25">
-                  <c:v>1650</c:v>
+                  <c:v>1650.0</c:v>
                 </c:pt>
                 <c:pt idx="26">
-                  <c:v>1700</c:v>
+                  <c:v>1700.0</c:v>
                 </c:pt>
                 <c:pt idx="27">
-                  <c:v>1750</c:v>
+                  <c:v>1750.0</c:v>
                 </c:pt>
                 <c:pt idx="28">
-                  <c:v>1800</c:v>
+                  <c:v>1800.0</c:v>
                 </c:pt>
                 <c:pt idx="29">
-                  <c:v>1850</c:v>
+                  <c:v>1850.0</c:v>
                 </c:pt>
                 <c:pt idx="30">
-                  <c:v>1900</c:v>
+                  <c:v>1900.0</c:v>
                 </c:pt>
                 <c:pt idx="31">
-                  <c:v>1950</c:v>
+                  <c:v>1950.0</c:v>
                 </c:pt>
                 <c:pt idx="32">
-                  <c:v>2000</c:v>
+                  <c:v>2000.0</c:v>
                 </c:pt>
                 <c:pt idx="33">
-                  <c:v>2050</c:v>
+                  <c:v>2050.0</c:v>
                 </c:pt>
                 <c:pt idx="34">
-                  <c:v>2100</c:v>
+                  <c:v>2100.0</c:v>
                 </c:pt>
                 <c:pt idx="35">
-                  <c:v>2150</c:v>
+                  <c:v>2150.0</c:v>
                 </c:pt>
                 <c:pt idx="36">
-                  <c:v>2200</c:v>
+                  <c:v>2200.0</c:v>
                 </c:pt>
                 <c:pt idx="37">
-                  <c:v>2250</c:v>
+                  <c:v>2250.0</c:v>
                 </c:pt>
                 <c:pt idx="38">
-                  <c:v>2300</c:v>
+                  <c:v>2300.0</c:v>
                 </c:pt>
                 <c:pt idx="39">
-                  <c:v>2350</c:v>
+                  <c:v>2350.0</c:v>
                 </c:pt>
                 <c:pt idx="40">
-                  <c:v>2400</c:v>
+                  <c:v>2400.0</c:v>
                 </c:pt>
                 <c:pt idx="41">
-                  <c:v>2450</c:v>
+                  <c:v>2450.0</c:v>
                 </c:pt>
                 <c:pt idx="42">
-                  <c:v>2500</c:v>
+                  <c:v>2500.0</c:v>
                 </c:pt>
                 <c:pt idx="43">
-                  <c:v>2550</c:v>
+                  <c:v>2550.0</c:v>
                 </c:pt>
                 <c:pt idx="44">
-                  <c:v>2600</c:v>
+                  <c:v>2600.0</c:v>
                 </c:pt>
                 <c:pt idx="45">
-                  <c:v>2650</c:v>
+                  <c:v>2650.0</c:v>
                 </c:pt>
                 <c:pt idx="46">
-                  <c:v>2700</c:v>
+                  <c:v>2700.0</c:v>
                 </c:pt>
                 <c:pt idx="47">
-                  <c:v>2750</c:v>
+                  <c:v>2750.0</c:v>
                 </c:pt>
                 <c:pt idx="48">
-                  <c:v>2800</c:v>
+                  <c:v>2800.0</c:v>
                 </c:pt>
                 <c:pt idx="49">
-                  <c:v>2850</c:v>
+                  <c:v>2850.0</c:v>
                 </c:pt>
                 <c:pt idx="50">
-                  <c:v>2900</c:v>
+                  <c:v>2900.0</c:v>
                 </c:pt>
                 <c:pt idx="51">
-                  <c:v>2950</c:v>
+                  <c:v>2950.0</c:v>
                 </c:pt>
                 <c:pt idx="52">
-                  <c:v>3000</c:v>
+                  <c:v>3000.0</c:v>
                 </c:pt>
                 <c:pt idx="53">
-                  <c:v>3050</c:v>
+                  <c:v>3050.0</c:v>
                 </c:pt>
                 <c:pt idx="54">
-                  <c:v>3100</c:v>
+                  <c:v>3100.0</c:v>
                 </c:pt>
                 <c:pt idx="55">
-                  <c:v>3150</c:v>
+                  <c:v>3150.0</c:v>
                 </c:pt>
                 <c:pt idx="56">
-                  <c:v>3200</c:v>
+                  <c:v>3200.0</c:v>
                 </c:pt>
                 <c:pt idx="57">
-                  <c:v>3250</c:v>
+                  <c:v>3250.0</c:v>
                 </c:pt>
                 <c:pt idx="58">
-                  <c:v>3300</c:v>
+                  <c:v>3300.0</c:v>
                 </c:pt>
                 <c:pt idx="59">
-                  <c:v>3350</c:v>
+                  <c:v>3350.0</c:v>
                 </c:pt>
                 <c:pt idx="60">
-                  <c:v>3400</c:v>
+                  <c:v>3400.0</c:v>
                 </c:pt>
                 <c:pt idx="61">
-                  <c:v>3450</c:v>
+                  <c:v>3450.0</c:v>
                 </c:pt>
                 <c:pt idx="62">
-                  <c:v>3500</c:v>
+                  <c:v>3500.0</c:v>
                 </c:pt>
               </c:numCache>
             </c:numRef>
@@ -1408,13 +1408,13 @@
                 <c:formatCode>General</c:formatCode>
                 <c:ptCount val="63"/>
                 <c:pt idx="0">
-                  <c:v>47.133333333333333</c:v>
+                  <c:v>47.11666666666667</c:v>
                 </c:pt>
                 <c:pt idx="1">
-                  <c:v>34.15</c:v>
+                  <c:v>34.13333333333333</c:v>
                 </c:pt>
                 <c:pt idx="2">
-                  <c:v>27.35</c:v>
+                  <c:v>27.333333333333332</c:v>
                 </c:pt>
                 <c:pt idx="3">
                   <c:v>22.966666666666665</c:v>
@@ -1423,13 +1423,13 @@
                   <c:v>19.866666666666667</c:v>
                 </c:pt>
                 <c:pt idx="5">
-                  <c:v>17.55</c:v>
+                  <c:v>17.533333333333335</c:v>
                 </c:pt>
                 <c:pt idx="6">
-                  <c:v>15.733333333333333</c:v>
+                  <c:v>15.716666666666667</c:v>
                 </c:pt>
                 <c:pt idx="7">
-                  <c:v>14.266666666666667</c:v>
+                  <c:v>14.25</c:v>
                 </c:pt>
                 <c:pt idx="8">
                   <c:v>13.05</c:v>
@@ -1444,37 +1444,37 @@
                   <c:v>10.416666666666666</c:v>
                 </c:pt>
                 <c:pt idx="12">
-                  <c:v>9.7666666666666675</c:v>
+                  <c:v>9.766666666666667</c:v>
                 </c:pt>
                 <c:pt idx="13">
-                  <c:v>9.1833333333333336</c:v>
+                  <c:v>9.183333333333334</c:v>
                 </c:pt>
                 <c:pt idx="14">
-                  <c:v>8.6833333333333336</c:v>
+                  <c:v>8.683333333333334</c:v>
                 </c:pt>
                 <c:pt idx="15">
-                  <c:v>8.2333333333333325</c:v>
+                  <c:v>8.216666666666667</c:v>
                 </c:pt>
                 <c:pt idx="16">
-                  <c:v>7.8166666666666664</c:v>
+                  <c:v>7.816666666666666</c:v>
                 </c:pt>
                 <c:pt idx="17">
                   <c:v>7.45</c:v>
                 </c:pt>
                 <c:pt idx="18">
-                  <c:v>7.1166666666666663</c:v>
+                  <c:v>7.1</c:v>
                 </c:pt>
                 <c:pt idx="19">
                   <c:v>6.8</c:v>
                 </c:pt>
                 <c:pt idx="20">
-                  <c:v>6.5166666666666666</c:v>
+                  <c:v>6.516666666666667</c:v>
                 </c:pt>
                 <c:pt idx="21">
-                  <c:v>6.2666666666666666</c:v>
+                  <c:v>6.25</c:v>
                 </c:pt>
                 <c:pt idx="22">
-                  <c:v>6.0166666666666666</c:v>
+                  <c:v>6.016666666666667</c:v>
                 </c:pt>
                 <c:pt idx="23">
                   <c:v>5.8</c:v>
@@ -1486,49 +1486,49 @@
                   <c:v>5.4</c:v>
                 </c:pt>
                 <c:pt idx="26">
-                  <c:v>5.2166666666666668</c:v>
+                  <c:v>5.216666666666667</c:v>
                 </c:pt>
                 <c:pt idx="27">
                   <c:v>5.05</c:v>
                 </c:pt>
                 <c:pt idx="28">
-                  <c:v>4.9000000000000004</c:v>
+                  <c:v>4.9</c:v>
                 </c:pt>
                 <c:pt idx="29">
                   <c:v>4.75</c:v>
                 </c:pt>
                 <c:pt idx="30">
-                  <c:v>4.6166666666666663</c:v>
+                  <c:v>4.616666666666666</c:v>
                 </c:pt>
                 <c:pt idx="31">
-                  <c:v>4.4833333333333334</c:v>
+                  <c:v>4.483333333333333</c:v>
                 </c:pt>
                 <c:pt idx="32">
-                  <c:v>4.3666666666666663</c:v>
+                  <c:v>4.366666666666666</c:v>
                 </c:pt>
                 <c:pt idx="33">
                   <c:v>4.25</c:v>
                 </c:pt>
                 <c:pt idx="34">
-                  <c:v>4.1333333333333337</c:v>
+                  <c:v>4.133333333333334</c:v>
                 </c:pt>
                 <c:pt idx="35">
-                  <c:v>4.0333333333333332</c:v>
+                  <c:v>4.033333333333333</c:v>
                 </c:pt>
                 <c:pt idx="36">
-                  <c:v>3.9333333333333331</c:v>
+                  <c:v>3.933333333333333</c:v>
                 </c:pt>
                 <c:pt idx="37">
                   <c:v>3.8333333333333335</c:v>
                 </c:pt>
                 <c:pt idx="38">
-                  <c:v>3.75</c:v>
+                  <c:v>3.7333333333333334</c:v>
                 </c:pt>
                 <c:pt idx="39">
                   <c:v>3.65</c:v>
                 </c:pt>
                 <c:pt idx="40">
-                  <c:v>3.5666666666666669</c:v>
+                  <c:v>3.566666666666667</c:v>
                 </c:pt>
                 <c:pt idx="41">
                   <c:v>3.5</c:v>
@@ -1540,10 +1540,10 @@
                   <c:v>3.35</c:v>
                 </c:pt>
                 <c:pt idx="44">
-                  <c:v>3.2833333333333332</c:v>
+                  <c:v>3.283333333333333</c:v>
                 </c:pt>
                 <c:pt idx="45">
-                  <c:v>3.2166666666666668</c:v>
+                  <c:v>3.216666666666667</c:v>
                 </c:pt>
                 <c:pt idx="46">
                   <c:v>3.15</c:v>
@@ -1552,10 +1552,10 @@
                   <c:v>3.0833333333333335</c:v>
                 </c:pt>
                 <c:pt idx="48">
-                  <c:v>3.0333333333333332</c:v>
+                  <c:v>3.033333333333333</c:v>
                 </c:pt>
                 <c:pt idx="49">
-                  <c:v>2.9666666666666668</c:v>
+                  <c:v>2.966666666666667</c:v>
                 </c:pt>
                 <c:pt idx="50">
                   <c:v>2.9166666666666665</c:v>
@@ -1564,13 +1564,13 @@
                   <c:v>2.8666666666666667</c:v>
                 </c:pt>
                 <c:pt idx="52">
-                  <c:v>2.8166666666666669</c:v>
+                  <c:v>2.816666666666667</c:v>
                 </c:pt>
                 <c:pt idx="53">
                   <c:v>2.7666666666666666</c:v>
                 </c:pt>
                 <c:pt idx="54">
-                  <c:v>2.7166666666666668</c:v>
+                  <c:v>2.716666666666667</c:v>
                 </c:pt>
                 <c:pt idx="55">
                   <c:v>2.6666666666666665</c:v>
@@ -1582,16 +1582,16 @@
                   <c:v>2.5833333333333335</c:v>
                 </c:pt>
                 <c:pt idx="58">
-                  <c:v>2.5499999999999998</c:v>
+                  <c:v>2.55</c:v>
                 </c:pt>
                 <c:pt idx="59">
                   <c:v>2.5</c:v>
                 </c:pt>
                 <c:pt idx="60">
-                  <c:v>2.4666666666666668</c:v>
+                  <c:v>2.466666666666667</c:v>
                 </c:pt>
                 <c:pt idx="61">
-                  <c:v>2.4333333333333331</c:v>
+                  <c:v>2.433333333333333</c:v>
                 </c:pt>
                 <c:pt idx="62">
                   <c:v>2.3833333333333333</c:v>

</xml_diff>

<commit_message>
Apresentacao corrigida pela rubrica
- Slide 3: equacoes com os nomes do notebook novo (Q1 = P*efi, Q sem ponto) e formulas de R1 a R4
- Slide 5: todos os parametros medidos, calculados, da literatura e ajustados
- Slide 6: justificativa das diferencas na validacao (correcao de 7 min, erro maximo, motivos)
- Slides 7 e 8: mesma mensagem sobre o ganho acima de 2000 W

Co-Authored-By: Claude Opus 5.5 <noreply@anthropic.com>
</commit_message>
<xml_diff>
--- a/Apresentacao_Projeto2_Grupo10.pptx
+++ b/Apresentacao_Projeto2_Grupo10.pptx
@@ -2360,7 +2360,7 @@
           <a:lstStyle/>
           <a:p>
             <a:r>
-              <a:t>Este é o gráfico conclusivo: rodamos o odeint dezenas de vezes, uma para cada potência de 100 a 3500 W. Abaixo de cerca de 400 W a água não ferve em 2 horas, porque as perdas igualam o calor recebido. O tempo cai rápido até uns 1500 W; depois o ganho é pequeno.</a:t>
+              <a:t>Este é o gráfico conclusivo: rodamos o odeint dezenas de vezes, uma para cada potência de 100 a 3500 W. Abaixo de cerca de 400 W a água não ferve em 2 horas, porque as perdas igualam o calor recebido. O tempo cai rápido até uns 2000 W; depois o ganho é cada vez menor: de 2000 para 3500 W só cai de 4,4 para 2,4 min.</a:t>
             </a:r>
           </a:p>
         </p:txBody>
@@ -2430,204 +2430,7 @@
           <a:lstStyle/>
           <a:p>
             <a:r>
-              <a:rPr dirty="0" err="1"/>
-              <a:t>Conclusões</a:t>
-            </a:r>
-            <a:r>
-              <a:rPr dirty="0"/>
-              <a:t>: com a panela </a:t>
-            </a:r>
-            <a:r>
-              <a:rPr dirty="0" err="1"/>
-              <a:t>sem</a:t>
-            </a:r>
-            <a:r>
-              <a:rPr dirty="0"/>
-              <a:t> </a:t>
-            </a:r>
-            <a:r>
-              <a:rPr dirty="0" err="1"/>
-              <a:t>tampa</a:t>
-            </a:r>
-            <a:r>
-              <a:rPr dirty="0"/>
-              <a:t>, </a:t>
-            </a:r>
-            <a:r>
-              <a:rPr dirty="0" err="1"/>
-              <a:t>existe</a:t>
-            </a:r>
-            <a:r>
-              <a:rPr dirty="0"/>
-              <a:t> </a:t>
-            </a:r>
-            <a:r>
-              <a:rPr dirty="0" err="1"/>
-              <a:t>uma</a:t>
-            </a:r>
-            <a:r>
-              <a:rPr dirty="0"/>
-              <a:t> </a:t>
-            </a:r>
-            <a:r>
-              <a:rPr dirty="0" err="1"/>
-              <a:t>potência</a:t>
-            </a:r>
-            <a:r>
-              <a:rPr dirty="0"/>
-              <a:t> </a:t>
-            </a:r>
-            <a:r>
-              <a:rPr dirty="0" err="1"/>
-              <a:t>mínima</a:t>
-            </a:r>
-            <a:r>
-              <a:rPr dirty="0"/>
-              <a:t> para </a:t>
-            </a:r>
-            <a:r>
-              <a:rPr dirty="0" err="1"/>
-              <a:t>ferver</a:t>
-            </a:r>
-            <a:r>
-              <a:rPr dirty="0"/>
-              <a:t>; </a:t>
-            </a:r>
-            <a:r>
-              <a:rPr dirty="0" err="1"/>
-              <a:t>acima</a:t>
-            </a:r>
-            <a:r>
-              <a:rPr dirty="0"/>
-              <a:t> de </a:t>
-            </a:r>
-            <a:r>
-              <a:rPr dirty="0" err="1"/>
-              <a:t>uns</a:t>
-            </a:r>
-            <a:r>
-              <a:rPr dirty="0"/>
-              <a:t> 2000 W, </a:t>
-            </a:r>
-            <a:r>
-              <a:rPr dirty="0" err="1"/>
-              <a:t>aumentar</a:t>
-            </a:r>
-            <a:r>
-              <a:rPr dirty="0"/>
-              <a:t> a </a:t>
-            </a:r>
-            <a:r>
-              <a:rPr dirty="0" err="1"/>
-              <a:t>potência</a:t>
-            </a:r>
-            <a:r>
-              <a:rPr dirty="0"/>
-              <a:t> </a:t>
-            </a:r>
-            <a:r>
-              <a:rPr dirty="0" err="1"/>
-              <a:t>quase</a:t>
-            </a:r>
-            <a:r>
-              <a:rPr dirty="0"/>
-              <a:t> </a:t>
-            </a:r>
-            <a:r>
-              <a:rPr dirty="0" err="1"/>
-              <a:t>não</a:t>
-            </a:r>
-            <a:r>
-              <a:rPr dirty="0"/>
-              <a:t> </a:t>
-            </a:r>
-            <a:r>
-              <a:rPr dirty="0" err="1"/>
-              <a:t>ajuda</a:t>
-            </a:r>
-            <a:r>
-              <a:rPr dirty="0"/>
-              <a:t>. O </a:t>
-            </a:r>
-            <a:r>
-              <a:rPr dirty="0" err="1"/>
-              <a:t>modelo</a:t>
-            </a:r>
-            <a:r>
-              <a:rPr dirty="0"/>
-              <a:t> </a:t>
-            </a:r>
-            <a:r>
-              <a:rPr dirty="0" err="1"/>
-              <a:t>reproduz</a:t>
-            </a:r>
-            <a:r>
-              <a:rPr dirty="0"/>
-              <a:t> o </a:t>
-            </a:r>
-            <a:r>
-              <a:rPr dirty="0" err="1"/>
-              <a:t>experimento</a:t>
-            </a:r>
-            <a:r>
-              <a:rPr dirty="0"/>
-              <a:t> com 2,8 % de </a:t>
-            </a:r>
-            <a:r>
-              <a:rPr dirty="0" err="1"/>
-              <a:t>erro</a:t>
-            </a:r>
-            <a:r>
-              <a:rPr dirty="0"/>
-              <a:t> </a:t>
-            </a:r>
-            <a:r>
-              <a:rPr dirty="0" err="1"/>
-              <a:t>médio</a:t>
-            </a:r>
-            <a:r>
-              <a:rPr dirty="0"/>
-              <a:t>. </a:t>
-            </a:r>
-            <a:r>
-              <a:rPr dirty="0" err="1"/>
-              <a:t>Limitação</a:t>
-            </a:r>
-            <a:r>
-              <a:rPr dirty="0"/>
-              <a:t>: </a:t>
-            </a:r>
-            <a:r>
-              <a:rPr dirty="0" err="1"/>
-              <a:t>evaporação</a:t>
-            </a:r>
-            <a:r>
-              <a:rPr dirty="0"/>
-              <a:t> e </a:t>
-            </a:r>
-            <a:r>
-              <a:rPr dirty="0" err="1"/>
-              <a:t>radiação</a:t>
-            </a:r>
-            <a:r>
-              <a:rPr dirty="0"/>
-              <a:t> </a:t>
-            </a:r>
-            <a:r>
-              <a:rPr dirty="0" err="1"/>
-              <a:t>estão</a:t>
-            </a:r>
-            <a:r>
-              <a:rPr dirty="0"/>
-              <a:t> </a:t>
-            </a:r>
-            <a:r>
-              <a:rPr dirty="0" err="1"/>
-              <a:t>embutidas</a:t>
-            </a:r>
-            <a:r>
-              <a:rPr dirty="0"/>
-              <a:t> no h do ar.</a:t>
+              <a:t>Conclusões: com a panela sem tampa, existe uma potência mínima para ferver; acima de uns 2000 W, aumentar a potência ajuda cada vez menos (de 4,4 para 2,4 min até 3500 W). O modelo reproduz o experimento com 2,8 % de erro médio. Limitação: evaporação e radiação estão embutidas no h do ar.</a:t>
             </a:r>
           </a:p>
         </p:txBody>
@@ -6555,8 +6358,8 @@
         </p:nvSpPr>
         <p:spPr>
           <a:xfrm>
-            <a:off x="548640" y="1554480"/>
-            <a:ext cx="6035040" cy="3337560"/>
+            <a:off x="548640" y="1463040"/>
+            <a:ext cx="6035040" cy="2971800"/>
           </a:xfrm>
           <a:prstGeom prst="roundRect">
             <a:avLst>
@@ -6616,113 +6419,26 @@
         </p:blipFill>
         <p:spPr>
           <a:xfrm>
-            <a:off x="640080" y="1664208"/>
-            <a:ext cx="5852160" cy="3043123"/>
+            <a:off x="928467" y="1572768"/>
+            <a:ext cx="5275384" cy="2743200"/>
           </a:xfrm>
           <a:prstGeom prst="rect">
             <a:avLst/>
           </a:prstGeom>
         </p:spPr>
       </p:pic>
-      <p:sp>
-        <p:nvSpPr>
-          <p:cNvPr id="6" name="TextBox 5"/>
-          <p:cNvSpPr txBox="1"/>
-          <p:nvPr/>
-        </p:nvSpPr>
-        <p:spPr>
-          <a:xfrm>
-            <a:off x="548640" y="5166360"/>
-            <a:ext cx="6035040" cy="1097280"/>
-          </a:xfrm>
-          <a:prstGeom prst="rect">
-            <a:avLst/>
-          </a:prstGeom>
-          <a:noFill/>
-        </p:spPr>
-        <p:txBody>
-          <a:bodyPr wrap="square" lIns="0" tIns="0" rIns="0" bIns="0" anchor="t">
-            <a:spAutoFit/>
-          </a:bodyPr>
-          <a:lstStyle/>
-          <a:p>
-            <a:pPr algn="l"/>
-            <a:r>
-              <a:rPr sz="1500" b="1" i="0">
-                <a:solidFill>
-                  <a:srgbClr val="14171F"/>
-                </a:solidFill>
-                <a:latin typeface="Calibri"/>
-              </a:rPr>
-              <a:t>Resistências: </a:t>
-            </a:r>
-            <a:r>
-              <a:rPr sz="1500" b="0" i="0">
-                <a:solidFill>
-                  <a:srgbClr val="5B6170"/>
-                </a:solidFill>
-                <a:latin typeface="Calibri"/>
-              </a:rPr>
-              <a:t>condução na parede </a:t>
-            </a:r>
-            <a:r>
-              <a:rPr sz="1500" b="0" i="0">
-                <a:solidFill>
-                  <a:srgbClr val="14171F"/>
-                </a:solidFill>
-                <a:latin typeface="Calibri"/>
-              </a:rPr>
-              <a:t>(R₂, R₃)</a:t>
-            </a:r>
-            <a:r>
-              <a:rPr sz="1500" b="0" i="0">
-                <a:solidFill>
-                  <a:srgbClr val="5B6170"/>
-                </a:solidFill>
-                <a:latin typeface="Calibri"/>
-              </a:rPr>
-              <a:t> e convecção no ar </a:t>
-            </a:r>
-            <a:r>
-              <a:rPr sz="1500" b="0" i="0">
-                <a:solidFill>
-                  <a:srgbClr val="14171F"/>
-                </a:solidFill>
-                <a:latin typeface="Calibri"/>
-              </a:rPr>
-              <a:t>(R₁, R₄)</a:t>
-            </a:r>
-          </a:p>
-          <a:p>
-            <a:pPr algn="l">
-              <a:spcBef>
-                <a:spcPts val="400"/>
-              </a:spcBef>
-            </a:pPr>
-            <a:r>
-              <a:rPr sz="1500" b="0" i="0">
-                <a:solidFill>
-                  <a:srgbClr val="5B6170"/>
-                </a:solidFill>
-                <a:latin typeface="Calibri"/>
-              </a:rPr>
-              <a:t>Leis de Fourier e de Newton do resfriamento</a:t>
-            </a:r>
-          </a:p>
-        </p:txBody>
-      </p:sp>
       <mc:AlternateContent xmlns:mc="http://schemas.openxmlformats.org/markup-compatibility/2006" xmlns:a14="http://schemas.microsoft.com/office/drawing/2010/main">
         <mc:Choice Requires="a14">
           <p:sp>
             <p:nvSpPr>
-              <p:cNvPr id="7" name="Equações"/>
+              <p:cNvPr id="6" name="Equações"/>
               <p:cNvSpPr txBox="1"/>
               <p:nvPr/>
             </p:nvSpPr>
             <p:spPr>
               <a:xfrm>
-                <a:off x="7086600" y="1417320"/>
-                <a:ext cx="4663440" cy="4937760"/>
+                <a:off x="7086600" y="1325880"/>
+                <a:ext cx="4663440" cy="5303520"/>
               </a:xfrm>
               <a:prstGeom prst="rect">
                 <a:avLst/>
@@ -6752,7 +6468,7 @@
               <a:p>
                 <a:pPr algn="l">
                   <a:spcBef>
-                    <a:spcPts val="1700"/>
+                    <a:spcPts val="1200"/>
                   </a:spcBef>
                   <a:buNone/>
                 </a:pPr>
@@ -6837,7 +6553,7 @@
                           </a:solidFill>
                           <a:latin typeface="Cambria Math" panose="02040503050406030204" pitchFamily="18" charset="0"/>
                         </a:rPr>
-                        <m:t> = </m:t>
+                        <m:t> = </m:t>
                       </m:r>
                       <m:f>
                         <m:fPr>
@@ -6851,46 +6567,10 @@
                           </m:ctrlPr>
                         </m:fPr>
                         <m:num>
-                          <m:r>
-                            <a:rPr lang="pt-BR" sz="2000" i="0">
-                              <a:solidFill>
-                                <a:srgbClr val="14171F"/>
-                              </a:solidFill>
-                              <a:latin typeface="Cambria Math" panose="02040503050406030204" pitchFamily="18" charset="0"/>
-                            </a:rPr>
-                            <m:t>𝜂</m:t>
-                          </m:r>
-                          <m:r>
-                            <a:rPr lang="pt-BR" sz="2000" i="0">
-                              <a:solidFill>
-                                <a:srgbClr val="14171F"/>
-                              </a:solidFill>
-                              <a:latin typeface="Cambria Math" panose="02040503050406030204" pitchFamily="18" charset="0"/>
-                            </a:rPr>
-                            <m:t>·</m:t>
-                          </m:r>
-                          <m:r>
-                            <a:rPr lang="pt-BR" sz="2000" i="0">
-                              <a:solidFill>
-                                <a:srgbClr val="14171F"/>
-                              </a:solidFill>
-                              <a:latin typeface="Cambria Math" panose="02040503050406030204" pitchFamily="18" charset="0"/>
-                            </a:rPr>
-                            <m:t>𝑃</m:t>
-                          </m:r>
-                          <m:r>
-                            <a:rPr lang="pt-BR" sz="2000" i="0">
-                              <a:solidFill>
-                                <a:srgbClr val="14171F"/>
-                              </a:solidFill>
-                              <a:latin typeface="Cambria Math" panose="02040503050406030204" pitchFamily="18" charset="0"/>
-                            </a:rPr>
-                            <m:t> − </m:t>
-                          </m:r>
                           <m:sSub>
                             <m:sSubPr>
                               <m:ctrlPr>
-                                <a:rPr lang="pt-BR" sz="2000" i="1">
+                                <a:rPr lang="pt-BR" sz="2000" i="0">
                                   <a:solidFill>
                                     <a:srgbClr val="14171F"/>
                                   </a:solidFill>
@@ -6899,30 +6579,58 @@
                               </m:ctrlPr>
                             </m:sSubPr>
                             <m:e>
-                              <m:acc>
-                                <m:accPr>
-                                  <m:chr m:val="̇"/>
-                                  <m:ctrlPr>
-                                    <a:rPr lang="pt-BR" sz="2000" i="0">
-                                      <a:solidFill>
-                                        <a:srgbClr val="14171F"/>
-                                      </a:solidFill>
-                                      <a:latin typeface="Cambria Math" panose="02040503050406030204" pitchFamily="18" charset="0"/>
-                                    </a:rPr>
-                                  </m:ctrlPr>
-                                </m:accPr>
-                                <m:e>
-                                  <m:r>
-                                    <a:rPr lang="pt-BR" sz="2000" i="0">
-                                      <a:solidFill>
-                                        <a:srgbClr val="14171F"/>
-                                      </a:solidFill>
-                                      <a:latin typeface="Cambria Math" panose="02040503050406030204" pitchFamily="18" charset="0"/>
-                                    </a:rPr>
-                                    <m:t>𝑄</m:t>
-                                  </m:r>
-                                </m:e>
-                              </m:acc>
+                              <m:r>
+                                <a:rPr lang="pt-BR" sz="2000" i="0">
+                                  <a:solidFill>
+                                    <a:srgbClr val="14171F"/>
+                                  </a:solidFill>
+                                  <a:latin typeface="Cambria Math" panose="02040503050406030204" pitchFamily="18" charset="0"/>
+                                </a:rPr>
+                                <m:t>𝑄</m:t>
+                              </m:r>
+                            </m:e>
+                            <m:sub>
+                              <m:r>
+                                <a:rPr lang="pt-BR" sz="2000" i="0">
+                                  <a:solidFill>
+                                    <a:srgbClr val="14171F"/>
+                                  </a:solidFill>
+                                  <a:latin typeface="Cambria Math" panose="02040503050406030204" pitchFamily="18" charset="0"/>
+                                </a:rPr>
+                                <m:t>1</m:t>
+                              </m:r>
+                            </m:sub>
+                          </m:sSub>
+                          <m:r>
+                            <a:rPr lang="pt-BR" sz="2000" i="0">
+                              <a:solidFill>
+                                <a:srgbClr val="14171F"/>
+                              </a:solidFill>
+                              <a:latin typeface="Cambria Math" panose="02040503050406030204" pitchFamily="18" charset="0"/>
+                            </a:rPr>
+                            <m:t> − </m:t>
+                          </m:r>
+                          <m:sSub>
+                            <m:sSubPr>
+                              <m:ctrlPr>
+                                <a:rPr lang="pt-BR" sz="2000" i="0">
+                                  <a:solidFill>
+                                    <a:srgbClr val="14171F"/>
+                                  </a:solidFill>
+                                  <a:latin typeface="Cambria Math" panose="02040503050406030204" pitchFamily="18" charset="0"/>
+                                </a:rPr>
+                              </m:ctrlPr>
+                            </m:sSubPr>
+                            <m:e>
+                              <m:r>
+                                <a:rPr lang="pt-BR" sz="2000" i="0">
+                                  <a:solidFill>
+                                    <a:srgbClr val="14171F"/>
+                                  </a:solidFill>
+                                  <a:latin typeface="Cambria Math" panose="02040503050406030204" pitchFamily="18" charset="0"/>
+                                </a:rPr>
+                                <m:t>𝑄</m:t>
+                              </m:r>
                             </m:e>
                             <m:sub>
                               <m:r>
@@ -6943,12 +6651,12 @@
                               </a:solidFill>
                               <a:latin typeface="Cambria Math" panose="02040503050406030204" pitchFamily="18" charset="0"/>
                             </a:rPr>
-                            <m:t> − </m:t>
+                            <m:t> − </m:t>
                           </m:r>
                           <m:sSub>
                             <m:sSubPr>
                               <m:ctrlPr>
-                                <a:rPr lang="pt-BR" sz="2000" i="1">
+                                <a:rPr lang="pt-BR" sz="2000" i="0">
                                   <a:solidFill>
                                     <a:srgbClr val="14171F"/>
                                   </a:solidFill>
@@ -6957,30 +6665,15 @@
                               </m:ctrlPr>
                             </m:sSubPr>
                             <m:e>
-                              <m:acc>
-                                <m:accPr>
-                                  <m:chr m:val="̇"/>
-                                  <m:ctrlPr>
-                                    <a:rPr lang="pt-BR" sz="2000" i="0">
-                                      <a:solidFill>
-                                        <a:srgbClr val="14171F"/>
-                                      </a:solidFill>
-                                      <a:latin typeface="Cambria Math" panose="02040503050406030204" pitchFamily="18" charset="0"/>
-                                    </a:rPr>
-                                  </m:ctrlPr>
-                                </m:accPr>
-                                <m:e>
-                                  <m:r>
-                                    <a:rPr lang="pt-BR" sz="2000" i="0">
-                                      <a:solidFill>
-                                        <a:srgbClr val="14171F"/>
-                                      </a:solidFill>
-                                      <a:latin typeface="Cambria Math" panose="02040503050406030204" pitchFamily="18" charset="0"/>
-                                    </a:rPr>
-                                    <m:t>𝑄</m:t>
-                                  </m:r>
-                                </m:e>
-                              </m:acc>
+                              <m:r>
+                                <a:rPr lang="pt-BR" sz="2000" i="0">
+                                  <a:solidFill>
+                                    <a:srgbClr val="14171F"/>
+                                  </a:solidFill>
+                                  <a:latin typeface="Cambria Math" panose="02040503050406030204" pitchFamily="18" charset="0"/>
+                                </a:rPr>
+                                <m:t>𝑄</m:t>
+                              </m:r>
                             </m:e>
                             <m:sub>
                               <m:r>
@@ -7078,23 +6771,17 @@
                     </m:oMath>
                   </m:oMathPara>
                 </a14:m>
-                <a:endParaRPr lang="pt-BR" sz="1300" b="1">
-                  <a:solidFill>
-                    <a:srgbClr val="F2711C"/>
-                  </a:solidFill>
-                  <a:latin typeface="Calibri"/>
-                </a:endParaRPr>
               </a:p>
               <a:p>
                 <a:pPr>
                   <a:buNone/>
                 </a:pPr>
-                <a:endParaRPr lang="pt-BR" sz="700"/>
+                <a:endParaRPr lang="pt-BR" sz="500"/>
               </a:p>
               <a:p>
                 <a:pPr algn="l">
                   <a:spcBef>
-                    <a:spcPts val="1700"/>
+                    <a:spcPts val="1200"/>
                   </a:spcBef>
                   <a:buNone/>
                 </a:pPr>
@@ -7179,12 +6866,12 @@
                           </a:solidFill>
                           <a:latin typeface="Cambria Math" panose="02040503050406030204" pitchFamily="18" charset="0"/>
                         </a:rPr>
-                        <m:t> = </m:t>
+                        <m:t> = </m:t>
                       </m:r>
                       <m:f>
                         <m:fPr>
                           <m:ctrlPr>
-                            <a:rPr lang="pt-BR" sz="2000" i="1">
+                            <a:rPr lang="pt-BR" sz="2000" i="0">
                               <a:solidFill>
                                 <a:srgbClr val="14171F"/>
                               </a:solidFill>
@@ -7196,7 +6883,7 @@
                           <m:sSub>
                             <m:sSubPr>
                               <m:ctrlPr>
-                                <a:rPr lang="pt-BR" sz="2000" i="1">
+                                <a:rPr lang="pt-BR" sz="2000" i="0">
                                   <a:solidFill>
                                     <a:srgbClr val="14171F"/>
                                   </a:solidFill>
@@ -7205,30 +6892,15 @@
                               </m:ctrlPr>
                             </m:sSubPr>
                             <m:e>
-                              <m:acc>
-                                <m:accPr>
-                                  <m:chr m:val="̇"/>
-                                  <m:ctrlPr>
-                                    <a:rPr lang="pt-BR" sz="2000" i="0">
-                                      <a:solidFill>
-                                        <a:srgbClr val="14171F"/>
-                                      </a:solidFill>
-                                      <a:latin typeface="Cambria Math" panose="02040503050406030204" pitchFamily="18" charset="0"/>
-                                    </a:rPr>
-                                  </m:ctrlPr>
-                                </m:accPr>
-                                <m:e>
-                                  <m:r>
-                                    <a:rPr lang="pt-BR" sz="2000" i="0">
-                                      <a:solidFill>
-                                        <a:srgbClr val="14171F"/>
-                                      </a:solidFill>
-                                      <a:latin typeface="Cambria Math" panose="02040503050406030204" pitchFamily="18" charset="0"/>
-                                    </a:rPr>
-                                    <m:t>𝑄</m:t>
-                                  </m:r>
-                                </m:e>
-                              </m:acc>
+                              <m:r>
+                                <a:rPr lang="pt-BR" sz="2000" i="0">
+                                  <a:solidFill>
+                                    <a:srgbClr val="14171F"/>
+                                  </a:solidFill>
+                                  <a:latin typeface="Cambria Math" panose="02040503050406030204" pitchFamily="18" charset="0"/>
+                                </a:rPr>
+                                <m:t>𝑄</m:t>
+                              </m:r>
                             </m:e>
                             <m:sub>
                               <m:r>
@@ -7249,12 +6921,12 @@
                               </a:solidFill>
                               <a:latin typeface="Cambria Math" panose="02040503050406030204" pitchFamily="18" charset="0"/>
                             </a:rPr>
-                            <m:t> − </m:t>
+                            <m:t> − </m:t>
                           </m:r>
                           <m:sSub>
                             <m:sSubPr>
                               <m:ctrlPr>
-                                <a:rPr lang="pt-BR" sz="2000" i="1">
+                                <a:rPr lang="pt-BR" sz="2000" i="0">
                                   <a:solidFill>
                                     <a:srgbClr val="14171F"/>
                                   </a:solidFill>
@@ -7263,30 +6935,15 @@
                               </m:ctrlPr>
                             </m:sSubPr>
                             <m:e>
-                              <m:acc>
-                                <m:accPr>
-                                  <m:chr m:val="̇"/>
-                                  <m:ctrlPr>
-                                    <a:rPr lang="pt-BR" sz="2000" i="0">
-                                      <a:solidFill>
-                                        <a:srgbClr val="14171F"/>
-                                      </a:solidFill>
-                                      <a:latin typeface="Cambria Math" panose="02040503050406030204" pitchFamily="18" charset="0"/>
-                                    </a:rPr>
-                                  </m:ctrlPr>
-                                </m:accPr>
-                                <m:e>
-                                  <m:r>
-                                    <a:rPr lang="pt-BR" sz="2000" i="0">
-                                      <a:solidFill>
-                                        <a:srgbClr val="14171F"/>
-                                      </a:solidFill>
-                                      <a:latin typeface="Cambria Math" panose="02040503050406030204" pitchFamily="18" charset="0"/>
-                                    </a:rPr>
-                                    <m:t>𝑄</m:t>
-                                  </m:r>
-                                </m:e>
-                              </m:acc>
+                              <m:r>
+                                <a:rPr lang="pt-BR" sz="2000" i="0">
+                                  <a:solidFill>
+                                    <a:srgbClr val="14171F"/>
+                                  </a:solidFill>
+                                  <a:latin typeface="Cambria Math" panose="02040503050406030204" pitchFamily="18" charset="0"/>
+                                </a:rPr>
+                                <m:t>𝑄</m:t>
+                              </m:r>
                             </m:e>
                             <m:sub>
                               <m:r>
@@ -7384,7 +7041,6 @@
                     </m:oMath>
                   </m:oMathPara>
                 </a14:m>
-                <a:endParaRPr lang="pt-BR" sz="700"/>
               </a:p>
               <a:p>
                 <a:pPr algn="l">
@@ -7406,7 +7062,7 @@
               <a:p>
                 <a:pPr algn="l">
                   <a:spcBef>
-                    <a:spcPts val="1700"/>
+                    <a:spcPts val="1200"/>
                   </a:spcBef>
                   <a:buNone/>
                 </a:pPr>
@@ -7419,7 +7075,7 @@
                       <m:sSub>
                         <m:sSubPr>
                           <m:ctrlPr>
-                            <a:rPr lang="pt-BR" sz="2000" i="1">
+                            <a:rPr lang="pt-BR" sz="2000" i="0">
                               <a:solidFill>
                                 <a:srgbClr val="14171F"/>
                               </a:solidFill>
@@ -7428,30 +7084,108 @@
                           </m:ctrlPr>
                         </m:sSubPr>
                         <m:e>
-                          <m:acc>
-                            <m:accPr>
-                              <m:chr m:val="̇"/>
-                              <m:ctrlPr>
-                                <a:rPr lang="pt-BR" sz="2000" i="0">
-                                  <a:solidFill>
-                                    <a:srgbClr val="14171F"/>
-                                  </a:solidFill>
-                                  <a:latin typeface="Cambria Math" panose="02040503050406030204" pitchFamily="18" charset="0"/>
-                                </a:rPr>
-                              </m:ctrlPr>
-                            </m:accPr>
-                            <m:e>
-                              <m:r>
-                                <a:rPr lang="pt-BR" sz="2000" i="0">
-                                  <a:solidFill>
-                                    <a:srgbClr val="14171F"/>
-                                  </a:solidFill>
-                                  <a:latin typeface="Cambria Math" panose="02040503050406030204" pitchFamily="18" charset="0"/>
-                                </a:rPr>
-                                <m:t>𝑄</m:t>
-                              </m:r>
-                            </m:e>
-                          </m:acc>
+                          <m:r>
+                            <a:rPr lang="pt-BR" sz="2000" i="0">
+                              <a:solidFill>
+                                <a:srgbClr val="14171F"/>
+                              </a:solidFill>
+                              <a:latin typeface="Cambria Math" panose="02040503050406030204" pitchFamily="18" charset="0"/>
+                            </a:rPr>
+                            <m:t>𝑄</m:t>
+                          </m:r>
+                        </m:e>
+                        <m:sub>
+                          <m:r>
+                            <a:rPr lang="pt-BR" sz="2000" i="0">
+                              <a:solidFill>
+                                <a:srgbClr val="14171F"/>
+                              </a:solidFill>
+                              <a:latin typeface="Cambria Math" panose="02040503050406030204" pitchFamily="18" charset="0"/>
+                            </a:rPr>
+                            <m:t>1</m:t>
+                          </m:r>
+                        </m:sub>
+                      </m:sSub>
+                      <m:r>
+                        <a:rPr lang="pt-BR" sz="2000" i="0">
+                          <a:solidFill>
+                            <a:srgbClr val="14171F"/>
+                          </a:solidFill>
+                          <a:latin typeface="Cambria Math" panose="02040503050406030204" pitchFamily="18" charset="0"/>
+                        </a:rPr>
+                        <m:t> = </m:t>
+                      </m:r>
+                      <m:r>
+                        <a:rPr lang="pt-BR" sz="2000" i="0">
+                          <a:solidFill>
+                            <a:srgbClr val="14171F"/>
+                          </a:solidFill>
+                          <a:latin typeface="Cambria Math" panose="02040503050406030204" pitchFamily="18" charset="0"/>
+                        </a:rPr>
+                        <m:t>𝑃</m:t>
+                      </m:r>
+                      <m:r>
+                        <a:rPr lang="pt-BR" sz="2000" i="0">
+                          <a:solidFill>
+                            <a:srgbClr val="14171F"/>
+                          </a:solidFill>
+                          <a:latin typeface="Cambria Math" panose="02040503050406030204" pitchFamily="18" charset="0"/>
+                        </a:rPr>
+                        <m:t>·</m:t>
+                      </m:r>
+                      <m:r>
+                        <a:rPr lang="pt-BR" sz="2000" i="0">
+                          <a:solidFill>
+                            <a:srgbClr val="14171F"/>
+                          </a:solidFill>
+                          <a:latin typeface="Cambria Math" panose="02040503050406030204" pitchFamily="18" charset="0"/>
+                        </a:rPr>
+                        <m:t>𝑒𝑓𝑖</m:t>
+                      </m:r>
+                    </m:oMath>
+                  </m:oMathPara>
+                </a14:m>
+              </a:p>
+              <a:p>
+                <a:pPr>
+                  <a:buNone/>
+                </a:pPr>
+                <a:endParaRPr lang="pt-BR" sz="500"/>
+              </a:p>
+              <a:p>
+                <a:pPr algn="l">
+                  <a:spcBef>
+                    <a:spcPts val="1200"/>
+                  </a:spcBef>
+                  <a:buNone/>
+                </a:pPr>
+                <a14:m>
+                  <m:oMathPara xmlns:m="http://schemas.openxmlformats.org/officeDocument/2006/math">
+                    <m:oMathParaPr>
+                      <m:jc m:val="left"/>
+                    </m:oMathParaPr>
+                    <m:oMath>
+                      <m:sSub>
+                        <m:sSubPr>
+                          <m:ctrlPr>
+                            <a:rPr lang="pt-BR" sz="2000" i="0">
+                              <a:solidFill>
+                                <a:srgbClr val="14171F"/>
+                              </a:solidFill>
+                              <a:latin typeface="Cambria Math" panose="02040503050406030204" pitchFamily="18" charset="0"/>
+                            </a:rPr>
+                          </m:ctrlPr>
+                        </m:sSubPr>
+                        <m:e>
+                          <m:r>
+                            <a:rPr lang="pt-BR" sz="2000" i="0">
+                              <a:solidFill>
+                                <a:srgbClr val="14171F"/>
+                              </a:solidFill>
+                              <a:latin typeface="Cambria Math" panose="02040503050406030204" pitchFamily="18" charset="0"/>
+                            </a:rPr>
+                            <m:t>𝑄</m:t>
+                          </m:r>
                         </m:e>
                         <m:sub>
                           <m:r>
@@ -7472,12 +7206,12 @@
                           </a:solidFill>
                           <a:latin typeface="Cambria Math" panose="02040503050406030204" pitchFamily="18" charset="0"/>
                         </a:rPr>
-                        <m:t> = </m:t>
+                        <m:t> = </m:t>
                       </m:r>
                       <m:f>
                         <m:fPr>
                           <m:ctrlPr>
-                            <a:rPr lang="pt-BR" sz="2000" i="1">
+                            <a:rPr lang="pt-BR" sz="2000" i="0">
                               <a:solidFill>
                                 <a:srgbClr val="14171F"/>
                               </a:solidFill>
@@ -7527,7 +7261,7 @@
                               </a:solidFill>
                               <a:latin typeface="Cambria Math" panose="02040503050406030204" pitchFamily="18" charset="0"/>
                             </a:rPr>
-                            <m:t> − </m:t>
+                            <m:t> − </m:t>
                           </m:r>
                           <m:sSub>
                             <m:sSubPr>
@@ -7604,23 +7338,17 @@
                     </m:oMath>
                   </m:oMathPara>
                 </a14:m>
-                <a:endParaRPr lang="pt-BR" sz="1300" b="1">
-                  <a:solidFill>
-                    <a:srgbClr val="F2711C"/>
-                  </a:solidFill>
-                  <a:latin typeface="Calibri"/>
-                </a:endParaRPr>
               </a:p>
               <a:p>
                 <a:pPr>
                   <a:buNone/>
                 </a:pPr>
-                <a:endParaRPr lang="pt-BR" sz="700"/>
+                <a:endParaRPr lang="pt-BR" sz="500"/>
               </a:p>
               <a:p>
                 <a:pPr algn="l">
                   <a:spcBef>
-                    <a:spcPts val="1700"/>
+                    <a:spcPts val="1200"/>
                   </a:spcBef>
                   <a:buNone/>
                 </a:pPr>
@@ -7633,7 +7361,7 @@
                       <m:sSub>
                         <m:sSubPr>
                           <m:ctrlPr>
-                            <a:rPr lang="pt-BR" sz="2000" i="1">
+                            <a:rPr lang="pt-BR" sz="2000" i="0">
                               <a:solidFill>
                                 <a:srgbClr val="14171F"/>
                               </a:solidFill>
@@ -7642,30 +7370,15 @@
                           </m:ctrlPr>
                         </m:sSubPr>
                         <m:e>
-                          <m:acc>
-                            <m:accPr>
-                              <m:chr m:val="̇"/>
-                              <m:ctrlPr>
-                                <a:rPr lang="pt-BR" sz="2000" i="0">
-                                  <a:solidFill>
-                                    <a:srgbClr val="14171F"/>
-                                  </a:solidFill>
-                                  <a:latin typeface="Cambria Math" panose="02040503050406030204" pitchFamily="18" charset="0"/>
-                                </a:rPr>
-                              </m:ctrlPr>
-                            </m:accPr>
-                            <m:e>
-                              <m:r>
-                                <a:rPr lang="pt-BR" sz="2000" i="0">
-                                  <a:solidFill>
-                                    <a:srgbClr val="14171F"/>
-                                  </a:solidFill>
-                                  <a:latin typeface="Cambria Math" panose="02040503050406030204" pitchFamily="18" charset="0"/>
-                                </a:rPr>
-                                <m:t>𝑄</m:t>
-                              </m:r>
-                            </m:e>
-                          </m:acc>
+                          <m:r>
+                            <a:rPr lang="pt-BR" sz="2000" i="0">
+                              <a:solidFill>
+                                <a:srgbClr val="14171F"/>
+                              </a:solidFill>
+                              <a:latin typeface="Cambria Math" panose="02040503050406030204" pitchFamily="18" charset="0"/>
+                            </a:rPr>
+                            <m:t>𝑄</m:t>
+                          </m:r>
                         </m:e>
                         <m:sub>
                           <m:r>
@@ -7686,12 +7399,12 @@
                           </a:solidFill>
                           <a:latin typeface="Cambria Math" panose="02040503050406030204" pitchFamily="18" charset="0"/>
                         </a:rPr>
-                        <m:t> = </m:t>
+                        <m:t> = </m:t>
                       </m:r>
                       <m:f>
                         <m:fPr>
                           <m:ctrlPr>
-                            <a:rPr lang="pt-BR" sz="2000" i="1">
+                            <a:rPr lang="pt-BR" sz="2000" i="0">
                               <a:solidFill>
                                 <a:srgbClr val="14171F"/>
                               </a:solidFill>
@@ -7741,7 +7454,7 @@
                               </a:solidFill>
                               <a:latin typeface="Cambria Math" panose="02040503050406030204" pitchFamily="18" charset="0"/>
                             </a:rPr>
-                            <m:t> − </m:t>
+                            <m:t> − </m:t>
                           </m:r>
                           <m:sSub>
                             <m:sSubPr>
@@ -7820,7 +7533,7 @@
                               </a:solidFill>
                               <a:latin typeface="Cambria Math" panose="02040503050406030204" pitchFamily="18" charset="0"/>
                             </a:rPr>
-                            <m:t> + </m:t>
+                            <m:t> + </m:t>
                           </m:r>
                           <m:sSub>
                             <m:sSubPr>
@@ -7861,18 +7574,17 @@
                     </m:oMath>
                   </m:oMathPara>
                 </a14:m>
-                <a:endParaRPr lang="pt-BR" sz="700"/>
               </a:p>
               <a:p>
                 <a:pPr>
                   <a:buNone/>
                 </a:pPr>
-                <a:endParaRPr lang="pt-BR" sz="700"/>
+                <a:endParaRPr lang="pt-BR" sz="500"/>
               </a:p>
               <a:p>
                 <a:pPr algn="l">
                   <a:spcBef>
-                    <a:spcPts val="1700"/>
+                    <a:spcPts val="1200"/>
                   </a:spcBef>
                   <a:buNone/>
                 </a:pPr>
@@ -7885,7 +7597,7 @@
                       <m:sSub>
                         <m:sSubPr>
                           <m:ctrlPr>
-                            <a:rPr lang="pt-BR" sz="2000" i="1">
+                            <a:rPr lang="pt-BR" sz="2000" i="0">
                               <a:solidFill>
                                 <a:srgbClr val="14171F"/>
                               </a:solidFill>
@@ -7894,30 +7606,15 @@
                           </m:ctrlPr>
                         </m:sSubPr>
                         <m:e>
-                          <m:acc>
-                            <m:accPr>
-                              <m:chr m:val="̇"/>
-                              <m:ctrlPr>
-                                <a:rPr lang="pt-BR" sz="2000" i="0">
-                                  <a:solidFill>
-                                    <a:srgbClr val="14171F"/>
-                                  </a:solidFill>
-                                  <a:latin typeface="Cambria Math" panose="02040503050406030204" pitchFamily="18" charset="0"/>
-                                </a:rPr>
-                              </m:ctrlPr>
-                            </m:accPr>
-                            <m:e>
-                              <m:r>
-                                <a:rPr lang="pt-BR" sz="2000" i="0">
-                                  <a:solidFill>
-                                    <a:srgbClr val="14171F"/>
-                                  </a:solidFill>
-                                  <a:latin typeface="Cambria Math" panose="02040503050406030204" pitchFamily="18" charset="0"/>
-                                </a:rPr>
-                                <m:t>𝑄</m:t>
-                              </m:r>
-                            </m:e>
-                          </m:acc>
+                          <m:r>
+                            <a:rPr lang="pt-BR" sz="2000" i="0">
+                              <a:solidFill>
+                                <a:srgbClr val="14171F"/>
+                              </a:solidFill>
+                              <a:latin typeface="Cambria Math" panose="02040503050406030204" pitchFamily="18" charset="0"/>
+                            </a:rPr>
+                            <m:t>𝑄</m:t>
+                          </m:r>
                         </m:e>
                         <m:sub>
                           <m:r>
@@ -7938,12 +7635,12 @@
                           </a:solidFill>
                           <a:latin typeface="Cambria Math" panose="02040503050406030204" pitchFamily="18" charset="0"/>
                         </a:rPr>
-                        <m:t> = </m:t>
+                        <m:t> = </m:t>
                       </m:r>
                       <m:f>
                         <m:fPr>
                           <m:ctrlPr>
-                            <a:rPr lang="pt-BR" sz="2000" i="1">
+                            <a:rPr lang="pt-BR" sz="2000" i="0">
                               <a:solidFill>
                                 <a:srgbClr val="14171F"/>
                               </a:solidFill>
@@ -7993,7 +7690,7 @@
                               </a:solidFill>
                               <a:latin typeface="Cambria Math" panose="02040503050406030204" pitchFamily="18" charset="0"/>
                             </a:rPr>
-                            <m:t> − </m:t>
+                            <m:t> − </m:t>
                           </m:r>
                           <m:sSub>
                             <m:sSubPr>
@@ -8070,22 +7767,21 @@
                     </m:oMath>
                   </m:oMathPara>
                 </a14:m>
-                <a:endParaRPr lang="pt-BR" sz="700"/>
               </a:p>
             </p:txBody>
           </p:sp>
         </mc:Choice>
-        <mc:Fallback xmlns="">
+        <mc:Fallback>
           <p:sp>
             <p:nvSpPr>
-              <p:cNvPr id="7" name="Equações"/>
+              <p:cNvPr id="6" name="Equações"/>
               <p:cNvSpPr txBox="1"/>
               <p:nvPr/>
             </p:nvSpPr>
             <p:spPr>
               <a:xfrm>
-                <a:off x="7086600" y="1417320"/>
-                <a:ext cx="4663440" cy="4937760"/>
+                <a:off x="7086600" y="1325880"/>
+                <a:ext cx="4663440" cy="5303520"/>
               </a:xfrm>
               <a:prstGeom prst="rect">
                 <a:avLst/>
@@ -8098,7 +7794,870 @@
               <a:p>
                 <a:r>
                   <a:rPr lang="pt-BR"/>
-                  <a:t>Equações do modelo</a:t>
+                  <a:t>Equações</a:t>
+                </a:r>
+              </a:p>
+            </p:txBody>
+          </p:sp>
+        </mc:Fallback>
+      </mc:AlternateContent>
+      <p:sp>
+        <p:nvSpPr>
+          <p:cNvPr id="7" name="Rótulo resistências"/>
+          <p:cNvSpPr txBox="1"/>
+          <p:nvPr/>
+        </p:nvSpPr>
+        <p:spPr>
+          <a:xfrm>
+            <a:off x="548640" y="4553712"/>
+            <a:ext cx="6035040" cy="274320"/>
+          </a:xfrm>
+          <a:prstGeom prst="rect">
+            <a:avLst/>
+          </a:prstGeom>
+          <a:noFill/>
+        </p:spPr>
+        <p:txBody>
+          <a:bodyPr wrap="square" lIns="0" rIns="0" tIns="0" bIns="0" anchor="t">
+            <a:spAutoFit/>
+          </a:bodyPr>
+          <a:lstStyle/>
+          <a:p>
+            <a:r>
+              <a:rPr sz="1300" b="1">
+                <a:solidFill>
+                  <a:srgbClr val="F2711C"/>
+                </a:solidFill>
+                <a:latin typeface="Calibri"/>
+              </a:rPr>
+              <a:t>Resistências térmicas </a:t>
+            </a:r>
+            <a:r>
+              <a:rPr sz="1300" b="0">
+                <a:solidFill>
+                  <a:srgbClr val="5B6170"/>
+                </a:solidFill>
+                <a:latin typeface="Calibri"/>
+              </a:rPr>
+              <a:t>(Fourier: condução · Newton: convecção)</a:t>
+            </a:r>
+          </a:p>
+        </p:txBody>
+      </p:sp>
+      <mc:AlternateContent xmlns:mc="http://schemas.openxmlformats.org/markup-compatibility/2006" xmlns:a14="http://schemas.microsoft.com/office/drawing/2010/main">
+        <mc:Choice Requires="a14">
+          <p:sp>
+            <p:nvSpPr>
+              <p:cNvPr id="8" name="Resistências R1 e R2"/>
+              <p:cNvSpPr txBox="1"/>
+              <p:nvPr/>
+            </p:nvSpPr>
+            <p:spPr>
+              <a:xfrm>
+                <a:off x="548640" y="4846320"/>
+                <a:ext cx="2834640" cy="1828800"/>
+              </a:xfrm>
+              <a:prstGeom prst="rect">
+                <a:avLst/>
+              </a:prstGeom>
+              <a:noFill/>
+            </p:spPr>
+            <p:txBody>
+              <a:bodyPr wrap="square" lIns="0" tIns="0" rIns="0" bIns="0"/>
+              <a:lstStyle/>
+              <a:p>
+                <a:pPr algn="l">
+                  <a:spcBef>
+                    <a:spcPts val="1000"/>
+                  </a:spcBef>
+                  <a:buNone/>
+                </a:pPr>
+                <a14:m>
+                  <m:oMathPara xmlns:m="http://schemas.openxmlformats.org/officeDocument/2006/math">
+                    <m:oMathParaPr>
+                      <m:jc m:val="left"/>
+                    </m:oMathParaPr>
+                    <m:oMath>
+                      <m:sSub>
+                        <m:sSubPr>
+                          <m:ctrlPr>
+                            <a:rPr lang="pt-BR" sz="1700" i="0">
+                              <a:solidFill>
+                                <a:srgbClr val="14171F"/>
+                              </a:solidFill>
+                              <a:latin typeface="Cambria Math" panose="02040503050406030204" pitchFamily="18" charset="0"/>
+                            </a:rPr>
+                          </m:ctrlPr>
+                        </m:sSubPr>
+                        <m:e>
+                          <m:r>
+                            <a:rPr lang="pt-BR" sz="1700" i="0">
+                              <a:solidFill>
+                                <a:srgbClr val="14171F"/>
+                              </a:solidFill>
+                              <a:latin typeface="Cambria Math" panose="02040503050406030204" pitchFamily="18" charset="0"/>
+                            </a:rPr>
+                            <m:t>𝑅</m:t>
+                          </m:r>
+                        </m:e>
+                        <m:sub>
+                          <m:r>
+                            <a:rPr lang="pt-BR" sz="1700" i="0">
+                              <a:solidFill>
+                                <a:srgbClr val="14171F"/>
+                              </a:solidFill>
+                              <a:latin typeface="Cambria Math" panose="02040503050406030204" pitchFamily="18" charset="0"/>
+                            </a:rPr>
+                            <m:t>1</m:t>
+                          </m:r>
+                        </m:sub>
+                      </m:sSub>
+                      <m:r>
+                        <a:rPr lang="pt-BR" sz="1700" i="0">
+                          <a:solidFill>
+                            <a:srgbClr val="14171F"/>
+                          </a:solidFill>
+                          <a:latin typeface="Cambria Math" panose="02040503050406030204" pitchFamily="18" charset="0"/>
+                        </a:rPr>
+                        <m:t> = </m:t>
+                      </m:r>
+                      <m:f>
+                        <m:fPr>
+                          <m:ctrlPr>
+                            <a:rPr lang="pt-BR" sz="1700" i="0">
+                              <a:solidFill>
+                                <a:srgbClr val="14171F"/>
+                              </a:solidFill>
+                              <a:latin typeface="Cambria Math" panose="02040503050406030204" pitchFamily="18" charset="0"/>
+                            </a:rPr>
+                          </m:ctrlPr>
+                        </m:fPr>
+                        <m:num>
+                          <m:r>
+                            <a:rPr lang="pt-BR" sz="1700" i="0">
+                              <a:solidFill>
+                                <a:srgbClr val="14171F"/>
+                              </a:solidFill>
+                              <a:latin typeface="Cambria Math" panose="02040503050406030204" pitchFamily="18" charset="0"/>
+                            </a:rPr>
+                            <m:t>1</m:t>
+                          </m:r>
+                        </m:num>
+                        <m:den>
+                          <m:sSub>
+                            <m:sSubPr>
+                              <m:ctrlPr>
+                                <a:rPr lang="pt-BR" sz="1700" i="0">
+                                  <a:solidFill>
+                                    <a:srgbClr val="14171F"/>
+                                  </a:solidFill>
+                                  <a:latin typeface="Cambria Math" panose="02040503050406030204" pitchFamily="18" charset="0"/>
+                                </a:rPr>
+                              </m:ctrlPr>
+                            </m:sSubPr>
+                            <m:e>
+                              <m:r>
+                                <a:rPr lang="pt-BR" sz="1700" i="0">
+                                  <a:solidFill>
+                                    <a:srgbClr val="14171F"/>
+                                  </a:solidFill>
+                                  <a:latin typeface="Cambria Math" panose="02040503050406030204" pitchFamily="18" charset="0"/>
+                                </a:rPr>
+                                <m:t>ℎ</m:t>
+                              </m:r>
+                            </m:e>
+                            <m:sub>
+                              <m:r>
+                                <a:rPr lang="pt-BR" sz="1700" i="0">
+                                  <a:solidFill>
+                                    <a:srgbClr val="14171F"/>
+                                  </a:solidFill>
+                                  <a:latin typeface="Cambria Math" panose="02040503050406030204" pitchFamily="18" charset="0"/>
+                                </a:rPr>
+                                <m:t>𝑎𝑟</m:t>
+                              </m:r>
+                            </m:sub>
+                          </m:sSub>
+                          <m:r>
+                            <a:rPr lang="pt-BR" sz="1700" i="0">
+                              <a:solidFill>
+                                <a:srgbClr val="14171F"/>
+                              </a:solidFill>
+                              <a:latin typeface="Cambria Math" panose="02040503050406030204" pitchFamily="18" charset="0"/>
+                            </a:rPr>
+                            <m:t>·</m:t>
+                          </m:r>
+                          <m:sSub>
+                            <m:sSubPr>
+                              <m:ctrlPr>
+                                <a:rPr lang="pt-BR" sz="1700" i="0">
+                                  <a:solidFill>
+                                    <a:srgbClr val="14171F"/>
+                                  </a:solidFill>
+                                  <a:latin typeface="Cambria Math" panose="02040503050406030204" pitchFamily="18" charset="0"/>
+                                </a:rPr>
+                              </m:ctrlPr>
+                            </m:sSubPr>
+                            <m:e>
+                              <m:r>
+                                <a:rPr lang="pt-BR" sz="1700" i="0">
+                                  <a:solidFill>
+                                    <a:srgbClr val="14171F"/>
+                                  </a:solidFill>
+                                  <a:latin typeface="Cambria Math" panose="02040503050406030204" pitchFamily="18" charset="0"/>
+                                </a:rPr>
+                                <m:t>𝐴</m:t>
+                              </m:r>
+                            </m:e>
+                            <m:sub>
+                              <m:r>
+                                <a:rPr lang="pt-BR" sz="1700" i="0">
+                                  <a:solidFill>
+                                    <a:srgbClr val="14171F"/>
+                                  </a:solidFill>
+                                  <a:latin typeface="Cambria Math" panose="02040503050406030204" pitchFamily="18" charset="0"/>
+                                </a:rPr>
+                                <m:t>𝑝𝑙𝑎𝑡𝑒𝑟𝑎𝑙</m:t>
+                              </m:r>
+                            </m:sub>
+                          </m:sSub>
+                        </m:den>
+                      </m:f>
+                    </m:oMath>
+                  </m:oMathPara>
+                </a14:m>
+              </a:p>
+              <a:p>
+                <a:pPr>
+                  <a:buNone/>
+                </a:pPr>
+                <a:endParaRPr lang="pt-BR" sz="500"/>
+              </a:p>
+              <a:p>
+                <a:pPr algn="l">
+                  <a:spcBef>
+                    <a:spcPts val="1000"/>
+                  </a:spcBef>
+                  <a:buNone/>
+                </a:pPr>
+                <a14:m>
+                  <m:oMathPara xmlns:m="http://schemas.openxmlformats.org/officeDocument/2006/math">
+                    <m:oMathParaPr>
+                      <m:jc m:val="left"/>
+                    </m:oMathParaPr>
+                    <m:oMath>
+                      <m:sSub>
+                        <m:sSubPr>
+                          <m:ctrlPr>
+                            <a:rPr lang="pt-BR" sz="1700" i="0">
+                              <a:solidFill>
+                                <a:srgbClr val="14171F"/>
+                              </a:solidFill>
+                              <a:latin typeface="Cambria Math" panose="02040503050406030204" pitchFamily="18" charset="0"/>
+                            </a:rPr>
+                          </m:ctrlPr>
+                        </m:sSubPr>
+                        <m:e>
+                          <m:r>
+                            <a:rPr lang="pt-BR" sz="1700" i="0">
+                              <a:solidFill>
+                                <a:srgbClr val="14171F"/>
+                              </a:solidFill>
+                              <a:latin typeface="Cambria Math" panose="02040503050406030204" pitchFamily="18" charset="0"/>
+                            </a:rPr>
+                            <m:t>𝑅</m:t>
+                          </m:r>
+                        </m:e>
+                        <m:sub>
+                          <m:r>
+                            <a:rPr lang="pt-BR" sz="1700" i="0">
+                              <a:solidFill>
+                                <a:srgbClr val="14171F"/>
+                              </a:solidFill>
+                              <a:latin typeface="Cambria Math" panose="02040503050406030204" pitchFamily="18" charset="0"/>
+                            </a:rPr>
+                            <m:t>2</m:t>
+                          </m:r>
+                        </m:sub>
+                      </m:sSub>
+                      <m:r>
+                        <a:rPr lang="pt-BR" sz="1700" i="0">
+                          <a:solidFill>
+                            <a:srgbClr val="14171F"/>
+                          </a:solidFill>
+                          <a:latin typeface="Cambria Math" panose="02040503050406030204" pitchFamily="18" charset="0"/>
+                        </a:rPr>
+                        <m:t> = </m:t>
+                      </m:r>
+                      <m:f>
+                        <m:fPr>
+                          <m:ctrlPr>
+                            <a:rPr lang="pt-BR" sz="1700" i="0">
+                              <a:solidFill>
+                                <a:srgbClr val="14171F"/>
+                              </a:solidFill>
+                              <a:latin typeface="Cambria Math" panose="02040503050406030204" pitchFamily="18" charset="0"/>
+                            </a:rPr>
+                          </m:ctrlPr>
+                        </m:fPr>
+                        <m:num>
+                          <m:f>
+                            <m:fPr>
+                              <m:type m:val="lin"/>
+                              <m:ctrlPr>
+                                <a:rPr lang="pt-BR" sz="1700" i="0">
+                                  <a:solidFill>
+                                    <a:srgbClr val="14171F"/>
+                                  </a:solidFill>
+                                  <a:latin typeface="Cambria Math" panose="02040503050406030204" pitchFamily="18" charset="0"/>
+                                </a:rPr>
+                              </m:ctrlPr>
+                            </m:fPr>
+                            <m:num>
+                              <m:r>
+                                <a:rPr lang="pt-BR" sz="1700" i="0">
+                                  <a:solidFill>
+                                    <a:srgbClr val="14171F"/>
+                                  </a:solidFill>
+                                  <a:latin typeface="Cambria Math" panose="02040503050406030204" pitchFamily="18" charset="0"/>
+                                </a:rPr>
+                                <m:t>𝑑</m:t>
+                              </m:r>
+                            </m:num>
+                            <m:den>
+                              <m:r>
+                                <a:rPr lang="pt-BR" sz="1700" i="0">
+                                  <a:solidFill>
+                                    <a:srgbClr val="14171F"/>
+                                  </a:solidFill>
+                                  <a:latin typeface="Cambria Math" panose="02040503050406030204" pitchFamily="18" charset="0"/>
+                                </a:rPr>
+                                <m:t>2</m:t>
+                              </m:r>
+                            </m:den>
+                          </m:f>
+                        </m:num>
+                        <m:den>
+                          <m:sSub>
+                            <m:sSubPr>
+                              <m:ctrlPr>
+                                <a:rPr lang="pt-BR" sz="1700" i="0">
+                                  <a:solidFill>
+                                    <a:srgbClr val="14171F"/>
+                                  </a:solidFill>
+                                  <a:latin typeface="Cambria Math" panose="02040503050406030204" pitchFamily="18" charset="0"/>
+                                </a:rPr>
+                              </m:ctrlPr>
+                            </m:sSubPr>
+                            <m:e>
+                              <m:r>
+                                <a:rPr lang="pt-BR" sz="1700" i="0">
+                                  <a:solidFill>
+                                    <a:srgbClr val="14171F"/>
+                                  </a:solidFill>
+                                  <a:latin typeface="Cambria Math" panose="02040503050406030204" pitchFamily="18" charset="0"/>
+                                </a:rPr>
+                                <m:t>𝐾</m:t>
+                              </m:r>
+                            </m:e>
+                            <m:sub>
+                              <m:r>
+                                <a:rPr lang="pt-BR" sz="1700" i="0">
+                                  <a:solidFill>
+                                    <a:srgbClr val="14171F"/>
+                                  </a:solidFill>
+                                  <a:latin typeface="Cambria Math" panose="02040503050406030204" pitchFamily="18" charset="0"/>
+                                </a:rPr>
+                                <m:t>𝑎𝑐𝑜</m:t>
+                              </m:r>
+                            </m:sub>
+                          </m:sSub>
+                          <m:r>
+                            <a:rPr lang="pt-BR" sz="1700" i="0">
+                              <a:solidFill>
+                                <a:srgbClr val="14171F"/>
+                              </a:solidFill>
+                              <a:latin typeface="Cambria Math" panose="02040503050406030204" pitchFamily="18" charset="0"/>
+                            </a:rPr>
+                            <m:t>·</m:t>
+                          </m:r>
+                          <m:sSub>
+                            <m:sSubPr>
+                              <m:ctrlPr>
+                                <a:rPr lang="pt-BR" sz="1700" i="0">
+                                  <a:solidFill>
+                                    <a:srgbClr val="14171F"/>
+                                  </a:solidFill>
+                                  <a:latin typeface="Cambria Math" panose="02040503050406030204" pitchFamily="18" charset="0"/>
+                                </a:rPr>
+                              </m:ctrlPr>
+                            </m:sSubPr>
+                            <m:e>
+                              <m:r>
+                                <a:rPr lang="pt-BR" sz="1700" i="0">
+                                  <a:solidFill>
+                                    <a:srgbClr val="14171F"/>
+                                  </a:solidFill>
+                                  <a:latin typeface="Cambria Math" panose="02040503050406030204" pitchFamily="18" charset="0"/>
+                                </a:rPr>
+                                <m:t>𝐴</m:t>
+                              </m:r>
+                            </m:e>
+                            <m:sub>
+                              <m:r>
+                                <a:rPr lang="pt-BR" sz="1700" i="0">
+                                  <a:solidFill>
+                                    <a:srgbClr val="14171F"/>
+                                  </a:solidFill>
+                                  <a:latin typeface="Cambria Math" panose="02040503050406030204" pitchFamily="18" charset="0"/>
+                                </a:rPr>
+                                <m:t>𝑝𝑙𝑎𝑡𝑒𝑟𝑎𝑙</m:t>
+                              </m:r>
+                            </m:sub>
+                          </m:sSub>
+                        </m:den>
+                      </m:f>
+                    </m:oMath>
+                  </m:oMathPara>
+                </a14:m>
+              </a:p>
+            </p:txBody>
+          </p:sp>
+        </mc:Choice>
+        <mc:Fallback>
+          <p:sp>
+            <p:nvSpPr>
+              <p:cNvPr id="8" name="Resistências R1 e R2"/>
+              <p:cNvSpPr txBox="1"/>
+              <p:nvPr/>
+            </p:nvSpPr>
+            <p:spPr>
+              <a:xfrm>
+                <a:off x="548640" y="4846320"/>
+                <a:ext cx="2834640" cy="1828800"/>
+              </a:xfrm>
+              <a:prstGeom prst="rect">
+                <a:avLst/>
+              </a:prstGeom>
+              <a:noFill/>
+            </p:spPr>
+            <p:txBody>
+              <a:bodyPr/>
+              <a:lstStyle/>
+              <a:p>
+                <a:r>
+                  <a:rPr lang="pt-BR"/>
+                  <a:t>Resistências R1 e R2</a:t>
+                </a:r>
+              </a:p>
+            </p:txBody>
+          </p:sp>
+        </mc:Fallback>
+      </mc:AlternateContent>
+      <mc:AlternateContent xmlns:mc="http://schemas.openxmlformats.org/markup-compatibility/2006" xmlns:a14="http://schemas.microsoft.com/office/drawing/2010/main">
+        <mc:Choice Requires="a14">
+          <p:sp>
+            <p:nvSpPr>
+              <p:cNvPr id="9" name="Resistências R3 e R4"/>
+              <p:cNvSpPr txBox="1"/>
+              <p:nvPr/>
+            </p:nvSpPr>
+            <p:spPr>
+              <a:xfrm>
+                <a:off x="3520440" y="4846320"/>
+                <a:ext cx="3108960" cy="1828800"/>
+              </a:xfrm>
+              <a:prstGeom prst="rect">
+                <a:avLst/>
+              </a:prstGeom>
+              <a:noFill/>
+            </p:spPr>
+            <p:txBody>
+              <a:bodyPr wrap="square" lIns="0" tIns="0" rIns="0" bIns="0"/>
+              <a:lstStyle/>
+              <a:p>
+                <a:pPr algn="l">
+                  <a:spcBef>
+                    <a:spcPts val="1000"/>
+                  </a:spcBef>
+                  <a:buNone/>
+                </a:pPr>
+                <a14:m>
+                  <m:oMathPara xmlns:m="http://schemas.openxmlformats.org/officeDocument/2006/math">
+                    <m:oMathParaPr>
+                      <m:jc m:val="left"/>
+                    </m:oMathParaPr>
+                    <m:oMath>
+                      <m:sSub>
+                        <m:sSubPr>
+                          <m:ctrlPr>
+                            <a:rPr lang="pt-BR" sz="1700" i="0">
+                              <a:solidFill>
+                                <a:srgbClr val="14171F"/>
+                              </a:solidFill>
+                              <a:latin typeface="Cambria Math" panose="02040503050406030204" pitchFamily="18" charset="0"/>
+                            </a:rPr>
+                          </m:ctrlPr>
+                        </m:sSubPr>
+                        <m:e>
+                          <m:r>
+                            <a:rPr lang="pt-BR" sz="1700" i="0">
+                              <a:solidFill>
+                                <a:srgbClr val="14171F"/>
+                              </a:solidFill>
+                              <a:latin typeface="Cambria Math" panose="02040503050406030204" pitchFamily="18" charset="0"/>
+                            </a:rPr>
+                            <m:t>𝑅</m:t>
+                          </m:r>
+                        </m:e>
+                        <m:sub>
+                          <m:r>
+                            <a:rPr lang="pt-BR" sz="1700" i="0">
+                              <a:solidFill>
+                                <a:srgbClr val="14171F"/>
+                              </a:solidFill>
+                              <a:latin typeface="Cambria Math" panose="02040503050406030204" pitchFamily="18" charset="0"/>
+                            </a:rPr>
+                            <m:t>3</m:t>
+                          </m:r>
+                        </m:sub>
+                      </m:sSub>
+                      <m:r>
+                        <a:rPr lang="pt-BR" sz="1700" i="0">
+                          <a:solidFill>
+                            <a:srgbClr val="14171F"/>
+                          </a:solidFill>
+                          <a:latin typeface="Cambria Math" panose="02040503050406030204" pitchFamily="18" charset="0"/>
+                        </a:rPr>
+                        <m:t> = </m:t>
+                      </m:r>
+                      <m:f>
+                        <m:fPr>
+                          <m:ctrlPr>
+                            <a:rPr lang="pt-BR" sz="1700" i="0">
+                              <a:solidFill>
+                                <a:srgbClr val="14171F"/>
+                              </a:solidFill>
+                              <a:latin typeface="Cambria Math" panose="02040503050406030204" pitchFamily="18" charset="0"/>
+                            </a:rPr>
+                          </m:ctrlPr>
+                        </m:fPr>
+                        <m:num>
+                          <m:f>
+                            <m:fPr>
+                              <m:type m:val="lin"/>
+                              <m:ctrlPr>
+                                <a:rPr lang="pt-BR" sz="1700" i="0">
+                                  <a:solidFill>
+                                    <a:srgbClr val="14171F"/>
+                                  </a:solidFill>
+                                  <a:latin typeface="Cambria Math" panose="02040503050406030204" pitchFamily="18" charset="0"/>
+                                </a:rPr>
+                              </m:ctrlPr>
+                            </m:fPr>
+                            <m:num>
+                              <m:r>
+                                <a:rPr lang="pt-BR" sz="1700" i="0">
+                                  <a:solidFill>
+                                    <a:srgbClr val="14171F"/>
+                                  </a:solidFill>
+                                  <a:latin typeface="Cambria Math" panose="02040503050406030204" pitchFamily="18" charset="0"/>
+                                </a:rPr>
+                                <m:t>𝑑</m:t>
+                              </m:r>
+                            </m:num>
+                            <m:den>
+                              <m:r>
+                                <a:rPr lang="pt-BR" sz="1700" i="0">
+                                  <a:solidFill>
+                                    <a:srgbClr val="14171F"/>
+                                  </a:solidFill>
+                                  <a:latin typeface="Cambria Math" panose="02040503050406030204" pitchFamily="18" charset="0"/>
+                                </a:rPr>
+                                <m:t>2</m:t>
+                              </m:r>
+                            </m:den>
+                          </m:f>
+                        </m:num>
+                        <m:den>
+                          <m:sSub>
+                            <m:sSubPr>
+                              <m:ctrlPr>
+                                <a:rPr lang="pt-BR" sz="1700" i="0">
+                                  <a:solidFill>
+                                    <a:srgbClr val="14171F"/>
+                                  </a:solidFill>
+                                  <a:latin typeface="Cambria Math" panose="02040503050406030204" pitchFamily="18" charset="0"/>
+                                </a:rPr>
+                              </m:ctrlPr>
+                            </m:sSubPr>
+                            <m:e>
+                              <m:r>
+                                <a:rPr lang="pt-BR" sz="1700" i="0">
+                                  <a:solidFill>
+                                    <a:srgbClr val="14171F"/>
+                                  </a:solidFill>
+                                  <a:latin typeface="Cambria Math" panose="02040503050406030204" pitchFamily="18" charset="0"/>
+                                </a:rPr>
+                                <m:t>𝐾</m:t>
+                              </m:r>
+                            </m:e>
+                            <m:sub>
+                              <m:r>
+                                <a:rPr lang="pt-BR" sz="1700" i="0">
+                                  <a:solidFill>
+                                    <a:srgbClr val="14171F"/>
+                                  </a:solidFill>
+                                  <a:latin typeface="Cambria Math" panose="02040503050406030204" pitchFamily="18" charset="0"/>
+                                </a:rPr>
+                                <m:t>𝑎𝑐𝑜</m:t>
+                              </m:r>
+                            </m:sub>
+                          </m:sSub>
+                          <m:r>
+                            <a:rPr lang="pt-BR" sz="1700" i="0">
+                              <a:solidFill>
+                                <a:srgbClr val="14171F"/>
+                              </a:solidFill>
+                              <a:latin typeface="Cambria Math" panose="02040503050406030204" pitchFamily="18" charset="0"/>
+                            </a:rPr>
+                            <m:t>·</m:t>
+                          </m:r>
+                          <m:sSub>
+                            <m:sSubPr>
+                              <m:ctrlPr>
+                                <a:rPr lang="pt-BR" sz="1700" i="0">
+                                  <a:solidFill>
+                                    <a:srgbClr val="14171F"/>
+                                  </a:solidFill>
+                                  <a:latin typeface="Cambria Math" panose="02040503050406030204" pitchFamily="18" charset="0"/>
+                                </a:rPr>
+                              </m:ctrlPr>
+                            </m:sSubPr>
+                            <m:e>
+                              <m:r>
+                                <a:rPr lang="pt-BR" sz="1700" i="0">
+                                  <a:solidFill>
+                                    <a:srgbClr val="14171F"/>
+                                  </a:solidFill>
+                                  <a:latin typeface="Cambria Math" panose="02040503050406030204" pitchFamily="18" charset="0"/>
+                                </a:rPr>
+                                <m:t>𝐴</m:t>
+                              </m:r>
+                            </m:e>
+                            <m:sub>
+                              <m:r>
+                                <a:rPr lang="pt-BR" sz="1700" i="0">
+                                  <a:solidFill>
+                                    <a:srgbClr val="14171F"/>
+                                  </a:solidFill>
+                                  <a:latin typeface="Cambria Math" panose="02040503050406030204" pitchFamily="18" charset="0"/>
+                                </a:rPr>
+                                <m:t>𝑝</m:t>
+                              </m:r>
+                            </m:sub>
+                          </m:sSub>
+                        </m:den>
+                      </m:f>
+                    </m:oMath>
+                  </m:oMathPara>
+                </a14:m>
+              </a:p>
+              <a:p>
+                <a:pPr>
+                  <a:buNone/>
+                </a:pPr>
+                <a:endParaRPr lang="pt-BR" sz="500"/>
+              </a:p>
+              <a:p>
+                <a:pPr algn="l">
+                  <a:spcBef>
+                    <a:spcPts val="1000"/>
+                  </a:spcBef>
+                  <a:buNone/>
+                </a:pPr>
+                <a14:m>
+                  <m:oMathPara xmlns:m="http://schemas.openxmlformats.org/officeDocument/2006/math">
+                    <m:oMathParaPr>
+                      <m:jc m:val="left"/>
+                    </m:oMathParaPr>
+                    <m:oMath>
+                      <m:sSub>
+                        <m:sSubPr>
+                          <m:ctrlPr>
+                            <a:rPr lang="pt-BR" sz="1700" i="0">
+                              <a:solidFill>
+                                <a:srgbClr val="14171F"/>
+                              </a:solidFill>
+                              <a:latin typeface="Cambria Math" panose="02040503050406030204" pitchFamily="18" charset="0"/>
+                            </a:rPr>
+                          </m:ctrlPr>
+                        </m:sSubPr>
+                        <m:e>
+                          <m:r>
+                            <a:rPr lang="pt-BR" sz="1700" i="0">
+                              <a:solidFill>
+                                <a:srgbClr val="14171F"/>
+                              </a:solidFill>
+                              <a:latin typeface="Cambria Math" panose="02040503050406030204" pitchFamily="18" charset="0"/>
+                            </a:rPr>
+                            <m:t>𝑅</m:t>
+                          </m:r>
+                        </m:e>
+                        <m:sub>
+                          <m:r>
+                            <a:rPr lang="pt-BR" sz="1700" i="0">
+                              <a:solidFill>
+                                <a:srgbClr val="14171F"/>
+                              </a:solidFill>
+                              <a:latin typeface="Cambria Math" panose="02040503050406030204" pitchFamily="18" charset="0"/>
+                            </a:rPr>
+                            <m:t>4</m:t>
+                          </m:r>
+                        </m:sub>
+                      </m:sSub>
+                      <m:r>
+                        <a:rPr lang="pt-BR" sz="1700" i="0">
+                          <a:solidFill>
+                            <a:srgbClr val="14171F"/>
+                          </a:solidFill>
+                          <a:latin typeface="Cambria Math" panose="02040503050406030204" pitchFamily="18" charset="0"/>
+                        </a:rPr>
+                        <m:t> = </m:t>
+                      </m:r>
+                      <m:f>
+                        <m:fPr>
+                          <m:ctrlPr>
+                            <a:rPr lang="pt-BR" sz="1700" i="0">
+                              <a:solidFill>
+                                <a:srgbClr val="14171F"/>
+                              </a:solidFill>
+                              <a:latin typeface="Cambria Math" panose="02040503050406030204" pitchFamily="18" charset="0"/>
+                            </a:rPr>
+                          </m:ctrlPr>
+                        </m:fPr>
+                        <m:num>
+                          <m:r>
+                            <a:rPr lang="pt-BR" sz="1700" i="0">
+                              <a:solidFill>
+                                <a:srgbClr val="14171F"/>
+                              </a:solidFill>
+                              <a:latin typeface="Cambria Math" panose="02040503050406030204" pitchFamily="18" charset="0"/>
+                            </a:rPr>
+                            <m:t>1</m:t>
+                          </m:r>
+                        </m:num>
+                        <m:den>
+                          <m:sSub>
+                            <m:sSubPr>
+                              <m:ctrlPr>
+                                <a:rPr lang="pt-BR" sz="1700" i="0">
+                                  <a:solidFill>
+                                    <a:srgbClr val="14171F"/>
+                                  </a:solidFill>
+                                  <a:latin typeface="Cambria Math" panose="02040503050406030204" pitchFamily="18" charset="0"/>
+                                </a:rPr>
+                              </m:ctrlPr>
+                            </m:sSubPr>
+                            <m:e>
+                              <m:r>
+                                <a:rPr lang="pt-BR" sz="1700" i="0">
+                                  <a:solidFill>
+                                    <a:srgbClr val="14171F"/>
+                                  </a:solidFill>
+                                  <a:latin typeface="Cambria Math" panose="02040503050406030204" pitchFamily="18" charset="0"/>
+                                </a:rPr>
+                                <m:t>ℎ</m:t>
+                              </m:r>
+                            </m:e>
+                            <m:sub>
+                              <m:r>
+                                <a:rPr lang="pt-BR" sz="1700" i="0">
+                                  <a:solidFill>
+                                    <a:srgbClr val="14171F"/>
+                                  </a:solidFill>
+                                  <a:latin typeface="Cambria Math" panose="02040503050406030204" pitchFamily="18" charset="0"/>
+                                </a:rPr>
+                                <m:t>𝑎𝑟</m:t>
+                              </m:r>
+                            </m:sub>
+                          </m:sSub>
+                          <m:r>
+                            <a:rPr lang="pt-BR" sz="1700" i="0">
+                              <a:solidFill>
+                                <a:srgbClr val="14171F"/>
+                              </a:solidFill>
+                              <a:latin typeface="Cambria Math" panose="02040503050406030204" pitchFamily="18" charset="0"/>
+                            </a:rPr>
+                            <m:t>·</m:t>
+                          </m:r>
+                          <m:sSub>
+                            <m:sSubPr>
+                              <m:ctrlPr>
+                                <a:rPr lang="pt-BR" sz="1700" i="0">
+                                  <a:solidFill>
+                                    <a:srgbClr val="14171F"/>
+                                  </a:solidFill>
+                                  <a:latin typeface="Cambria Math" panose="02040503050406030204" pitchFamily="18" charset="0"/>
+                                </a:rPr>
+                              </m:ctrlPr>
+                            </m:sSubPr>
+                            <m:e>
+                              <m:r>
+                                <a:rPr lang="pt-BR" sz="1700" i="0">
+                                  <a:solidFill>
+                                    <a:srgbClr val="14171F"/>
+                                  </a:solidFill>
+                                  <a:latin typeface="Cambria Math" panose="02040503050406030204" pitchFamily="18" charset="0"/>
+                                </a:rPr>
+                                <m:t>𝐴</m:t>
+                              </m:r>
+                            </m:e>
+                            <m:sub>
+                              <m:r>
+                                <a:rPr lang="pt-BR" sz="1700" i="0">
+                                  <a:solidFill>
+                                    <a:srgbClr val="14171F"/>
+                                  </a:solidFill>
+                                  <a:latin typeface="Cambria Math" panose="02040503050406030204" pitchFamily="18" charset="0"/>
+                                </a:rPr>
+                                <m:t>𝑝𝑎𝑛𝑒𝑙𝑎𝑎𝑏𝑒𝑟𝑡𝑎</m:t>
+                              </m:r>
+                            </m:sub>
+                          </m:sSub>
+                        </m:den>
+                      </m:f>
+                    </m:oMath>
+                  </m:oMathPara>
+                </a14:m>
+              </a:p>
+            </p:txBody>
+          </p:sp>
+        </mc:Choice>
+        <mc:Fallback>
+          <p:sp>
+            <p:nvSpPr>
+              <p:cNvPr id="9" name="Resistências R3 e R4"/>
+              <p:cNvSpPr txBox="1"/>
+              <p:nvPr/>
+            </p:nvSpPr>
+            <p:spPr>
+              <a:xfrm>
+                <a:off x="3520440" y="4846320"/>
+                <a:ext cx="3108960" cy="1828800"/>
+              </a:xfrm>
+              <a:prstGeom prst="rect">
+                <a:avLst/>
+              </a:prstGeom>
+              <a:noFill/>
+            </p:spPr>
+            <p:txBody>
+              <a:bodyPr/>
+              <a:lstStyle/>
+              <a:p>
+                <a:r>
+                  <a:rPr lang="pt-BR"/>
+                  <a:t>Resistências R3 e R4</a:t>
                 </a:r>
               </a:p>
             </p:txBody>
@@ -8844,14 +9403,14 @@
       </p:sp>
       <p:sp>
         <p:nvSpPr>
-          <p:cNvPr id="7" name="Medido 2"/>
+          <p:cNvPr id="36" name="Medido 1b"/>
           <p:cNvSpPr/>
           <p:nvPr/>
         </p:nvSpPr>
         <p:spPr>
           <a:xfrm>
             <a:off x="548640" y="1920240"/>
-            <a:ext cx="3337560" cy="749808"/>
+            <a:ext cx="1636776" cy="713232"/>
           </a:xfrm>
           <a:prstGeom prst="roundRect">
             <a:avLst>
@@ -8897,58 +9456,14 @@
       </p:sp>
       <p:sp>
         <p:nvSpPr>
-          <p:cNvPr id="8" name="TextBox 7"/>
-          <p:cNvSpPr txBox="1"/>
+          <p:cNvPr id="38" name="Medido 2b"/>
+          <p:cNvSpPr/>
           <p:nvPr/>
         </p:nvSpPr>
         <p:spPr>
           <a:xfrm>
-            <a:off x="777240" y="2011680"/>
-            <a:ext cx="3017520" cy="594360"/>
-          </a:xfrm>
-          <a:prstGeom prst="rect">
-            <a:avLst/>
-          </a:prstGeom>
-          <a:noFill/>
-        </p:spPr>
-        <p:txBody>
-          <a:bodyPr wrap="square" lIns="0" tIns="0" rIns="0" bIns="0" anchor="ctr">
-            <a:spAutoFit/>
-          </a:bodyPr>
-          <a:lstStyle/>
-          <a:p>
-            <a:pPr algn="l"/>
-            <a:r>
-              <a:rPr sz="2000" b="1" i="0">
-                <a:solidFill>
-                  <a:srgbClr val="1C7ED6"/>
-                </a:solidFill>
-                <a:latin typeface="Calibri"/>
-              </a:rPr>
-              <a:t>81,2 mm</a:t>
-            </a:r>
-            <a:r>
-              <a:rPr sz="1400" b="0" i="0">
-                <a:solidFill>
-                  <a:srgbClr val="5B6170"/>
-                </a:solidFill>
-                <a:latin typeface="Calibri"/>
-              </a:rPr>
-              <a:t>   altura</a:t>
-            </a:r>
-          </a:p>
-        </p:txBody>
-      </p:sp>
-      <p:sp>
-        <p:nvSpPr>
-          <p:cNvPr id="13" name="Medido 5"/>
-          <p:cNvSpPr/>
-          <p:nvPr/>
-        </p:nvSpPr>
-        <p:spPr>
-          <a:xfrm>
-            <a:off x="548640" y="2807208"/>
-            <a:ext cx="3337560" cy="749808"/>
+            <a:off x="2249424" y="1920240"/>
+            <a:ext cx="1636776" cy="713232"/>
           </a:xfrm>
           <a:prstGeom prst="roundRect">
             <a:avLst>
@@ -8994,93 +9509,14 @@
       </p:sp>
       <p:sp>
         <p:nvSpPr>
-          <p:cNvPr id="14" name="TextBox 13"/>
-          <p:cNvSpPr txBox="1"/>
+          <p:cNvPr id="40" name="Medido 3b"/>
+          <p:cNvSpPr/>
           <p:nvPr/>
         </p:nvSpPr>
         <p:spPr>
           <a:xfrm>
-            <a:off x="777240" y="2898648"/>
-            <a:ext cx="3017520" cy="594360"/>
-          </a:xfrm>
-          <a:prstGeom prst="rect">
-            <a:avLst/>
-          </a:prstGeom>
-          <a:noFill/>
-        </p:spPr>
-        <p:txBody>
-          <a:bodyPr wrap="square" lIns="0" tIns="0" rIns="0" bIns="0" anchor="ctr">
-            <a:spAutoFit/>
-          </a:bodyPr>
-          <a:lstStyle/>
-          <a:p>
-            <a:pPr algn="l"/>
-            <a:r>
-              <a:rPr sz="2000" b="1" i="0">
-                <a:solidFill>
-                  <a:srgbClr val="1C7ED6"/>
-                </a:solidFill>
-                <a:latin typeface="Calibri"/>
-              </a:rPr>
-              <a:t>18,9 °C</a:t>
-            </a:r>
-            <a:r>
-              <a:rPr sz="1400" b="0" i="0">
-                <a:solidFill>
-                  <a:srgbClr val="5B6170"/>
-                </a:solidFill>
-                <a:latin typeface="Calibri"/>
-              </a:rPr>
-              <a:t>   temperatura ambiente</a:t>
-            </a:r>
-          </a:p>
-        </p:txBody>
-      </p:sp>
-      <p:sp>
-        <p:nvSpPr>
-          <p:cNvPr id="15" name="TextBox 14"/>
-          <p:cNvSpPr txBox="1"/>
-          <p:nvPr/>
-        </p:nvSpPr>
-        <p:spPr>
-          <a:xfrm>
-            <a:off x="4434840" y="1508760"/>
-            <a:ext cx="3383280" cy="320040"/>
-          </a:xfrm>
-          <a:prstGeom prst="rect">
-            <a:avLst/>
-          </a:prstGeom>
-          <a:noFill/>
-        </p:spPr>
-        <p:txBody>
-          <a:bodyPr wrap="square" lIns="0" tIns="0" rIns="0" bIns="0" anchor="t">
-            <a:spAutoFit/>
-          </a:bodyPr>
-          <a:lstStyle/>
-          <a:p>
-            <a:pPr algn="l"/>
-            <a:r>
-              <a:rPr sz="1300" b="1" i="0">
-                <a:solidFill>
-                  <a:srgbClr val="5B6170"/>
-                </a:solidFill>
-                <a:latin typeface="Calibri"/>
-              </a:rPr>
-              <a:t>CALCULADO</a:t>
-            </a:r>
-          </a:p>
-        </p:txBody>
-      </p:sp>
-      <p:sp>
-        <p:nvSpPr>
-          <p:cNvPr id="16" name="Cartão CALCULADO"/>
-          <p:cNvSpPr/>
-          <p:nvPr/>
-        </p:nvSpPr>
-        <p:spPr>
-          <a:xfrm>
-            <a:off x="4434840" y="1920240"/>
-            <a:ext cx="3337560" cy="1636776"/>
+            <a:off x="548640" y="2724912"/>
+            <a:ext cx="1636776" cy="713232"/>
           </a:xfrm>
           <a:prstGeom prst="roundRect">
             <a:avLst>
@@ -9126,14 +9562,173 @@
       </p:sp>
       <p:sp>
         <p:nvSpPr>
-          <p:cNvPr id="17" name="TextBox 16"/>
+          <p:cNvPr id="42" name="Medido 4b"/>
+          <p:cNvSpPr/>
+          <p:nvPr/>
+        </p:nvSpPr>
+        <p:spPr>
+          <a:xfrm>
+            <a:off x="2249424" y="2724912"/>
+            <a:ext cx="1636776" cy="713232"/>
+          </a:xfrm>
+          <a:prstGeom prst="roundRect">
+            <a:avLst>
+              <a:gd name="adj" fmla="val 8000"/>
+            </a:avLst>
+          </a:prstGeom>
+          <a:solidFill>
+            <a:srgbClr val="FFFFFF"/>
+          </a:solidFill>
+          <a:ln>
+            <a:noFill/>
+          </a:ln>
+          <a:effectLst>
+            <a:outerShdw blurRad="190500" dist="38100" dir="5400000" algn="t" rotWithShape="0">
+              <a:srgbClr val="000000">
+                <a:alpha val="14000"/>
+              </a:srgbClr>
+            </a:outerShdw>
+          </a:effectLst>
+        </p:spPr>
+        <p:style>
+          <a:lnRef idx="1">
+            <a:schemeClr val="accent1"/>
+          </a:lnRef>
+          <a:fillRef idx="3">
+            <a:schemeClr val="accent1"/>
+          </a:fillRef>
+          <a:effectRef idx="2">
+            <a:schemeClr val="accent1"/>
+          </a:effectRef>
+          <a:fontRef idx="minor">
+            <a:schemeClr val="lt1"/>
+          </a:fontRef>
+        </p:style>
+        <p:txBody>
+          <a:bodyPr rtlCol="0" anchor="ctr"/>
+          <a:lstStyle/>
+          <a:p>
+            <a:pPr algn="ctr"/>
+            <a:endParaRPr/>
+          </a:p>
+        </p:txBody>
+      </p:sp>
+      <p:sp>
+        <p:nvSpPr>
+          <p:cNvPr id="44" name="Medido 5b"/>
+          <p:cNvSpPr/>
+          <p:nvPr/>
+        </p:nvSpPr>
+        <p:spPr>
+          <a:xfrm>
+            <a:off x="548640" y="3529584"/>
+            <a:ext cx="1636776" cy="713232"/>
+          </a:xfrm>
+          <a:prstGeom prst="roundRect">
+            <a:avLst>
+              <a:gd name="adj" fmla="val 8000"/>
+            </a:avLst>
+          </a:prstGeom>
+          <a:solidFill>
+            <a:srgbClr val="FFFFFF"/>
+          </a:solidFill>
+          <a:ln>
+            <a:noFill/>
+          </a:ln>
+          <a:effectLst>
+            <a:outerShdw blurRad="190500" dist="38100" dir="5400000" algn="t" rotWithShape="0">
+              <a:srgbClr val="000000">
+                <a:alpha val="14000"/>
+              </a:srgbClr>
+            </a:outerShdw>
+          </a:effectLst>
+        </p:spPr>
+        <p:style>
+          <a:lnRef idx="1">
+            <a:schemeClr val="accent1"/>
+          </a:lnRef>
+          <a:fillRef idx="3">
+            <a:schemeClr val="accent1"/>
+          </a:fillRef>
+          <a:effectRef idx="2">
+            <a:schemeClr val="accent1"/>
+          </a:effectRef>
+          <a:fontRef idx="minor">
+            <a:schemeClr val="lt1"/>
+          </a:fontRef>
+        </p:style>
+        <p:txBody>
+          <a:bodyPr rtlCol="0" anchor="ctr"/>
+          <a:lstStyle/>
+          <a:p>
+            <a:pPr algn="ctr"/>
+            <a:endParaRPr/>
+          </a:p>
+        </p:txBody>
+      </p:sp>
+      <p:sp>
+        <p:nvSpPr>
+          <p:cNvPr id="46" name="Medido 6b"/>
+          <p:cNvSpPr/>
+          <p:nvPr/>
+        </p:nvSpPr>
+        <p:spPr>
+          <a:xfrm>
+            <a:off x="2249424" y="3529584"/>
+            <a:ext cx="1636776" cy="713232"/>
+          </a:xfrm>
+          <a:prstGeom prst="roundRect">
+            <a:avLst>
+              <a:gd name="adj" fmla="val 8000"/>
+            </a:avLst>
+          </a:prstGeom>
+          <a:solidFill>
+            <a:srgbClr val="FFFFFF"/>
+          </a:solidFill>
+          <a:ln>
+            <a:noFill/>
+          </a:ln>
+          <a:effectLst>
+            <a:outerShdw blurRad="190500" dist="38100" dir="5400000" algn="t" rotWithShape="0">
+              <a:srgbClr val="000000">
+                <a:alpha val="14000"/>
+              </a:srgbClr>
+            </a:outerShdw>
+          </a:effectLst>
+        </p:spPr>
+        <p:style>
+          <a:lnRef idx="1">
+            <a:schemeClr val="accent1"/>
+          </a:lnRef>
+          <a:fillRef idx="3">
+            <a:schemeClr val="accent1"/>
+          </a:fillRef>
+          <a:effectRef idx="2">
+            <a:schemeClr val="accent1"/>
+          </a:effectRef>
+          <a:fontRef idx="minor">
+            <a:schemeClr val="lt1"/>
+          </a:fontRef>
+        </p:style>
+        <p:txBody>
+          <a:bodyPr rtlCol="0" anchor="ctr"/>
+          <a:lstStyle/>
+          <a:p>
+            <a:pPr algn="ctr"/>
+            <a:endParaRPr/>
+          </a:p>
+        </p:txBody>
+      </p:sp>
+      <p:sp>
+        <p:nvSpPr>
+          <p:cNvPr id="48" name="Rótulo LITERATURA"/>
           <p:cNvSpPr txBox="1"/>
           <p:nvPr/>
         </p:nvSpPr>
         <p:spPr>
           <a:xfrm>
-            <a:off x="4709159" y="2057400"/>
-            <a:ext cx="2834640" cy="731520"/>
+            <a:off x="4434840" y="2926080"/>
+            <a:ext cx="3383280" cy="320040"/>
           </a:xfrm>
           <a:prstGeom prst="rect">
             <a:avLst/>
@@ -9148,27 +9743,27 @@
           <a:p>
             <a:pPr algn="l"/>
             <a:r>
-              <a:rPr sz="3400" b="1" i="0">
+              <a:rPr sz="1300" b="1" i="0">
                 <a:solidFill>
                   <a:srgbClr val="5B6170"/>
                 </a:solidFill>
                 <a:latin typeface="Calibri"/>
               </a:rPr>
-              <a:t>0,75 kg</a:t>
-            </a:r>
-          </a:p>
-        </p:txBody>
-      </p:sp>
-      <p:sp>
-        <p:nvSpPr>
-          <p:cNvPr id="18" name="TextBox 17"/>
+              <a:t>DA LITERATURA</a:t>
+            </a:r>
+          </a:p>
+        </p:txBody>
+      </p:sp>
+      <p:sp>
+        <p:nvSpPr>
+          <p:cNvPr id="15" name="TextBox 14"/>
           <p:cNvSpPr txBox="1"/>
           <p:nvPr/>
         </p:nvSpPr>
         <p:spPr>
           <a:xfrm>
-            <a:off x="4709159" y="2788920"/>
-            <a:ext cx="2834640" cy="365760"/>
+            <a:off x="4434840" y="1508760"/>
+            <a:ext cx="3383280" cy="320040"/>
           </a:xfrm>
           <a:prstGeom prst="rect">
             <a:avLst/>
@@ -9183,13 +9778,189 @@
           <a:p>
             <a:pPr algn="l"/>
             <a:r>
-              <a:rPr sz="1500" b="1" i="0">
-                <a:solidFill>
-                  <a:srgbClr val="14171F"/>
+              <a:rPr sz="1300" b="1" i="0">
+                <a:solidFill>
+                  <a:srgbClr val="5B6170"/>
                 </a:solidFill>
                 <a:latin typeface="Calibri"/>
               </a:rPr>
-              <a:t>massa da panela</a:t>
+              <a:t>CALCULADO</a:t>
+            </a:r>
+          </a:p>
+        </p:txBody>
+      </p:sp>
+      <p:sp>
+        <p:nvSpPr>
+          <p:cNvPr id="49" name="Cartão LITERATURA"/>
+          <p:cNvSpPr/>
+          <p:nvPr/>
+        </p:nvSpPr>
+        <p:spPr>
+          <a:xfrm>
+            <a:off x="4434840" y="3310128"/>
+            <a:ext cx="3337560" cy="932688"/>
+          </a:xfrm>
+          <a:prstGeom prst="roundRect">
+            <a:avLst>
+              <a:gd name="adj" fmla="val 8000"/>
+            </a:avLst>
+          </a:prstGeom>
+          <a:solidFill>
+            <a:srgbClr val="FFFFFF"/>
+          </a:solidFill>
+          <a:ln>
+            <a:noFill/>
+          </a:ln>
+          <a:effectLst>
+            <a:outerShdw blurRad="190500" dist="38100" dir="5400000" algn="t" rotWithShape="0">
+              <a:srgbClr val="000000">
+                <a:alpha val="14000"/>
+              </a:srgbClr>
+            </a:outerShdw>
+          </a:effectLst>
+        </p:spPr>
+        <p:style>
+          <a:lnRef idx="1">
+            <a:schemeClr val="accent1"/>
+          </a:lnRef>
+          <a:fillRef idx="3">
+            <a:schemeClr val="accent1"/>
+          </a:fillRef>
+          <a:effectRef idx="2">
+            <a:schemeClr val="accent1"/>
+          </a:effectRef>
+          <a:fontRef idx="minor">
+            <a:schemeClr val="lt1"/>
+          </a:fontRef>
+        </p:style>
+        <p:txBody>
+          <a:bodyPr rtlCol="0" anchor="ctr"/>
+          <a:lstStyle/>
+          <a:p>
+            <a:pPr algn="ctr"/>
+            <a:endParaRPr/>
+          </a:p>
+        </p:txBody>
+      </p:sp>
+      <p:sp>
+        <p:nvSpPr>
+          <p:cNvPr id="16" name="Cartão CALCULADO"/>
+          <p:cNvSpPr/>
+          <p:nvPr/>
+        </p:nvSpPr>
+        <p:spPr>
+          <a:xfrm>
+            <a:off x="4434840" y="1920240"/>
+            <a:ext cx="3337560" cy="914400"/>
+          </a:xfrm>
+          <a:prstGeom prst="roundRect">
+            <a:avLst>
+              <a:gd name="adj" fmla="val 8000"/>
+            </a:avLst>
+          </a:prstGeom>
+          <a:solidFill>
+            <a:srgbClr val="FFFFFF"/>
+          </a:solidFill>
+          <a:ln>
+            <a:noFill/>
+          </a:ln>
+          <a:effectLst>
+            <a:outerShdw blurRad="190500" dist="38100" dir="5400000" algn="t" rotWithShape="0">
+              <a:srgbClr val="000000">
+                <a:alpha val="14000"/>
+              </a:srgbClr>
+            </a:outerShdw>
+          </a:effectLst>
+        </p:spPr>
+        <p:style>
+          <a:lnRef idx="1">
+            <a:schemeClr val="accent1"/>
+          </a:lnRef>
+          <a:fillRef idx="3">
+            <a:schemeClr val="accent1"/>
+          </a:fillRef>
+          <a:effectRef idx="2">
+            <a:schemeClr val="accent1"/>
+          </a:effectRef>
+          <a:fontRef idx="minor">
+            <a:schemeClr val="lt1"/>
+          </a:fontRef>
+        </p:style>
+        <p:txBody>
+          <a:bodyPr rtlCol="0" anchor="ctr"/>
+          <a:lstStyle/>
+          <a:p>
+            <a:pPr algn="ctr"/>
+            <a:endParaRPr/>
+          </a:p>
+        </p:txBody>
+      </p:sp>
+      <p:sp>
+        <p:nvSpPr>
+          <p:cNvPr id="17" name="TextBox 16"/>
+          <p:cNvSpPr txBox="1"/>
+          <p:nvPr/>
+        </p:nvSpPr>
+        <p:spPr>
+          <a:xfrm>
+            <a:off x="4709159" y="1984248"/>
+            <a:ext cx="2834640" cy="502920"/>
+          </a:xfrm>
+          <a:prstGeom prst="rect">
+            <a:avLst/>
+          </a:prstGeom>
+          <a:noFill/>
+        </p:spPr>
+        <p:txBody>
+          <a:bodyPr wrap="square" lIns="0" tIns="0" rIns="0" bIns="0" anchor="t">
+            <a:spAutoFit/>
+          </a:bodyPr>
+          <a:lstStyle/>
+          <a:p>
+            <a:pPr algn="l"/>
+            <a:r>
+              <a:rPr sz="3400" b="1" i="0">
+                <a:solidFill>
+                  <a:srgbClr val="5B6170"/>
+                </a:solidFill>
+                <a:latin typeface="Calibri"/>
+              </a:rPr>
+              <a:t>0,75 kg</a:t>
+            </a:r>
+          </a:p>
+        </p:txBody>
+      </p:sp>
+      <p:sp>
+        <p:nvSpPr>
+          <p:cNvPr id="18" name="TextBox 17"/>
+          <p:cNvSpPr txBox="1"/>
+          <p:nvPr/>
+        </p:nvSpPr>
+        <p:spPr>
+          <a:xfrm>
+            <a:off x="4709159" y="2450592"/>
+            <a:ext cx="2834640" cy="274320"/>
+          </a:xfrm>
+          <a:prstGeom prst="rect">
+            <a:avLst/>
+          </a:prstGeom>
+          <a:noFill/>
+        </p:spPr>
+        <p:txBody>
+          <a:bodyPr wrap="square" lIns="0" tIns="0" rIns="0" bIns="0" anchor="t">
+            <a:spAutoFit/>
+          </a:bodyPr>
+          <a:lstStyle/>
+          <a:p>
+            <a:pPr algn="l"/>
+            <a:r>
+              <a:rPr sz="1500" b="1" i="0">
+                <a:solidFill>
+                  <a:srgbClr val="14171F"/>
+                </a:solidFill>
+                <a:latin typeface="Calibri"/>
+              </a:rPr>
+              <a:t>massa da panela (mp)</a:t>
             </a:r>
           </a:p>
         </p:txBody>
@@ -9560,8 +10331,8 @@
         </p:nvSpPr>
         <p:spPr>
           <a:xfrm>
-            <a:off x="548640" y="3931920"/>
-            <a:ext cx="2286000" cy="2286000"/>
+            <a:off x="548640" y="4434840"/>
+            <a:ext cx="2286000" cy="1783080"/>
           </a:xfrm>
           <a:prstGeom prst="roundRect">
             <a:avLst>
@@ -9613,7 +10384,7 @@
         </p:nvSpPr>
         <p:spPr>
           <a:xfrm>
-            <a:off x="777240" y="4133087"/>
+            <a:off x="777240" y="4599432"/>
             <a:ext cx="457200" cy="457200"/>
           </a:xfrm>
           <a:prstGeom prst="ellipse">
@@ -9666,8 +10437,8 @@
         </p:nvSpPr>
         <p:spPr>
           <a:xfrm>
-            <a:off x="777240" y="4727448"/>
-            <a:ext cx="1874519" cy="1417320"/>
+            <a:off x="777240" y="5166360"/>
+            <a:ext cx="1874519" cy="1005840"/>
           </a:xfrm>
           <a:prstGeom prst="rect">
             <a:avLst/>
@@ -9716,8 +10487,8 @@
         </p:nvSpPr>
         <p:spPr>
           <a:xfrm>
-            <a:off x="2999232" y="3931920"/>
-            <a:ext cx="2286000" cy="2286000"/>
+            <a:off x="2999232" y="4434840"/>
+            <a:ext cx="2286000" cy="1783080"/>
           </a:xfrm>
           <a:prstGeom prst="roundRect">
             <a:avLst>
@@ -9769,7 +10540,7 @@
         </p:nvSpPr>
         <p:spPr>
           <a:xfrm>
-            <a:off x="3227832" y="4133087"/>
+            <a:off x="3227832" y="4599432"/>
             <a:ext cx="457200" cy="457200"/>
           </a:xfrm>
           <a:prstGeom prst="ellipse">
@@ -9822,8 +10593,8 @@
         </p:nvSpPr>
         <p:spPr>
           <a:xfrm>
-            <a:off x="3227832" y="4727448"/>
-            <a:ext cx="1874519" cy="1417320"/>
+            <a:off x="3227832" y="5166360"/>
+            <a:ext cx="1874519" cy="1005840"/>
           </a:xfrm>
           <a:prstGeom prst="rect">
             <a:avLst/>
@@ -9872,8 +10643,8 @@
         </p:nvSpPr>
         <p:spPr>
           <a:xfrm>
-            <a:off x="5449824" y="3931920"/>
-            <a:ext cx="2286000" cy="2286000"/>
+            <a:off x="5449824" y="4434840"/>
+            <a:ext cx="2286000" cy="1783080"/>
           </a:xfrm>
           <a:prstGeom prst="roundRect">
             <a:avLst>
@@ -9925,7 +10696,7 @@
         </p:nvSpPr>
         <p:spPr>
           <a:xfrm>
-            <a:off x="5678424" y="4133087"/>
+            <a:off x="5678424" y="4599432"/>
             <a:ext cx="457200" cy="457200"/>
           </a:xfrm>
           <a:prstGeom prst="ellipse">
@@ -9978,8 +10749,8 @@
         </p:nvSpPr>
         <p:spPr>
           <a:xfrm>
-            <a:off x="5678424" y="4727448"/>
-            <a:ext cx="1874519" cy="1417320"/>
+            <a:off x="5678424" y="5166360"/>
+            <a:ext cx="1874519" cy="1005840"/>
           </a:xfrm>
           <a:prstGeom prst="rect">
             <a:avLst/>
@@ -10016,6 +10787,369 @@
                 <a:latin typeface="Calibri"/>
               </a:rPr>
               <a:t>No modo 150 °C, a potência que chega à panela é uma média.</a:t>
+            </a:r>
+          </a:p>
+        </p:txBody>
+      </p:sp>
+      <p:sp>
+        <p:nvSpPr>
+          <p:cNvPr id="37" name="Texto medido 1"/>
+          <p:cNvSpPr txBox="1"/>
+          <p:nvPr/>
+        </p:nvSpPr>
+        <p:spPr>
+          <a:xfrm>
+            <a:off x="704088" y="2011680"/>
+            <a:ext cx="1417320" cy="548640"/>
+          </a:xfrm>
+          <a:prstGeom prst="rect">
+            <a:avLst/>
+          </a:prstGeom>
+          <a:noFill/>
+        </p:spPr>
+        <p:txBody>
+          <a:bodyPr wrap="square" lIns="0" rIns="0" tIns="0" bIns="0" anchor="t">
+            <a:spAutoFit/>
+          </a:bodyPr>
+          <a:lstStyle/>
+          <a:p>
+            <a:r>
+              <a:rPr sz="1800" b="1">
+                <a:solidFill>
+                  <a:srgbClr val="1C7ED6"/>
+                </a:solidFill>
+                <a:latin typeface="Calibri"/>
+              </a:rPr>
+              <a:t>8,0 cm</a:t>
+            </a:r>
+          </a:p>
+          <a:p>
+            <a:r>
+              <a:rPr sz="1100" b="0">
+                <a:solidFill>
+                  <a:srgbClr val="5B6170"/>
+                </a:solidFill>
+                <a:latin typeface="Calibri"/>
+              </a:rPr>
+              <a:t>raio (r)</a:t>
+            </a:r>
+          </a:p>
+        </p:txBody>
+      </p:sp>
+      <p:sp>
+        <p:nvSpPr>
+          <p:cNvPr id="39" name="Texto medido 2"/>
+          <p:cNvSpPr txBox="1"/>
+          <p:nvPr/>
+        </p:nvSpPr>
+        <p:spPr>
+          <a:xfrm>
+            <a:off x="2404872" y="2011680"/>
+            <a:ext cx="1417320" cy="548640"/>
+          </a:xfrm>
+          <a:prstGeom prst="rect">
+            <a:avLst/>
+          </a:prstGeom>
+          <a:noFill/>
+        </p:spPr>
+        <p:txBody>
+          <a:bodyPr wrap="square" lIns="0" rIns="0" tIns="0" bIns="0" anchor="t">
+            <a:spAutoFit/>
+          </a:bodyPr>
+          <a:lstStyle/>
+          <a:p>
+            <a:r>
+              <a:rPr sz="1800" b="1">
+                <a:solidFill>
+                  <a:srgbClr val="1C7ED6"/>
+                </a:solidFill>
+                <a:latin typeface="Calibri"/>
+              </a:rPr>
+              <a:t>81,2 mm</a:t>
+            </a:r>
+          </a:p>
+          <a:p>
+            <a:r>
+              <a:rPr sz="1100" b="0">
+                <a:solidFill>
+                  <a:srgbClr val="5B6170"/>
+                </a:solidFill>
+                <a:latin typeface="Calibri"/>
+              </a:rPr>
+              <a:t>altura (H)</a:t>
+            </a:r>
+          </a:p>
+        </p:txBody>
+      </p:sp>
+      <p:sp>
+        <p:nvSpPr>
+          <p:cNvPr id="41" name="Texto medido 3"/>
+          <p:cNvSpPr txBox="1"/>
+          <p:nvPr/>
+        </p:nvSpPr>
+        <p:spPr>
+          <a:xfrm>
+            <a:off x="704088" y="2816352"/>
+            <a:ext cx="1417320" cy="548640"/>
+          </a:xfrm>
+          <a:prstGeom prst="rect">
+            <a:avLst/>
+          </a:prstGeom>
+          <a:noFill/>
+        </p:spPr>
+        <p:txBody>
+          <a:bodyPr wrap="square" lIns="0" rIns="0" tIns="0" bIns="0" anchor="t">
+            <a:spAutoFit/>
+          </a:bodyPr>
+          <a:lstStyle/>
+          <a:p>
+            <a:r>
+              <a:rPr sz="1800" b="1">
+                <a:solidFill>
+                  <a:srgbClr val="1C7ED6"/>
+                </a:solidFill>
+                <a:latin typeface="Calibri"/>
+              </a:rPr>
+              <a:t>0,54 mm</a:t>
+            </a:r>
+          </a:p>
+          <a:p>
+            <a:r>
+              <a:rPr sz="1100" b="0">
+                <a:solidFill>
+                  <a:srgbClr val="5B6170"/>
+                </a:solidFill>
+                <a:latin typeface="Calibri"/>
+              </a:rPr>
+              <a:t>espessura (d)</a:t>
+            </a:r>
+          </a:p>
+        </p:txBody>
+      </p:sp>
+      <p:sp>
+        <p:nvSpPr>
+          <p:cNvPr id="43" name="Texto medido 4"/>
+          <p:cNvSpPr txBox="1"/>
+          <p:nvPr/>
+        </p:nvSpPr>
+        <p:spPr>
+          <a:xfrm>
+            <a:off x="2404872" y="2816352"/>
+            <a:ext cx="1417320" cy="548640"/>
+          </a:xfrm>
+          <a:prstGeom prst="rect">
+            <a:avLst/>
+          </a:prstGeom>
+          <a:noFill/>
+        </p:spPr>
+        <p:txBody>
+          <a:bodyPr wrap="square" lIns="0" rIns="0" tIns="0" bIns="0" anchor="t">
+            <a:spAutoFit/>
+          </a:bodyPr>
+          <a:lstStyle/>
+          <a:p>
+            <a:r>
+              <a:rPr sz="1800" b="1">
+                <a:solidFill>
+                  <a:srgbClr val="1C7ED6"/>
+                </a:solidFill>
+                <a:latin typeface="Calibri"/>
+              </a:rPr>
+              <a:t>1,123 kg</a:t>
+            </a:r>
+          </a:p>
+          <a:p>
+            <a:r>
+              <a:rPr sz="1100" b="0">
+                <a:solidFill>
+                  <a:srgbClr val="5B6170"/>
+                </a:solidFill>
+                <a:latin typeface="Calibri"/>
+              </a:rPr>
+              <a:t>massa de água (ma)</a:t>
+            </a:r>
+          </a:p>
+        </p:txBody>
+      </p:sp>
+      <p:sp>
+        <p:nvSpPr>
+          <p:cNvPr id="45" name="Texto medido 5"/>
+          <p:cNvSpPr txBox="1"/>
+          <p:nvPr/>
+        </p:nvSpPr>
+        <p:spPr>
+          <a:xfrm>
+            <a:off x="704088" y="3621024"/>
+            <a:ext cx="1417320" cy="548640"/>
+          </a:xfrm>
+          <a:prstGeom prst="rect">
+            <a:avLst/>
+          </a:prstGeom>
+          <a:noFill/>
+        </p:spPr>
+        <p:txBody>
+          <a:bodyPr wrap="square" lIns="0" rIns="0" tIns="0" bIns="0" anchor="t">
+            <a:spAutoFit/>
+          </a:bodyPr>
+          <a:lstStyle/>
+          <a:p>
+            <a:r>
+              <a:rPr sz="1800" b="1">
+                <a:solidFill>
+                  <a:srgbClr val="1C7ED6"/>
+                </a:solidFill>
+                <a:latin typeface="Calibri"/>
+              </a:rPr>
+              <a:t>18,9 °C</a:t>
+            </a:r>
+          </a:p>
+          <a:p>
+            <a:r>
+              <a:rPr sz="1100" b="0">
+                <a:solidFill>
+                  <a:srgbClr val="5B6170"/>
+                </a:solidFill>
+                <a:latin typeface="Calibri"/>
+              </a:rPr>
+              <a:t>ambiente (Tamb)</a:t>
+            </a:r>
+          </a:p>
+        </p:txBody>
+      </p:sp>
+      <p:sp>
+        <p:nvSpPr>
+          <p:cNvPr id="47" name="Texto medido 6"/>
+          <p:cNvSpPr txBox="1"/>
+          <p:nvPr/>
+        </p:nvSpPr>
+        <p:spPr>
+          <a:xfrm>
+            <a:off x="2404872" y="3621024"/>
+            <a:ext cx="1417320" cy="548640"/>
+          </a:xfrm>
+          <a:prstGeom prst="rect">
+            <a:avLst/>
+          </a:prstGeom>
+          <a:noFill/>
+        </p:spPr>
+        <p:txBody>
+          <a:bodyPr wrap="square" lIns="0" rIns="0" tIns="0" bIns="0" anchor="t">
+            <a:spAutoFit/>
+          </a:bodyPr>
+          <a:lstStyle/>
+          <a:p>
+            <a:r>
+              <a:rPr sz="1800" b="1">
+                <a:solidFill>
+                  <a:srgbClr val="1C7ED6"/>
+                </a:solidFill>
+                <a:latin typeface="Calibri"/>
+              </a:rPr>
+              <a:t>20,7 °C</a:t>
+            </a:r>
+          </a:p>
+          <a:p>
+            <a:r>
+              <a:rPr sz="1100" b="0">
+                <a:solidFill>
+                  <a:srgbClr val="5B6170"/>
+                </a:solidFill>
+                <a:latin typeface="Calibri"/>
+              </a:rPr>
+              <a:t>inicial (Tp0 = Ta0)</a:t>
+            </a:r>
+          </a:p>
+        </p:txBody>
+      </p:sp>
+      <p:sp>
+        <p:nvSpPr>
+          <p:cNvPr id="50" name="Texto literatura"/>
+          <p:cNvSpPr txBox="1"/>
+          <p:nvPr/>
+        </p:nvSpPr>
+        <p:spPr>
+          <a:xfrm>
+            <a:off x="4709160" y="3401568"/>
+            <a:ext cx="2926080" cy="822960"/>
+          </a:xfrm>
+          <a:prstGeom prst="rect">
+            <a:avLst/>
+          </a:prstGeom>
+          <a:noFill/>
+        </p:spPr>
+        <p:txBody>
+          <a:bodyPr wrap="square" lIns="0" rIns="0" tIns="0" bIns="0" anchor="t">
+            <a:spAutoFit/>
+          </a:bodyPr>
+          <a:lstStyle/>
+          <a:p>
+            <a:r>
+              <a:rPr sz="1400" b="1">
+                <a:solidFill>
+                  <a:srgbClr val="5B6170"/>
+                </a:solidFill>
+                <a:latin typeface="Calibri"/>
+              </a:rPr>
+              <a:t>500 J/(kg·K)</a:t>
+            </a:r>
+            <a:r>
+              <a:rPr sz="1200" b="0">
+                <a:solidFill>
+                  <a:srgbClr val="5B6170"/>
+                </a:solidFill>
+                <a:latin typeface="Calibri"/>
+              </a:rPr>
+              <a:t>   aço (cp)</a:t>
+            </a:r>
+          </a:p>
+          <a:p>
+            <a:pPr>
+              <a:spcBef>
+                <a:spcPts val="200"/>
+              </a:spcBef>
+            </a:pPr>
+            <a:r>
+              <a:rPr sz="1400" b="1">
+                <a:solidFill>
+                  <a:srgbClr val="5B6170"/>
+                </a:solidFill>
+                <a:latin typeface="Calibri"/>
+              </a:rPr>
+              <a:t>4186 J/(kg·K)</a:t>
+            </a:r>
+            <a:r>
+              <a:rPr sz="1200" b="0">
+                <a:solidFill>
+                  <a:srgbClr val="5B6170"/>
+                </a:solidFill>
+                <a:latin typeface="Calibri"/>
+              </a:rPr>
+              <a:t>   água (ca)</a:t>
+            </a:r>
+          </a:p>
+          <a:p>
+            <a:pPr>
+              <a:spcBef>
+                <a:spcPts val="200"/>
+              </a:spcBef>
+            </a:pPr>
+            <a:r>
+              <a:rPr sz="1400" b="1">
+                <a:solidFill>
+                  <a:srgbClr val="5B6170"/>
+                </a:solidFill>
+                <a:latin typeface="Calibri"/>
+              </a:rPr>
+              <a:t>16 W/(m·K)</a:t>
+            </a:r>
+            <a:r>
+              <a:rPr sz="1200" b="0">
+                <a:solidFill>
+                  <a:srgbClr val="5B6170"/>
+                </a:solidFill>
+                <a:latin typeface="Calibri"/>
+              </a:rPr>
+              <a:t>   aço inox (Kaco)</a:t>
             </a:r>
           </a:p>
         </p:txBody>
@@ -10143,14 +11277,14 @@
       </p:graphicFrame>
       <p:sp>
         <p:nvSpPr>
-          <p:cNvPr id="5" name="Cartão do erro"/>
+          <p:cNvPr id="8" name="Cartão das diferenças"/>
           <p:cNvSpPr/>
           <p:nvPr/>
         </p:nvSpPr>
         <p:spPr>
           <a:xfrm>
-            <a:off x="8183879" y="2743200"/>
-            <a:ext cx="3474720" cy="2194560"/>
+            <a:off x="8183879" y="3520440"/>
+            <a:ext cx="3474720" cy="2880360"/>
           </a:xfrm>
           <a:prstGeom prst="roundRect">
             <a:avLst>
@@ -10196,13 +11330,66 @@
       </p:sp>
       <p:sp>
         <p:nvSpPr>
+          <p:cNvPr id="5" name="Cartão do erro"/>
+          <p:cNvSpPr/>
+          <p:nvPr/>
+        </p:nvSpPr>
+        <p:spPr>
+          <a:xfrm>
+            <a:off x="8183879" y="1554480"/>
+            <a:ext cx="3474720" cy="1783080"/>
+          </a:xfrm>
+          <a:prstGeom prst="roundRect">
+            <a:avLst>
+              <a:gd name="adj" fmla="val 8000"/>
+            </a:avLst>
+          </a:prstGeom>
+          <a:solidFill>
+            <a:srgbClr val="F6F7F9"/>
+          </a:solidFill>
+          <a:ln>
+            <a:noFill/>
+          </a:ln>
+          <a:effectLst>
+            <a:outerShdw blurRad="190500" dist="38100" dir="5400000" algn="t" rotWithShape="0">
+              <a:srgbClr val="000000">
+                <a:alpha val="14000"/>
+              </a:srgbClr>
+            </a:outerShdw>
+          </a:effectLst>
+        </p:spPr>
+        <p:style>
+          <a:lnRef idx="1">
+            <a:schemeClr val="accent1"/>
+          </a:lnRef>
+          <a:fillRef idx="3">
+            <a:schemeClr val="accent1"/>
+          </a:fillRef>
+          <a:effectRef idx="2">
+            <a:schemeClr val="accent1"/>
+          </a:effectRef>
+          <a:fontRef idx="minor">
+            <a:schemeClr val="lt1"/>
+          </a:fontRef>
+        </p:style>
+        <p:txBody>
+          <a:bodyPr rtlCol="0" anchor="ctr"/>
+          <a:lstStyle/>
+          <a:p>
+            <a:pPr algn="ctr"/>
+            <a:endParaRPr/>
+          </a:p>
+        </p:txBody>
+      </p:sp>
+      <p:sp>
+        <p:nvSpPr>
           <p:cNvPr id="6" name="TextBox 5"/>
           <p:cNvSpPr txBox="1"/>
           <p:nvPr/>
         </p:nvSpPr>
         <p:spPr>
           <a:xfrm>
-            <a:off x="8458200" y="2926080"/>
+            <a:off x="8458200" y="1691640"/>
             <a:ext cx="3017520" cy="914400"/>
           </a:xfrm>
           <a:prstGeom prst="rect">
@@ -10237,7 +11424,7 @@
         </p:nvSpPr>
         <p:spPr>
           <a:xfrm>
-            <a:off x="8458200" y="3950208"/>
+            <a:off x="8458200" y="2715768"/>
             <a:ext cx="3017520" cy="215444"/>
           </a:xfrm>
           <a:prstGeom prst="rect">
@@ -10285,6 +11472,115 @@
               </a:solidFill>
               <a:latin typeface="Calibri"/>
             </a:endParaRPr>
+          </a:p>
+        </p:txBody>
+      </p:sp>
+      <p:sp>
+        <p:nvSpPr>
+          <p:cNvPr id="9" name="Texto das diferenças"/>
+          <p:cNvSpPr txBox="1"/>
+          <p:nvPr/>
+        </p:nvSpPr>
+        <p:spPr>
+          <a:xfrm>
+            <a:off x="8458200" y="3703320"/>
+            <a:ext cx="3017520" cy="2606040"/>
+          </a:xfrm>
+          <a:prstGeom prst="rect">
+            <a:avLst/>
+          </a:prstGeom>
+          <a:noFill/>
+        </p:spPr>
+        <p:txBody>
+          <a:bodyPr wrap="square" lIns="0" rIns="0" tIns="0" bIns="0" anchor="t">
+            <a:spAutoFit/>
+          </a:bodyPr>
+          <a:lstStyle/>
+          <a:p>
+            <a:r>
+              <a:rPr sz="1500" b="1">
+                <a:solidFill>
+                  <a:srgbClr val="14171F"/>
+                </a:solidFill>
+                <a:latin typeface="Calibri"/>
+              </a:rPr>
+              <a:t>Por que o modelo difere?</a:t>
+            </a:r>
+          </a:p>
+          <a:p>
+            <a:pPr>
+              <a:spcBef>
+                <a:spcPts val="600"/>
+              </a:spcBef>
+            </a:pPr>
+            <a:r>
+              <a:rPr sz="1250" b="1">
+                <a:solidFill>
+                  <a:srgbClr val="14171F"/>
+                </a:solidFill>
+                <a:latin typeface="Calibri"/>
+              </a:rPr>
+              <a:t>Tempo corrigido: </a:t>
+            </a:r>
+            <a:r>
+              <a:rPr sz="1250" b="0">
+                <a:solidFill>
+                  <a:srgbClr val="5B6170"/>
+                </a:solidFill>
+                <a:latin typeface="Calibri"/>
+              </a:rPr>
+              <a:t>o cronômetro começou 7 min antes do aquecimento (2 primeiros pontos descartados).</a:t>
+            </a:r>
+          </a:p>
+          <a:p>
+            <a:pPr>
+              <a:spcBef>
+                <a:spcPts val="600"/>
+              </a:spcBef>
+            </a:pPr>
+            <a:r>
+              <a:rPr sz="1250" b="1">
+                <a:solidFill>
+                  <a:srgbClr val="14171F"/>
+                </a:solidFill>
+                <a:latin typeface="Calibri"/>
+              </a:rPr>
+              <a:t>Até ~27 min o modelo fica acima </a:t>
+            </a:r>
+            <a:r>
+              <a:rPr sz="1250" b="0">
+                <a:solidFill>
+                  <a:srgbClr val="5B6170"/>
+                </a:solidFill>
+                <a:latin typeface="Calibri"/>
+              </a:rPr>
+              <a:t>(maior erro: 6,8 % aos 11 min); depois, um pouco abaixo.</a:t>
+            </a:r>
+          </a:p>
+          <a:p>
+            <a:pPr>
+              <a:spcBef>
+                <a:spcPts val="600"/>
+              </a:spcBef>
+            </a:pPr>
+            <a:r>
+              <a:rPr sz="1250" b="1">
+                <a:solidFill>
+                  <a:srgbClr val="14171F"/>
+                </a:solidFill>
+                <a:latin typeface="Calibri"/>
+              </a:rPr>
+              <a:t>Motivos: </a:t>
+            </a:r>
+            <a:r>
+              <a:rPr sz="1250" b="0">
+                <a:solidFill>
+                  <a:srgbClr val="5B6170"/>
+                </a:solidFill>
+                <a:latin typeface="Calibri"/>
+              </a:rPr>
+              <a:t>o fogão liga e desliga (usamos a média de 200 W) e o h do ar é constante, mas a evaporação aumenta com a temperatura.</a:t>
+            </a:r>
           </a:p>
         </p:txBody>
       </p:sp>
@@ -11563,7 +12859,7 @@
                 </a:solidFill>
                 <a:latin typeface="Calibri"/>
               </a:rPr>
-              <a:t>a partir daí, mais potência quase não reduz o tempo</a:t>
+              <a:t>acima disso o ganho é pequeno: até 3500 W o tempo só cai de 4,4 para 2,4 min</a:t>
             </a:r>
           </a:p>
         </p:txBody>

</xml_diff>